<commit_message>
Make AutoVLA attack slides editable
</commit_message>
<xml_diff>
--- a/report/autovla_blackbox_attack_2slides.pptx
+++ b/report/autovla_blackbox_attack_2slides.pptx
@@ -6,7 +6,7 @@
   </p:sldMasterIdLst>
   <p:sldIdLst>
     <p:sldId id="256" r:id="rId7"/>
-    <p:sldId id="257" r:id="rId9"/>
+    <p:sldId id="257" r:id="rId8"/>
   </p:sldIdLst>
   <p:sldSz cx="12191999" cy="6858000" type="screen4x3"/>
   <p:notesSz cx="6858000" cy="9144000"/>
@@ -106,496 +106,6 @@
     </a:lvl9pPr>
   </p:defaultTextStyle>
 </p:presentation>
-</file>
-
-<file path=ppt/notesMasters/notesMaster1.xml><?xml version="1.0" encoding="utf-8"?>
-<p:notesMaster xmlns:a="http://schemas.openxmlformats.org/drawingml/2006/main" xmlns:p="http://schemas.openxmlformats.org/presentationml/2006/main" xmlns:r="http://schemas.openxmlformats.org/officeDocument/2006/relationships">
-  <p:cSld>
-    <p:bg>
-      <p:bgRef idx="1001">
-        <a:schemeClr val="bg1"/>
-      </p:bgRef>
-    </p:bg>
-    <p:spTree>
-      <p:nvGrpSpPr>
-        <p:cNvPr id="1" name=""/>
-        <p:cNvGrpSpPr/>
-        <p:nvPr/>
-      </p:nvGrpSpPr>
-      <p:grpSpPr>
-        <a:xfrm>
-          <a:off x="0" y="0"/>
-          <a:ext cx="0" cy="0"/>
-          <a:chOff x="0" y="0"/>
-          <a:chExt cx="0" cy="0"/>
-        </a:xfrm>
-      </p:grpSpPr>
-      <p:sp>
-        <p:nvSpPr>
-          <p:cNvPr id="2" name="Header Placeholder 1"/>
-          <p:cNvSpPr>
-            <a:spLocks noGrp="1"/>
-          </p:cNvSpPr>
-          <p:nvPr>
-            <p:ph type="hdr" sz="quarter"/>
-          </p:nvPr>
-        </p:nvSpPr>
-        <p:spPr>
-          <a:xfrm>
-            <a:off x="0" y="0"/>
-            <a:ext cx="2971800" cy="457200"/>
-          </a:xfrm>
-          <a:prstGeom prst="rect">
-            <a:avLst/>
-          </a:prstGeom>
-        </p:spPr>
-        <p:txBody>
-          <a:bodyPr vert="horz" lIns="91440" tIns="45720" rIns="91440" bIns="45720" rtlCol="0"/>
-          <a:lstStyle>
-            <a:lvl1pPr algn="l">
-              <a:defRPr sz="1200"/>
-            </a:lvl1pPr>
-          </a:lstStyle>
-          <a:p>
-            <a:endParaRPr lang="en-US"/>
-          </a:p>
-        </p:txBody>
-      </p:sp>
-      <p:sp>
-        <p:nvSpPr>
-          <p:cNvPr id="3" name="Date Placeholder 2"/>
-          <p:cNvSpPr>
-            <a:spLocks noGrp="1"/>
-          </p:cNvSpPr>
-          <p:nvPr>
-            <p:ph type="dt" idx="1"/>
-          </p:nvPr>
-        </p:nvSpPr>
-        <p:spPr>
-          <a:xfrm>
-            <a:off x="3884613" y="0"/>
-            <a:ext cx="2971800" cy="457200"/>
-          </a:xfrm>
-          <a:prstGeom prst="rect">
-            <a:avLst/>
-          </a:prstGeom>
-        </p:spPr>
-        <p:txBody>
-          <a:bodyPr vert="horz" lIns="91440" tIns="45720" rIns="91440" bIns="45720" rtlCol="0"/>
-          <a:lstStyle>
-            <a:lvl1pPr algn="r">
-              <a:defRPr sz="1200"/>
-            </a:lvl1pPr>
-          </a:lstStyle>
-          <a:p>
-            <a:fld id="{0F89C1C7-3DCD-1040-A9CF-14679D8B5DDD}" type="datetimeFigureOut">
-              <a:rPr lang="en-US" smtClean="0"/>
-              <a:t>10/17/16</a:t>
-            </a:fld>
-            <a:endParaRPr lang="en-US"/>
-          </a:p>
-        </p:txBody>
-      </p:sp>
-      <p:sp>
-        <p:nvSpPr>
-          <p:cNvPr id="4" name="Slide Image Placeholder 3"/>
-          <p:cNvSpPr>
-            <a:spLocks noGrp="1" noRot="1" noChangeAspect="1"/>
-          </p:cNvSpPr>
-          <p:nvPr>
-            <p:ph type="sldImg" idx="2"/>
-          </p:nvPr>
-        </p:nvSpPr>
-        <p:spPr>
-          <a:xfrm>
-            <a:off x="1143000" y="685800"/>
-            <a:ext cx="4572000" cy="3429000"/>
-          </a:xfrm>
-          <a:prstGeom prst="rect">
-            <a:avLst/>
-          </a:prstGeom>
-          <a:noFill/>
-          <a:ln w="12700">
-            <a:solidFill>
-              <a:prstClr val="black"/>
-            </a:solidFill>
-          </a:ln>
-        </p:spPr>
-        <p:txBody>
-          <a:bodyPr vert="horz" lIns="91440" tIns="45720" rIns="91440" bIns="45720" rtlCol="0" anchor="ctr"/>
-          <a:lstStyle/>
-          <a:p>
-            <a:endParaRPr lang="en-US"/>
-          </a:p>
-        </p:txBody>
-      </p:sp>
-      <p:sp>
-        <p:nvSpPr>
-          <p:cNvPr id="5" name="Notes Placeholder 4"/>
-          <p:cNvSpPr>
-            <a:spLocks noGrp="1"/>
-          </p:cNvSpPr>
-          <p:nvPr>
-            <p:ph type="body" sz="quarter" idx="3"/>
-          </p:nvPr>
-        </p:nvSpPr>
-        <p:spPr>
-          <a:xfrm>
-            <a:off x="685800" y="4343400"/>
-            <a:ext cx="5486400" cy="4114800"/>
-          </a:xfrm>
-          <a:prstGeom prst="rect">
-            <a:avLst/>
-          </a:prstGeom>
-        </p:spPr>
-        <p:txBody>
-          <a:bodyPr vert="horz" lIns="91440" tIns="45720" rIns="91440" bIns="45720" rtlCol="0"/>
-          <a:lstStyle/>
-          <a:p>
-            <a:pPr lvl="0"/>
-            <a:r>
-              <a:rPr lang="en-US" smtClean="0"/>
-              <a:t>Click to edit Master text styles</a:t>
-            </a:r>
-          </a:p>
-          <a:p>
-            <a:pPr lvl="1"/>
-            <a:r>
-              <a:rPr lang="en-US" smtClean="0"/>
-              <a:t>Second level</a:t>
-            </a:r>
-          </a:p>
-          <a:p>
-            <a:pPr lvl="2"/>
-            <a:r>
-              <a:rPr lang="en-US" smtClean="0"/>
-              <a:t>Third level</a:t>
-            </a:r>
-          </a:p>
-          <a:p>
-            <a:pPr lvl="3"/>
-            <a:r>
-              <a:rPr lang="en-US" smtClean="0"/>
-              <a:t>Fourth level</a:t>
-            </a:r>
-          </a:p>
-          <a:p>
-            <a:pPr lvl="4"/>
-            <a:r>
-              <a:rPr lang="en-US" smtClean="0"/>
-              <a:t>Fifth level</a:t>
-            </a:r>
-            <a:endParaRPr lang="en-US"/>
-          </a:p>
-        </p:txBody>
-      </p:sp>
-      <p:sp>
-        <p:nvSpPr>
-          <p:cNvPr id="6" name="Footer Placeholder 5"/>
-          <p:cNvSpPr>
-            <a:spLocks noGrp="1"/>
-          </p:cNvSpPr>
-          <p:nvPr>
-            <p:ph type="ftr" sz="quarter" idx="4"/>
-          </p:nvPr>
-        </p:nvSpPr>
-        <p:spPr>
-          <a:xfrm>
-            <a:off x="0" y="8685213"/>
-            <a:ext cx="2971800" cy="457200"/>
-          </a:xfrm>
-          <a:prstGeom prst="rect">
-            <a:avLst/>
-          </a:prstGeom>
-        </p:spPr>
-        <p:txBody>
-          <a:bodyPr vert="horz" lIns="91440" tIns="45720" rIns="91440" bIns="45720" rtlCol="0" anchor="b"/>
-          <a:lstStyle>
-            <a:lvl1pPr algn="l">
-              <a:defRPr sz="1200"/>
-            </a:lvl1pPr>
-          </a:lstStyle>
-          <a:p>
-            <a:endParaRPr lang="en-US"/>
-          </a:p>
-        </p:txBody>
-      </p:sp>
-      <p:sp>
-        <p:nvSpPr>
-          <p:cNvPr id="7" name="Slide Number Placeholder 6"/>
-          <p:cNvSpPr>
-            <a:spLocks noGrp="1"/>
-          </p:cNvSpPr>
-          <p:nvPr>
-            <p:ph type="sldNum" sz="quarter" idx="5"/>
-          </p:nvPr>
-        </p:nvSpPr>
-        <p:spPr>
-          <a:xfrm>
-            <a:off x="3884613" y="8685213"/>
-            <a:ext cx="2971800" cy="457200"/>
-          </a:xfrm>
-          <a:prstGeom prst="rect">
-            <a:avLst/>
-          </a:prstGeom>
-        </p:spPr>
-        <p:txBody>
-          <a:bodyPr vert="horz" lIns="91440" tIns="45720" rIns="91440" bIns="45720" rtlCol="0" anchor="b"/>
-          <a:lstStyle>
-            <a:lvl1pPr algn="r">
-              <a:defRPr sz="1200"/>
-            </a:lvl1pPr>
-          </a:lstStyle>
-          <a:p>
-            <a:fld id="{BB5E49A5-4136-284D-997B-48E1D791AD67}" type="slidenum">
-              <a:rPr lang="en-US" smtClean="0"/>
-              <a:t>‹#›</a:t>
-            </a:fld>
-            <a:endParaRPr lang="en-US"/>
-          </a:p>
-        </p:txBody>
-      </p:sp>
-    </p:spTree>
-    <p:extLst>
-      <p:ext uri="{BB962C8B-B14F-4D97-AF65-F5344CB8AC3E}">
-        <p14:creationId xmlns:p14="http://schemas.microsoft.com/office/powerpoint/2010/main" val="2623252185"/>
-      </p:ext>
-    </p:extLst>
-  </p:cSld>
-  <p:clrMap bg1="lt1" tx1="dk1" bg2="lt2" tx2="dk2" accent1="accent1" accent2="accent2" accent3="accent3" accent4="accent4" accent5="accent5" accent6="accent6" hlink="hlink" folHlink="folHlink"/>
-  <p:notesStyle>
-    <a:lvl1pPr marL="0" algn="l" defTabSz="457200" rtl="0" eaLnBrk="1" latinLnBrk="0" hangingPunct="1">
-      <a:defRPr sz="1200" kern="1200">
-        <a:solidFill>
-          <a:schemeClr val="tx1"/>
-        </a:solidFill>
-        <a:latin typeface="+mn-lt"/>
-        <a:ea typeface="+mn-ea"/>
-        <a:cs typeface="+mn-cs"/>
-      </a:defRPr>
-    </a:lvl1pPr>
-    <a:lvl2pPr marL="457200" algn="l" defTabSz="457200" rtl="0" eaLnBrk="1" latinLnBrk="0" hangingPunct="1">
-      <a:defRPr sz="1200" kern="1200">
-        <a:solidFill>
-          <a:schemeClr val="tx1"/>
-        </a:solidFill>
-        <a:latin typeface="+mn-lt"/>
-        <a:ea typeface="+mn-ea"/>
-        <a:cs typeface="+mn-cs"/>
-      </a:defRPr>
-    </a:lvl2pPr>
-    <a:lvl3pPr marL="914400" algn="l" defTabSz="457200" rtl="0" eaLnBrk="1" latinLnBrk="0" hangingPunct="1">
-      <a:defRPr sz="1200" kern="1200">
-        <a:solidFill>
-          <a:schemeClr val="tx1"/>
-        </a:solidFill>
-        <a:latin typeface="+mn-lt"/>
-        <a:ea typeface="+mn-ea"/>
-        <a:cs typeface="+mn-cs"/>
-      </a:defRPr>
-    </a:lvl3pPr>
-    <a:lvl4pPr marL="1371600" algn="l" defTabSz="457200" rtl="0" eaLnBrk="1" latinLnBrk="0" hangingPunct="1">
-      <a:defRPr sz="1200" kern="1200">
-        <a:solidFill>
-          <a:schemeClr val="tx1"/>
-        </a:solidFill>
-        <a:latin typeface="+mn-lt"/>
-        <a:ea typeface="+mn-ea"/>
-        <a:cs typeface="+mn-cs"/>
-      </a:defRPr>
-    </a:lvl4pPr>
-    <a:lvl5pPr marL="1828800" algn="l" defTabSz="457200" rtl="0" eaLnBrk="1" latinLnBrk="0" hangingPunct="1">
-      <a:defRPr sz="1200" kern="1200">
-        <a:solidFill>
-          <a:schemeClr val="tx1"/>
-        </a:solidFill>
-        <a:latin typeface="+mn-lt"/>
-        <a:ea typeface="+mn-ea"/>
-        <a:cs typeface="+mn-cs"/>
-      </a:defRPr>
-    </a:lvl5pPr>
-    <a:lvl6pPr marL="2286000" algn="l" defTabSz="457200" rtl="0" eaLnBrk="1" latinLnBrk="0" hangingPunct="1">
-      <a:defRPr sz="1200" kern="1200">
-        <a:solidFill>
-          <a:schemeClr val="tx1"/>
-        </a:solidFill>
-        <a:latin typeface="+mn-lt"/>
-        <a:ea typeface="+mn-ea"/>
-        <a:cs typeface="+mn-cs"/>
-      </a:defRPr>
-    </a:lvl6pPr>
-    <a:lvl7pPr marL="2743200" algn="l" defTabSz="457200" rtl="0" eaLnBrk="1" latinLnBrk="0" hangingPunct="1">
-      <a:defRPr sz="1200" kern="1200">
-        <a:solidFill>
-          <a:schemeClr val="tx1"/>
-        </a:solidFill>
-        <a:latin typeface="+mn-lt"/>
-        <a:ea typeface="+mn-ea"/>
-        <a:cs typeface="+mn-cs"/>
-      </a:defRPr>
-    </a:lvl7pPr>
-    <a:lvl8pPr marL="3200400" algn="l" defTabSz="457200" rtl="0" eaLnBrk="1" latinLnBrk="0" hangingPunct="1">
-      <a:defRPr sz="1200" kern="1200">
-        <a:solidFill>
-          <a:schemeClr val="tx1"/>
-        </a:solidFill>
-        <a:latin typeface="+mn-lt"/>
-        <a:ea typeface="+mn-ea"/>
-        <a:cs typeface="+mn-cs"/>
-      </a:defRPr>
-    </a:lvl8pPr>
-    <a:lvl9pPr marL="3657600" algn="l" defTabSz="457200" rtl="0" eaLnBrk="1" latinLnBrk="0" hangingPunct="1">
-      <a:defRPr sz="1200" kern="1200">
-        <a:solidFill>
-          <a:schemeClr val="tx1"/>
-        </a:solidFill>
-        <a:latin typeface="+mn-lt"/>
-        <a:ea typeface="+mn-ea"/>
-        <a:cs typeface="+mn-cs"/>
-      </a:defRPr>
-    </a:lvl9pPr>
-  </p:notesStyle>
-</p:notesMaster>
-</file>
-
-<file path=ppt/notesSlides/notesSlide1.xml><?xml version="1.0" encoding="utf-8"?>
-<p:notes xmlns:a="http://schemas.openxmlformats.org/drawingml/2006/main" xmlns:p="http://schemas.openxmlformats.org/presentationml/2006/main" xmlns:r="http://schemas.openxmlformats.org/officeDocument/2006/relationships">
-  <p:cSld>
-    <p:spTree>
-      <p:nvGrpSpPr>
-        <p:cNvPr id="1" name=""/>
-        <p:cNvGrpSpPr/>
-        <p:nvPr/>
-      </p:nvGrpSpPr>
-      <p:grpSpPr>
-        <a:xfrm>
-          <a:off x="0" y="0"/>
-          <a:ext cx="0" cy="0"/>
-          <a:chOff x="0" y="0"/>
-          <a:chExt cx="0" cy="0"/>
-        </a:xfrm>
-      </p:grpSpPr>
-      <p:sp>
-        <p:nvSpPr>
-          <p:cNvPr id="2" name="Slide Image Placeholder 1"/>
-          <p:cNvSpPr>
-            <a:spLocks noGrp="1"/>
-          </p:cNvSpPr>
-          <p:nvPr>
-            <p:ph type="sldImg" idx="2"/>
-          </p:nvPr>
-        </p:nvSpPr>
-        <p:spPr/>
-      </p:sp>
-      <p:sp>
-        <p:nvSpPr>
-          <p:cNvPr id="3" name="Notes Placeholder 2"/>
-          <p:cNvSpPr>
-            <a:spLocks noGrp="1"/>
-          </p:cNvSpPr>
-          <p:nvPr>
-            <p:ph type="body" idx="3" sz="quarter"/>
-          </p:nvPr>
-        </p:nvSpPr>
-        <p:spPr/>
-        <p:txBody>
-          <a:bodyPr/>
-          <a:lstStyle/>
-          <a:p>
-            <a:r>
-              <a:t>Slide 1 notes: concise summary of AutoVLA black-box patch attack method and results.</a:t>
-            </a:r>
-          </a:p>
-        </p:txBody>
-      </p:sp>
-      <p:sp>
-        <p:nvSpPr>
-          <p:cNvPr id="4" name="Slide Number Placeholder 3"/>
-          <p:cNvSpPr>
-            <a:spLocks noGrp="1"/>
-          </p:cNvSpPr>
-          <p:nvPr>
-            <p:ph type="sldNum" idx="5" sz="quarter"/>
-          </p:nvPr>
-        </p:nvSpPr>
-        <p:spPr/>
-      </p:sp>
-    </p:spTree>
-  </p:cSld>
-  <p:clrMapOvr>
-    <a:masterClrMapping/>
-  </p:clrMapOvr>
-</p:notes>
-</file>
-
-<file path=ppt/notesSlides/notesSlide2.xml><?xml version="1.0" encoding="utf-8"?>
-<p:notes xmlns:a="http://schemas.openxmlformats.org/drawingml/2006/main" xmlns:p="http://schemas.openxmlformats.org/presentationml/2006/main" xmlns:r="http://schemas.openxmlformats.org/officeDocument/2006/relationships">
-  <p:cSld>
-    <p:spTree>
-      <p:nvGrpSpPr>
-        <p:cNvPr id="1" name=""/>
-        <p:cNvGrpSpPr/>
-        <p:nvPr/>
-      </p:nvGrpSpPr>
-      <p:grpSpPr>
-        <a:xfrm>
-          <a:off x="0" y="0"/>
-          <a:ext cx="0" cy="0"/>
-          <a:chOff x="0" y="0"/>
-          <a:chExt cx="0" cy="0"/>
-        </a:xfrm>
-      </p:grpSpPr>
-      <p:sp>
-        <p:nvSpPr>
-          <p:cNvPr id="2" name="Slide Image Placeholder 1"/>
-          <p:cNvSpPr>
-            <a:spLocks noGrp="1"/>
-          </p:cNvSpPr>
-          <p:nvPr>
-            <p:ph type="sldImg" idx="2"/>
-          </p:nvPr>
-        </p:nvSpPr>
-        <p:spPr/>
-      </p:sp>
-      <p:sp>
-        <p:nvSpPr>
-          <p:cNvPr id="3" name="Notes Placeholder 2"/>
-          <p:cNvSpPr>
-            <a:spLocks noGrp="1"/>
-          </p:cNvSpPr>
-          <p:nvPr>
-            <p:ph type="body" idx="3" sz="quarter"/>
-          </p:nvPr>
-        </p:nvSpPr>
-        <p:spPr/>
-        <p:txBody>
-          <a:bodyPr/>
-          <a:lstStyle/>
-          <a:p>
-            <a:r>
-              <a:t>Slide 2 notes: concise summary of AutoVLA black-box patch attack method and results.</a:t>
-            </a:r>
-          </a:p>
-        </p:txBody>
-      </p:sp>
-      <p:sp>
-        <p:nvSpPr>
-          <p:cNvPr id="4" name="Slide Number Placeholder 3"/>
-          <p:cNvSpPr>
-            <a:spLocks noGrp="1"/>
-          </p:cNvSpPr>
-          <p:nvPr>
-            <p:ph type="sldNum" idx="5" sz="quarter"/>
-          </p:nvPr>
-        </p:nvSpPr>
-        <p:spPr/>
-      </p:sp>
-    </p:spTree>
-  </p:cSld>
-  <p:clrMapOvr>
-    <a:masterClrMapping/>
-  </p:clrMapOvr>
-</p:notes>
 </file>
 
 <file path=ppt/slideLayouts/slideLayout1.xml><?xml version="1.0" encoding="utf-8"?>
@@ -3572,6 +3082,14 @@
 <file path=ppt/slides/slide1.xml><?xml version="1.0" encoding="utf-8"?>
 <p:sld xmlns:a="http://schemas.openxmlformats.org/drawingml/2006/main" xmlns:p="http://schemas.openxmlformats.org/presentationml/2006/main" xmlns:r="http://schemas.openxmlformats.org/officeDocument/2006/relationships">
   <p:cSld>
+    <p:bg>
+      <p:bgPr>
+        <a:solidFill>
+          <a:srgbClr val="F8FAFC"/>
+        </a:solidFill>
+        <a:effectLst/>
+      </p:bgPr>
+    </p:bg>
     <p:spTree>
       <p:nvGrpSpPr>
         <p:cNvPr id="1" name=""/>
@@ -3579,9 +3097,1427 @@
         <p:nvPr/>
       </p:nvGrpSpPr>
       <p:grpSpPr/>
+      <p:sp>
+        <p:nvSpPr>
+          <p:cNvPr id="2" name="TextBox 1"/>
+          <p:cNvSpPr txBox="1"/>
+          <p:nvPr/>
+        </p:nvSpPr>
+        <p:spPr>
+          <a:xfrm>
+            <a:off x="594360" y="384048"/>
+            <a:ext cx="8961120" cy="502920"/>
+          </a:xfrm>
+          <a:prstGeom prst="rect">
+            <a:avLst/>
+          </a:prstGeom>
+          <a:noFill/>
+        </p:spPr>
+        <p:txBody>
+          <a:bodyPr wrap="square" lIns="18288" rIns="18288" tIns="18288" bIns="18288">
+            <a:spAutoFit/>
+          </a:bodyPr>
+          <a:lstStyle/>
+          <a:p>
+            <a:r>
+              <a:rPr sz="3400" b="1">
+                <a:solidFill>
+                  <a:srgbClr val="0F172A"/>
+                </a:solidFill>
+                <a:latin typeface="Aptos"/>
+              </a:rPr>
+              <a:t>Black-box Patch Attack on AutoVLA</a:t>
+            </a:r>
+          </a:p>
+        </p:txBody>
+      </p:sp>
+      <p:sp>
+        <p:nvSpPr>
+          <p:cNvPr id="3" name="TextBox 2"/>
+          <p:cNvSpPr txBox="1"/>
+          <p:nvPr/>
+        </p:nvSpPr>
+        <p:spPr>
+          <a:xfrm>
+            <a:off x="612648" y="896112"/>
+            <a:ext cx="8412480" cy="320040"/>
+          </a:xfrm>
+          <a:prstGeom prst="rect">
+            <a:avLst/>
+          </a:prstGeom>
+          <a:noFill/>
+        </p:spPr>
+        <p:txBody>
+          <a:bodyPr wrap="square" lIns="18288" rIns="18288" tIns="18288" bIns="18288">
+            <a:spAutoFit/>
+          </a:bodyPr>
+          <a:lstStyle/>
+          <a:p>
+            <a:r>
+              <a:rPr sz="1900" b="0">
+                <a:solidFill>
+                  <a:srgbClr val="475569"/>
+                </a:solidFill>
+                <a:latin typeface="Aptos"/>
+              </a:rPr>
+              <a:t>Query-only trajectory manipulation on nuScenes front camera inputs</a:t>
+            </a:r>
+          </a:p>
+        </p:txBody>
+      </p:sp>
+      <p:sp>
+        <p:nvSpPr>
+          <p:cNvPr id="4" name="Rounded Rectangle 3"/>
+          <p:cNvSpPr/>
+          <p:nvPr/>
+        </p:nvSpPr>
+        <p:spPr>
+          <a:xfrm>
+            <a:off x="594360" y="1508760"/>
+            <a:ext cx="1783080" cy="1143000"/>
+          </a:xfrm>
+          <a:prstGeom prst="roundRect">
+            <a:avLst/>
+          </a:prstGeom>
+          <a:solidFill>
+            <a:srgbClr val="FFFFFF"/>
+          </a:solidFill>
+          <a:ln w="12700">
+            <a:solidFill>
+              <a:srgbClr val="CBD5E1"/>
+            </a:solidFill>
+          </a:ln>
+        </p:spPr>
+        <p:style>
+          <a:lnRef idx="1">
+            <a:schemeClr val="accent1"/>
+          </a:lnRef>
+          <a:fillRef idx="3">
+            <a:schemeClr val="accent1"/>
+          </a:fillRef>
+          <a:effectRef idx="2">
+            <a:schemeClr val="accent1"/>
+          </a:effectRef>
+          <a:fontRef idx="minor">
+            <a:schemeClr val="lt1"/>
+          </a:fontRef>
+        </p:style>
+        <p:txBody>
+          <a:bodyPr rtlCol="0" anchor="ctr"/>
+          <a:lstStyle/>
+          <a:p>
+            <a:pPr algn="ctr"/>
+          </a:p>
+        </p:txBody>
+      </p:sp>
+      <p:sp>
+        <p:nvSpPr>
+          <p:cNvPr id="5" name="Oval 4"/>
+          <p:cNvSpPr/>
+          <p:nvPr/>
+        </p:nvSpPr>
+        <p:spPr>
+          <a:xfrm>
+            <a:off x="740664" y="1673351"/>
+            <a:ext cx="347472" cy="347472"/>
+          </a:xfrm>
+          <a:prstGeom prst="ellipse">
+            <a:avLst/>
+          </a:prstGeom>
+          <a:solidFill>
+            <a:srgbClr val="2563EB"/>
+          </a:solidFill>
+          <a:ln>
+            <a:solidFill>
+              <a:srgbClr val="2563EB"/>
+            </a:solidFill>
+          </a:ln>
+        </p:spPr>
+        <p:style>
+          <a:lnRef idx="1">
+            <a:schemeClr val="accent1"/>
+          </a:lnRef>
+          <a:fillRef idx="3">
+            <a:schemeClr val="accent1"/>
+          </a:fillRef>
+          <a:effectRef idx="2">
+            <a:schemeClr val="accent1"/>
+          </a:effectRef>
+          <a:fontRef idx="minor">
+            <a:schemeClr val="lt1"/>
+          </a:fontRef>
+        </p:style>
+        <p:txBody>
+          <a:bodyPr rtlCol="0" anchor="ctr"/>
+          <a:lstStyle/>
+          <a:p>
+            <a:pPr algn="ctr"/>
+          </a:p>
+        </p:txBody>
+      </p:sp>
+      <p:sp>
+        <p:nvSpPr>
+          <p:cNvPr id="6" name="TextBox 5"/>
+          <p:cNvSpPr txBox="1"/>
+          <p:nvPr/>
+        </p:nvSpPr>
+        <p:spPr>
+          <a:xfrm>
+            <a:off x="850392" y="1723643"/>
+            <a:ext cx="182880" cy="164592"/>
+          </a:xfrm>
+          <a:prstGeom prst="rect">
+            <a:avLst/>
+          </a:prstGeom>
+          <a:noFill/>
+        </p:spPr>
+        <p:txBody>
+          <a:bodyPr wrap="square" lIns="18288" rIns="18288" tIns="18288" bIns="18288">
+            <a:spAutoFit/>
+          </a:bodyPr>
+          <a:lstStyle/>
+          <a:p>
+            <a:pPr algn="ctr"/>
+            <a:r>
+              <a:rPr sz="1700" b="1">
+                <a:solidFill>
+                  <a:srgbClr val="FFFFFF"/>
+                </a:solidFill>
+                <a:latin typeface="Aptos"/>
+              </a:rPr>
+              <a:t>1</a:t>
+            </a:r>
+          </a:p>
+        </p:txBody>
+      </p:sp>
+      <p:sp>
+        <p:nvSpPr>
+          <p:cNvPr id="7" name="TextBox 6"/>
+          <p:cNvSpPr txBox="1"/>
+          <p:nvPr/>
+        </p:nvSpPr>
+        <p:spPr>
+          <a:xfrm>
+            <a:off x="758952" y="2130552"/>
+            <a:ext cx="1417320" cy="219456"/>
+          </a:xfrm>
+          <a:prstGeom prst="rect">
+            <a:avLst/>
+          </a:prstGeom>
+          <a:noFill/>
+        </p:spPr>
+        <p:txBody>
+          <a:bodyPr wrap="square" lIns="18288" rIns="18288" tIns="18288" bIns="18288">
+            <a:spAutoFit/>
+          </a:bodyPr>
+          <a:lstStyle/>
+          <a:p>
+            <a:r>
+              <a:rPr sz="1600" b="1">
+                <a:solidFill>
+                  <a:srgbClr val="0F172A"/>
+                </a:solidFill>
+                <a:latin typeface="Aptos"/>
+              </a:rPr>
+              <a:t>Clean AutoVLA</a:t>
+            </a:r>
+          </a:p>
+        </p:txBody>
+      </p:sp>
+      <p:sp>
+        <p:nvSpPr>
+          <p:cNvPr id="8" name="TextBox 7"/>
+          <p:cNvSpPr txBox="1"/>
+          <p:nvPr/>
+        </p:nvSpPr>
+        <p:spPr>
+          <a:xfrm>
+            <a:off x="758952" y="2377439"/>
+            <a:ext cx="1417320" cy="256032"/>
+          </a:xfrm>
+          <a:prstGeom prst="rect">
+            <a:avLst/>
+          </a:prstGeom>
+          <a:noFill/>
+        </p:spPr>
+        <p:txBody>
+          <a:bodyPr wrap="square" lIns="18288" rIns="18288" tIns="18288" bIns="18288">
+            <a:spAutoFit/>
+          </a:bodyPr>
+          <a:lstStyle/>
+          <a:p>
+            <a:r>
+              <a:rPr sz="1300" b="0">
+                <a:solidFill>
+                  <a:srgbClr val="475569"/>
+                </a:solidFill>
+                <a:latin typeface="Aptos"/>
+              </a:rPr>
+              <a:t>decode clean trajectory</a:t>
+            </a:r>
+          </a:p>
+        </p:txBody>
+      </p:sp>
+      <p:cxnSp>
+        <p:nvCxnSpPr>
+          <p:cNvPr id="9" name="Connector 8"/>
+          <p:cNvCxnSpPr/>
+          <p:nvPr/>
+        </p:nvCxnSpPr>
+        <p:spPr>
+          <a:xfrm>
+            <a:off x="2404872" y="2075688"/>
+            <a:ext cx="310896" cy="0"/>
+          </a:xfrm>
+          <a:prstGeom prst="line">
+            <a:avLst/>
+          </a:prstGeom>
+          <a:ln w="27940">
+            <a:solidFill>
+              <a:srgbClr val="2563EB"/>
+            </a:solidFill>
+          </a:ln>
+        </p:spPr>
+        <p:style>
+          <a:lnRef idx="2">
+            <a:schemeClr val="accent1"/>
+          </a:lnRef>
+          <a:fillRef idx="0">
+            <a:schemeClr val="accent1"/>
+          </a:fillRef>
+          <a:effectRef idx="1">
+            <a:schemeClr val="accent1"/>
+          </a:effectRef>
+          <a:fontRef idx="minor">
+            <a:schemeClr val="tx1"/>
+          </a:fontRef>
+        </p:style>
+      </p:cxnSp>
+      <p:sp>
+        <p:nvSpPr>
+          <p:cNvPr id="10" name="Rounded Rectangle 9"/>
+          <p:cNvSpPr/>
+          <p:nvPr/>
+        </p:nvSpPr>
+        <p:spPr>
+          <a:xfrm>
+            <a:off x="2788920" y="1508760"/>
+            <a:ext cx="1783080" cy="1143000"/>
+          </a:xfrm>
+          <a:prstGeom prst="roundRect">
+            <a:avLst/>
+          </a:prstGeom>
+          <a:solidFill>
+            <a:srgbClr val="FFFFFF"/>
+          </a:solidFill>
+          <a:ln w="12700">
+            <a:solidFill>
+              <a:srgbClr val="CBD5E1"/>
+            </a:solidFill>
+          </a:ln>
+        </p:spPr>
+        <p:style>
+          <a:lnRef idx="1">
+            <a:schemeClr val="accent1"/>
+          </a:lnRef>
+          <a:fillRef idx="3">
+            <a:schemeClr val="accent1"/>
+          </a:fillRef>
+          <a:effectRef idx="2">
+            <a:schemeClr val="accent1"/>
+          </a:effectRef>
+          <a:fontRef idx="minor">
+            <a:schemeClr val="lt1"/>
+          </a:fontRef>
+        </p:style>
+        <p:txBody>
+          <a:bodyPr rtlCol="0" anchor="ctr"/>
+          <a:lstStyle/>
+          <a:p>
+            <a:pPr algn="ctr"/>
+          </a:p>
+        </p:txBody>
+      </p:sp>
+      <p:sp>
+        <p:nvSpPr>
+          <p:cNvPr id="11" name="Oval 10"/>
+          <p:cNvSpPr/>
+          <p:nvPr/>
+        </p:nvSpPr>
+        <p:spPr>
+          <a:xfrm>
+            <a:off x="2935224" y="1673351"/>
+            <a:ext cx="347472" cy="347472"/>
+          </a:xfrm>
+          <a:prstGeom prst="ellipse">
+            <a:avLst/>
+          </a:prstGeom>
+          <a:solidFill>
+            <a:srgbClr val="2563EB"/>
+          </a:solidFill>
+          <a:ln>
+            <a:solidFill>
+              <a:srgbClr val="2563EB"/>
+            </a:solidFill>
+          </a:ln>
+        </p:spPr>
+        <p:style>
+          <a:lnRef idx="1">
+            <a:schemeClr val="accent1"/>
+          </a:lnRef>
+          <a:fillRef idx="3">
+            <a:schemeClr val="accent1"/>
+          </a:fillRef>
+          <a:effectRef idx="2">
+            <a:schemeClr val="accent1"/>
+          </a:effectRef>
+          <a:fontRef idx="minor">
+            <a:schemeClr val="lt1"/>
+          </a:fontRef>
+        </p:style>
+        <p:txBody>
+          <a:bodyPr rtlCol="0" anchor="ctr"/>
+          <a:lstStyle/>
+          <a:p>
+            <a:pPr algn="ctr"/>
+          </a:p>
+        </p:txBody>
+      </p:sp>
+      <p:sp>
+        <p:nvSpPr>
+          <p:cNvPr id="12" name="TextBox 11"/>
+          <p:cNvSpPr txBox="1"/>
+          <p:nvPr/>
+        </p:nvSpPr>
+        <p:spPr>
+          <a:xfrm>
+            <a:off x="3044952" y="1723643"/>
+            <a:ext cx="182880" cy="164592"/>
+          </a:xfrm>
+          <a:prstGeom prst="rect">
+            <a:avLst/>
+          </a:prstGeom>
+          <a:noFill/>
+        </p:spPr>
+        <p:txBody>
+          <a:bodyPr wrap="square" lIns="18288" rIns="18288" tIns="18288" bIns="18288">
+            <a:spAutoFit/>
+          </a:bodyPr>
+          <a:lstStyle/>
+          <a:p>
+            <a:pPr algn="ctr"/>
+            <a:r>
+              <a:rPr sz="1700" b="1">
+                <a:solidFill>
+                  <a:srgbClr val="FFFFFF"/>
+                </a:solidFill>
+                <a:latin typeface="Aptos"/>
+              </a:rPr>
+              <a:t>2</a:t>
+            </a:r>
+          </a:p>
+        </p:txBody>
+      </p:sp>
+      <p:sp>
+        <p:nvSpPr>
+          <p:cNvPr id="13" name="TextBox 12"/>
+          <p:cNvSpPr txBox="1"/>
+          <p:nvPr/>
+        </p:nvSpPr>
+        <p:spPr>
+          <a:xfrm>
+            <a:off x="2953512" y="2130552"/>
+            <a:ext cx="1417320" cy="219456"/>
+          </a:xfrm>
+          <a:prstGeom prst="rect">
+            <a:avLst/>
+          </a:prstGeom>
+          <a:noFill/>
+        </p:spPr>
+        <p:txBody>
+          <a:bodyPr wrap="square" lIns="18288" rIns="18288" tIns="18288" bIns="18288">
+            <a:spAutoFit/>
+          </a:bodyPr>
+          <a:lstStyle/>
+          <a:p>
+            <a:r>
+              <a:rPr sz="1600" b="1">
+                <a:solidFill>
+                  <a:srgbClr val="0F172A"/>
+                </a:solidFill>
+                <a:latin typeface="Aptos"/>
+              </a:rPr>
+              <a:t>Patch placement</a:t>
+            </a:r>
+          </a:p>
+        </p:txBody>
+      </p:sp>
+      <p:sp>
+        <p:nvSpPr>
+          <p:cNvPr id="14" name="TextBox 13"/>
+          <p:cNvSpPr txBox="1"/>
+          <p:nvPr/>
+        </p:nvSpPr>
+        <p:spPr>
+          <a:xfrm>
+            <a:off x="2953512" y="2377439"/>
+            <a:ext cx="1417320" cy="256032"/>
+          </a:xfrm>
+          <a:prstGeom prst="rect">
+            <a:avLst/>
+          </a:prstGeom>
+          <a:noFill/>
+        </p:spPr>
+        <p:txBody>
+          <a:bodyPr wrap="square" lIns="18288" rIns="18288" tIns="18288" bIns="18288">
+            <a:spAutoFit/>
+          </a:bodyPr>
+          <a:lstStyle/>
+          <a:p>
+            <a:r>
+              <a:rPr sz="1300" b="0">
+                <a:solidFill>
+                  <a:srgbClr val="475569"/>
+                </a:solidFill>
+                <a:latin typeface="Aptos"/>
+              </a:rPr>
+              <a:t>scene-aware + sweep</a:t>
+            </a:r>
+          </a:p>
+        </p:txBody>
+      </p:sp>
+      <p:cxnSp>
+        <p:nvCxnSpPr>
+          <p:cNvPr id="15" name="Connector 14"/>
+          <p:cNvCxnSpPr/>
+          <p:nvPr/>
+        </p:nvCxnSpPr>
+        <p:spPr>
+          <a:xfrm>
+            <a:off x="4599431" y="2075688"/>
+            <a:ext cx="310897" cy="0"/>
+          </a:xfrm>
+          <a:prstGeom prst="line">
+            <a:avLst/>
+          </a:prstGeom>
+          <a:ln w="27940">
+            <a:solidFill>
+              <a:srgbClr val="2563EB"/>
+            </a:solidFill>
+          </a:ln>
+        </p:spPr>
+        <p:style>
+          <a:lnRef idx="2">
+            <a:schemeClr val="accent1"/>
+          </a:lnRef>
+          <a:fillRef idx="0">
+            <a:schemeClr val="accent1"/>
+          </a:fillRef>
+          <a:effectRef idx="1">
+            <a:schemeClr val="accent1"/>
+          </a:effectRef>
+          <a:fontRef idx="minor">
+            <a:schemeClr val="tx1"/>
+          </a:fontRef>
+        </p:style>
+      </p:cxnSp>
+      <p:sp>
+        <p:nvSpPr>
+          <p:cNvPr id="16" name="Rounded Rectangle 15"/>
+          <p:cNvSpPr/>
+          <p:nvPr/>
+        </p:nvSpPr>
+        <p:spPr>
+          <a:xfrm>
+            <a:off x="4983480" y="1508760"/>
+            <a:ext cx="1783080" cy="1143000"/>
+          </a:xfrm>
+          <a:prstGeom prst="roundRect">
+            <a:avLst/>
+          </a:prstGeom>
+          <a:solidFill>
+            <a:srgbClr val="FFFFFF"/>
+          </a:solidFill>
+          <a:ln w="12700">
+            <a:solidFill>
+              <a:srgbClr val="CBD5E1"/>
+            </a:solidFill>
+          </a:ln>
+        </p:spPr>
+        <p:style>
+          <a:lnRef idx="1">
+            <a:schemeClr val="accent1"/>
+          </a:lnRef>
+          <a:fillRef idx="3">
+            <a:schemeClr val="accent1"/>
+          </a:fillRef>
+          <a:effectRef idx="2">
+            <a:schemeClr val="accent1"/>
+          </a:effectRef>
+          <a:fontRef idx="minor">
+            <a:schemeClr val="lt1"/>
+          </a:fontRef>
+        </p:style>
+        <p:txBody>
+          <a:bodyPr rtlCol="0" anchor="ctr"/>
+          <a:lstStyle/>
+          <a:p>
+            <a:pPr algn="ctr"/>
+          </a:p>
+        </p:txBody>
+      </p:sp>
+      <p:sp>
+        <p:nvSpPr>
+          <p:cNvPr id="17" name="Oval 16"/>
+          <p:cNvSpPr/>
+          <p:nvPr/>
+        </p:nvSpPr>
+        <p:spPr>
+          <a:xfrm>
+            <a:off x="5129784" y="1673351"/>
+            <a:ext cx="347472" cy="347472"/>
+          </a:xfrm>
+          <a:prstGeom prst="ellipse">
+            <a:avLst/>
+          </a:prstGeom>
+          <a:solidFill>
+            <a:srgbClr val="2563EB"/>
+          </a:solidFill>
+          <a:ln>
+            <a:solidFill>
+              <a:srgbClr val="2563EB"/>
+            </a:solidFill>
+          </a:ln>
+        </p:spPr>
+        <p:style>
+          <a:lnRef idx="1">
+            <a:schemeClr val="accent1"/>
+          </a:lnRef>
+          <a:fillRef idx="3">
+            <a:schemeClr val="accent1"/>
+          </a:fillRef>
+          <a:effectRef idx="2">
+            <a:schemeClr val="accent1"/>
+          </a:effectRef>
+          <a:fontRef idx="minor">
+            <a:schemeClr val="lt1"/>
+          </a:fontRef>
+        </p:style>
+        <p:txBody>
+          <a:bodyPr rtlCol="0" anchor="ctr"/>
+          <a:lstStyle/>
+          <a:p>
+            <a:pPr algn="ctr"/>
+          </a:p>
+        </p:txBody>
+      </p:sp>
+      <p:sp>
+        <p:nvSpPr>
+          <p:cNvPr id="18" name="TextBox 17"/>
+          <p:cNvSpPr txBox="1"/>
+          <p:nvPr/>
+        </p:nvSpPr>
+        <p:spPr>
+          <a:xfrm>
+            <a:off x="5239512" y="1723643"/>
+            <a:ext cx="182880" cy="164592"/>
+          </a:xfrm>
+          <a:prstGeom prst="rect">
+            <a:avLst/>
+          </a:prstGeom>
+          <a:noFill/>
+        </p:spPr>
+        <p:txBody>
+          <a:bodyPr wrap="square" lIns="18288" rIns="18288" tIns="18288" bIns="18288">
+            <a:spAutoFit/>
+          </a:bodyPr>
+          <a:lstStyle/>
+          <a:p>
+            <a:pPr algn="ctr"/>
+            <a:r>
+              <a:rPr sz="1700" b="1">
+                <a:solidFill>
+                  <a:srgbClr val="FFFFFF"/>
+                </a:solidFill>
+                <a:latin typeface="Aptos"/>
+              </a:rPr>
+              <a:t>3</a:t>
+            </a:r>
+          </a:p>
+        </p:txBody>
+      </p:sp>
+      <p:sp>
+        <p:nvSpPr>
+          <p:cNvPr id="19" name="TextBox 18"/>
+          <p:cNvSpPr txBox="1"/>
+          <p:nvPr/>
+        </p:nvSpPr>
+        <p:spPr>
+          <a:xfrm>
+            <a:off x="5148072" y="2130552"/>
+            <a:ext cx="1417320" cy="219456"/>
+          </a:xfrm>
+          <a:prstGeom prst="rect">
+            <a:avLst/>
+          </a:prstGeom>
+          <a:noFill/>
+        </p:spPr>
+        <p:txBody>
+          <a:bodyPr wrap="square" lIns="18288" rIns="18288" tIns="18288" bIns="18288">
+            <a:spAutoFit/>
+          </a:bodyPr>
+          <a:lstStyle/>
+          <a:p>
+            <a:r>
+              <a:rPr sz="1600" b="1">
+                <a:solidFill>
+                  <a:srgbClr val="0F172A"/>
+                </a:solidFill>
+                <a:latin typeface="Aptos"/>
+              </a:rPr>
+              <a:t>Black-box search</a:t>
+            </a:r>
+          </a:p>
+        </p:txBody>
+      </p:sp>
+      <p:sp>
+        <p:nvSpPr>
+          <p:cNvPr id="20" name="TextBox 19"/>
+          <p:cNvSpPr txBox="1"/>
+          <p:nvPr/>
+        </p:nvSpPr>
+        <p:spPr>
+          <a:xfrm>
+            <a:off x="5148072" y="2377439"/>
+            <a:ext cx="1417320" cy="256032"/>
+          </a:xfrm>
+          <a:prstGeom prst="rect">
+            <a:avLst/>
+          </a:prstGeom>
+          <a:noFill/>
+        </p:spPr>
+        <p:txBody>
+          <a:bodyPr wrap="square" lIns="18288" rIns="18288" tIns="18288" bIns="18288">
+            <a:spAutoFit/>
+          </a:bodyPr>
+          <a:lstStyle/>
+          <a:p>
+            <a:r>
+              <a:rPr sz="1300" b="0">
+                <a:solidFill>
+                  <a:srgbClr val="475569"/>
+                </a:solidFill>
+                <a:latin typeface="Aptos"/>
+              </a:rPr>
+              <a:t>evolution / NES, no gradients</a:t>
+            </a:r>
+          </a:p>
+        </p:txBody>
+      </p:sp>
+      <p:cxnSp>
+        <p:nvCxnSpPr>
+          <p:cNvPr id="21" name="Connector 20"/>
+          <p:cNvCxnSpPr/>
+          <p:nvPr/>
+        </p:nvCxnSpPr>
+        <p:spPr>
+          <a:xfrm>
+            <a:off x="6793992" y="2075688"/>
+            <a:ext cx="310896" cy="0"/>
+          </a:xfrm>
+          <a:prstGeom prst="line">
+            <a:avLst/>
+          </a:prstGeom>
+          <a:ln w="27940">
+            <a:solidFill>
+              <a:srgbClr val="2563EB"/>
+            </a:solidFill>
+          </a:ln>
+        </p:spPr>
+        <p:style>
+          <a:lnRef idx="2">
+            <a:schemeClr val="accent1"/>
+          </a:lnRef>
+          <a:fillRef idx="0">
+            <a:schemeClr val="accent1"/>
+          </a:fillRef>
+          <a:effectRef idx="1">
+            <a:schemeClr val="accent1"/>
+          </a:effectRef>
+          <a:fontRef idx="minor">
+            <a:schemeClr val="tx1"/>
+          </a:fontRef>
+        </p:style>
+      </p:cxnSp>
+      <p:sp>
+        <p:nvSpPr>
+          <p:cNvPr id="22" name="Rounded Rectangle 21"/>
+          <p:cNvSpPr/>
+          <p:nvPr/>
+        </p:nvSpPr>
+        <p:spPr>
+          <a:xfrm>
+            <a:off x="7178040" y="1508760"/>
+            <a:ext cx="1783080" cy="1143000"/>
+          </a:xfrm>
+          <a:prstGeom prst="roundRect">
+            <a:avLst/>
+          </a:prstGeom>
+          <a:solidFill>
+            <a:srgbClr val="FFFFFF"/>
+          </a:solidFill>
+          <a:ln w="12700">
+            <a:solidFill>
+              <a:srgbClr val="CBD5E1"/>
+            </a:solidFill>
+          </a:ln>
+        </p:spPr>
+        <p:style>
+          <a:lnRef idx="1">
+            <a:schemeClr val="accent1"/>
+          </a:lnRef>
+          <a:fillRef idx="3">
+            <a:schemeClr val="accent1"/>
+          </a:fillRef>
+          <a:effectRef idx="2">
+            <a:schemeClr val="accent1"/>
+          </a:effectRef>
+          <a:fontRef idx="minor">
+            <a:schemeClr val="lt1"/>
+          </a:fontRef>
+        </p:style>
+        <p:txBody>
+          <a:bodyPr rtlCol="0" anchor="ctr"/>
+          <a:lstStyle/>
+          <a:p>
+            <a:pPr algn="ctr"/>
+          </a:p>
+        </p:txBody>
+      </p:sp>
+      <p:sp>
+        <p:nvSpPr>
+          <p:cNvPr id="23" name="Oval 22"/>
+          <p:cNvSpPr/>
+          <p:nvPr/>
+        </p:nvSpPr>
+        <p:spPr>
+          <a:xfrm>
+            <a:off x="7324344" y="1673351"/>
+            <a:ext cx="347472" cy="347472"/>
+          </a:xfrm>
+          <a:prstGeom prst="ellipse">
+            <a:avLst/>
+          </a:prstGeom>
+          <a:solidFill>
+            <a:srgbClr val="2563EB"/>
+          </a:solidFill>
+          <a:ln>
+            <a:solidFill>
+              <a:srgbClr val="2563EB"/>
+            </a:solidFill>
+          </a:ln>
+        </p:spPr>
+        <p:style>
+          <a:lnRef idx="1">
+            <a:schemeClr val="accent1"/>
+          </a:lnRef>
+          <a:fillRef idx="3">
+            <a:schemeClr val="accent1"/>
+          </a:fillRef>
+          <a:effectRef idx="2">
+            <a:schemeClr val="accent1"/>
+          </a:effectRef>
+          <a:fontRef idx="minor">
+            <a:schemeClr val="lt1"/>
+          </a:fontRef>
+        </p:style>
+        <p:txBody>
+          <a:bodyPr rtlCol="0" anchor="ctr"/>
+          <a:lstStyle/>
+          <a:p>
+            <a:pPr algn="ctr"/>
+          </a:p>
+        </p:txBody>
+      </p:sp>
+      <p:sp>
+        <p:nvSpPr>
+          <p:cNvPr id="24" name="TextBox 23"/>
+          <p:cNvSpPr txBox="1"/>
+          <p:nvPr/>
+        </p:nvSpPr>
+        <p:spPr>
+          <a:xfrm>
+            <a:off x="7434071" y="1723643"/>
+            <a:ext cx="182880" cy="164592"/>
+          </a:xfrm>
+          <a:prstGeom prst="rect">
+            <a:avLst/>
+          </a:prstGeom>
+          <a:noFill/>
+        </p:spPr>
+        <p:txBody>
+          <a:bodyPr wrap="square" lIns="18288" rIns="18288" tIns="18288" bIns="18288">
+            <a:spAutoFit/>
+          </a:bodyPr>
+          <a:lstStyle/>
+          <a:p>
+            <a:pPr algn="ctr"/>
+            <a:r>
+              <a:rPr sz="1700" b="1">
+                <a:solidFill>
+                  <a:srgbClr val="FFFFFF"/>
+                </a:solidFill>
+                <a:latin typeface="Aptos"/>
+              </a:rPr>
+              <a:t>4</a:t>
+            </a:r>
+          </a:p>
+        </p:txBody>
+      </p:sp>
+      <p:sp>
+        <p:nvSpPr>
+          <p:cNvPr id="25" name="TextBox 24"/>
+          <p:cNvSpPr txBox="1"/>
+          <p:nvPr/>
+        </p:nvSpPr>
+        <p:spPr>
+          <a:xfrm>
+            <a:off x="7342631" y="2130552"/>
+            <a:ext cx="1417320" cy="219456"/>
+          </a:xfrm>
+          <a:prstGeom prst="rect">
+            <a:avLst/>
+          </a:prstGeom>
+          <a:noFill/>
+        </p:spPr>
+        <p:txBody>
+          <a:bodyPr wrap="square" lIns="18288" rIns="18288" tIns="18288" bIns="18288">
+            <a:spAutoFit/>
+          </a:bodyPr>
+          <a:lstStyle/>
+          <a:p>
+            <a:r>
+              <a:rPr sz="1600" b="1">
+                <a:solidFill>
+                  <a:srgbClr val="0F172A"/>
+                </a:solidFill>
+                <a:latin typeface="Aptos"/>
+              </a:rPr>
+              <a:t>Objective</a:t>
+            </a:r>
+          </a:p>
+        </p:txBody>
+      </p:sp>
+      <p:sp>
+        <p:nvSpPr>
+          <p:cNvPr id="26" name="TextBox 25"/>
+          <p:cNvSpPr txBox="1"/>
+          <p:nvPr/>
+        </p:nvSpPr>
+        <p:spPr>
+          <a:xfrm>
+            <a:off x="7342631" y="2377439"/>
+            <a:ext cx="1417320" cy="256032"/>
+          </a:xfrm>
+          <a:prstGeom prst="rect">
+            <a:avLst/>
+          </a:prstGeom>
+          <a:noFill/>
+        </p:spPr>
+        <p:txBody>
+          <a:bodyPr wrap="square" lIns="18288" rIns="18288" tIns="18288" bIns="18288">
+            <a:spAutoFit/>
+          </a:bodyPr>
+          <a:lstStyle/>
+          <a:p>
+            <a:r>
+              <a:rPr sz="1300" b="0">
+                <a:solidFill>
+                  <a:srgbClr val="475569"/>
+                </a:solidFill>
+                <a:latin typeface="Aptos"/>
+              </a:rPr>
+              <a:t>target-direction trajectory shift</a:t>
+            </a:r>
+          </a:p>
+        </p:txBody>
+      </p:sp>
+      <p:cxnSp>
+        <p:nvCxnSpPr>
+          <p:cNvPr id="27" name="Connector 26"/>
+          <p:cNvCxnSpPr/>
+          <p:nvPr/>
+        </p:nvCxnSpPr>
+        <p:spPr>
+          <a:xfrm>
+            <a:off x="8988552" y="2075688"/>
+            <a:ext cx="310896" cy="0"/>
+          </a:xfrm>
+          <a:prstGeom prst="line">
+            <a:avLst/>
+          </a:prstGeom>
+          <a:ln w="27940">
+            <a:solidFill>
+              <a:srgbClr val="2563EB"/>
+            </a:solidFill>
+          </a:ln>
+        </p:spPr>
+        <p:style>
+          <a:lnRef idx="2">
+            <a:schemeClr val="accent1"/>
+          </a:lnRef>
+          <a:fillRef idx="0">
+            <a:schemeClr val="accent1"/>
+          </a:fillRef>
+          <a:effectRef idx="1">
+            <a:schemeClr val="accent1"/>
+          </a:effectRef>
+          <a:fontRef idx="minor">
+            <a:schemeClr val="tx1"/>
+          </a:fontRef>
+        </p:style>
+      </p:cxnSp>
+      <p:sp>
+        <p:nvSpPr>
+          <p:cNvPr id="28" name="Rounded Rectangle 27"/>
+          <p:cNvSpPr/>
+          <p:nvPr/>
+        </p:nvSpPr>
+        <p:spPr>
+          <a:xfrm>
+            <a:off x="9372600" y="1508760"/>
+            <a:ext cx="1783080" cy="1143000"/>
+          </a:xfrm>
+          <a:prstGeom prst="roundRect">
+            <a:avLst/>
+          </a:prstGeom>
+          <a:solidFill>
+            <a:srgbClr val="FFFFFF"/>
+          </a:solidFill>
+          <a:ln w="12700">
+            <a:solidFill>
+              <a:srgbClr val="CBD5E1"/>
+            </a:solidFill>
+          </a:ln>
+        </p:spPr>
+        <p:style>
+          <a:lnRef idx="1">
+            <a:schemeClr val="accent1"/>
+          </a:lnRef>
+          <a:fillRef idx="3">
+            <a:schemeClr val="accent1"/>
+          </a:fillRef>
+          <a:effectRef idx="2">
+            <a:schemeClr val="accent1"/>
+          </a:effectRef>
+          <a:fontRef idx="minor">
+            <a:schemeClr val="lt1"/>
+          </a:fontRef>
+        </p:style>
+        <p:txBody>
+          <a:bodyPr rtlCol="0" anchor="ctr"/>
+          <a:lstStyle/>
+          <a:p>
+            <a:pPr algn="ctr"/>
+          </a:p>
+        </p:txBody>
+      </p:sp>
+      <p:sp>
+        <p:nvSpPr>
+          <p:cNvPr id="29" name="Oval 28"/>
+          <p:cNvSpPr/>
+          <p:nvPr/>
+        </p:nvSpPr>
+        <p:spPr>
+          <a:xfrm>
+            <a:off x="9518904" y="1673351"/>
+            <a:ext cx="347472" cy="347472"/>
+          </a:xfrm>
+          <a:prstGeom prst="ellipse">
+            <a:avLst/>
+          </a:prstGeom>
+          <a:solidFill>
+            <a:srgbClr val="2563EB"/>
+          </a:solidFill>
+          <a:ln>
+            <a:solidFill>
+              <a:srgbClr val="2563EB"/>
+            </a:solidFill>
+          </a:ln>
+        </p:spPr>
+        <p:style>
+          <a:lnRef idx="1">
+            <a:schemeClr val="accent1"/>
+          </a:lnRef>
+          <a:fillRef idx="3">
+            <a:schemeClr val="accent1"/>
+          </a:fillRef>
+          <a:effectRef idx="2">
+            <a:schemeClr val="accent1"/>
+          </a:effectRef>
+          <a:fontRef idx="minor">
+            <a:schemeClr val="lt1"/>
+          </a:fontRef>
+        </p:style>
+        <p:txBody>
+          <a:bodyPr rtlCol="0" anchor="ctr"/>
+          <a:lstStyle/>
+          <a:p>
+            <a:pPr algn="ctr"/>
+          </a:p>
+        </p:txBody>
+      </p:sp>
+      <p:sp>
+        <p:nvSpPr>
+          <p:cNvPr id="30" name="TextBox 29"/>
+          <p:cNvSpPr txBox="1"/>
+          <p:nvPr/>
+        </p:nvSpPr>
+        <p:spPr>
+          <a:xfrm>
+            <a:off x="9628632" y="1723643"/>
+            <a:ext cx="182880" cy="164592"/>
+          </a:xfrm>
+          <a:prstGeom prst="rect">
+            <a:avLst/>
+          </a:prstGeom>
+          <a:noFill/>
+        </p:spPr>
+        <p:txBody>
+          <a:bodyPr wrap="square" lIns="18288" rIns="18288" tIns="18288" bIns="18288">
+            <a:spAutoFit/>
+          </a:bodyPr>
+          <a:lstStyle/>
+          <a:p>
+            <a:pPr algn="ctr"/>
+            <a:r>
+              <a:rPr sz="1700" b="1">
+                <a:solidFill>
+                  <a:srgbClr val="FFFFFF"/>
+                </a:solidFill>
+                <a:latin typeface="Aptos"/>
+              </a:rPr>
+              <a:t>5</a:t>
+            </a:r>
+          </a:p>
+        </p:txBody>
+      </p:sp>
+      <p:sp>
+        <p:nvSpPr>
+          <p:cNvPr id="31" name="TextBox 30"/>
+          <p:cNvSpPr txBox="1"/>
+          <p:nvPr/>
+        </p:nvSpPr>
+        <p:spPr>
+          <a:xfrm>
+            <a:off x="9537192" y="2130552"/>
+            <a:ext cx="1417320" cy="219456"/>
+          </a:xfrm>
+          <a:prstGeom prst="rect">
+            <a:avLst/>
+          </a:prstGeom>
+          <a:noFill/>
+        </p:spPr>
+        <p:txBody>
+          <a:bodyPr wrap="square" lIns="18288" rIns="18288" tIns="18288" bIns="18288">
+            <a:spAutoFit/>
+          </a:bodyPr>
+          <a:lstStyle/>
+          <a:p>
+            <a:r>
+              <a:rPr sz="1600" b="1">
+                <a:solidFill>
+                  <a:srgbClr val="0F172A"/>
+                </a:solidFill>
+                <a:latin typeface="Aptos"/>
+              </a:rPr>
+              <a:t>Evaluate</a:t>
+            </a:r>
+          </a:p>
+        </p:txBody>
+      </p:sp>
+      <p:sp>
+        <p:nvSpPr>
+          <p:cNvPr id="32" name="TextBox 31"/>
+          <p:cNvSpPr txBox="1"/>
+          <p:nvPr/>
+        </p:nvSpPr>
+        <p:spPr>
+          <a:xfrm>
+            <a:off x="9537192" y="2377439"/>
+            <a:ext cx="1417320" cy="256032"/>
+          </a:xfrm>
+          <a:prstGeom prst="rect">
+            <a:avLst/>
+          </a:prstGeom>
+          <a:noFill/>
+        </p:spPr>
+        <p:txBody>
+          <a:bodyPr wrap="square" lIns="18288" rIns="18288" tIns="18288" bIns="18288">
+            <a:spAutoFit/>
+          </a:bodyPr>
+          <a:lstStyle/>
+          <a:p>
+            <a:r>
+              <a:rPr sz="1300" b="0">
+                <a:solidFill>
+                  <a:srgbClr val="475569"/>
+                </a:solidFill>
+                <a:latin typeface="Aptos"/>
+              </a:rPr>
+              <a:t>clean vs attacked trajectory</a:t>
+            </a:r>
+          </a:p>
+        </p:txBody>
+      </p:sp>
+      <p:sp>
+        <p:nvSpPr>
+          <p:cNvPr id="33" name="Rounded Rectangle 32"/>
+          <p:cNvSpPr/>
+          <p:nvPr/>
+        </p:nvSpPr>
+        <p:spPr>
+          <a:xfrm>
+            <a:off x="594360" y="3246120"/>
+            <a:ext cx="4389120" cy="2834640"/>
+          </a:xfrm>
+          <a:prstGeom prst="roundRect">
+            <a:avLst/>
+          </a:prstGeom>
+          <a:solidFill>
+            <a:srgbClr val="FFFFFF"/>
+          </a:solidFill>
+          <a:ln w="12700">
+            <a:solidFill>
+              <a:srgbClr val="CBD5E1"/>
+            </a:solidFill>
+          </a:ln>
+        </p:spPr>
+        <p:style>
+          <a:lnRef idx="1">
+            <a:schemeClr val="accent1"/>
+          </a:lnRef>
+          <a:fillRef idx="3">
+            <a:schemeClr val="accent1"/>
+          </a:fillRef>
+          <a:effectRef idx="2">
+            <a:schemeClr val="accent1"/>
+          </a:effectRef>
+          <a:fontRef idx="minor">
+            <a:schemeClr val="lt1"/>
+          </a:fontRef>
+        </p:style>
+        <p:txBody>
+          <a:bodyPr rtlCol="0" anchor="ctr"/>
+          <a:lstStyle/>
+          <a:p>
+            <a:pPr algn="ctr"/>
+          </a:p>
+        </p:txBody>
+      </p:sp>
+      <p:sp>
+        <p:nvSpPr>
+          <p:cNvPr id="34" name="TextBox 33"/>
+          <p:cNvSpPr txBox="1"/>
+          <p:nvPr/>
+        </p:nvSpPr>
+        <p:spPr>
+          <a:xfrm>
+            <a:off x="822960" y="3520440"/>
+            <a:ext cx="3840480" cy="320040"/>
+          </a:xfrm>
+          <a:prstGeom prst="rect">
+            <a:avLst/>
+          </a:prstGeom>
+          <a:noFill/>
+        </p:spPr>
+        <p:txBody>
+          <a:bodyPr wrap="square" lIns="18288" rIns="18288" tIns="18288" bIns="18288">
+            <a:spAutoFit/>
+          </a:bodyPr>
+          <a:lstStyle/>
+          <a:p>
+            <a:r>
+              <a:rPr sz="2200" b="1">
+                <a:solidFill>
+                  <a:srgbClr val="0F172A"/>
+                </a:solidFill>
+                <a:latin typeface="Aptos"/>
+              </a:rPr>
+              <a:t>Attack objective</a:t>
+            </a:r>
+          </a:p>
+        </p:txBody>
+      </p:sp>
+      <p:sp>
+        <p:nvSpPr>
+          <p:cNvPr id="35" name="TextBox 34"/>
+          <p:cNvSpPr txBox="1"/>
+          <p:nvPr/>
+        </p:nvSpPr>
+        <p:spPr>
+          <a:xfrm>
+            <a:off x="822960" y="3977639"/>
+            <a:ext cx="3886200" cy="1920240"/>
+          </a:xfrm>
+          <a:prstGeom prst="rect">
+            <a:avLst/>
+          </a:prstGeom>
+          <a:noFill/>
+        </p:spPr>
+        <p:txBody>
+          <a:bodyPr wrap="square" lIns="45720" rIns="45720" tIns="18288" bIns="18288">
+            <a:spAutoFit/>
+          </a:bodyPr>
+          <a:lstStyle/>
+          <a:p>
+            <a:pPr>
+              <a:spcAft>
+                <a:spcPts val="700"/>
+              </a:spcAft>
+              <a:defRPr sz="1600">
+                <a:solidFill>
+                  <a:srgbClr val="475569"/>
+                </a:solidFill>
+                <a:latin typeface="Aptos"/>
+              </a:defRPr>
+            </a:pPr>
+            <a:r>
+              <a:t>Use decoded trajectory only: clean prediction vs attacked prediction.</a:t>
+            </a:r>
+          </a:p>
+          <a:p>
+            <a:pPr>
+              <a:spcAft>
+                <a:spcPts val="700"/>
+              </a:spcAft>
+              <a:defRPr sz="1600">
+                <a:solidFill>
+                  <a:srgbClr val="475569"/>
+                </a:solidFill>
+                <a:latin typeface="Aptos"/>
+              </a:defRPr>
+            </a:pPr>
+            <a:r>
+              <a:t>Position-aware loss rewards target-direction lateral shift and final displacement.</a:t>
+            </a:r>
+          </a:p>
+          <a:p>
+            <a:pPr>
+              <a:spcAft>
+                <a:spcPts val="700"/>
+              </a:spcAft>
+              <a:defRPr sz="1600">
+                <a:solidFill>
+                  <a:srgbClr val="475569"/>
+                </a:solidFill>
+                <a:latin typeface="Aptos"/>
+              </a:defRPr>
+            </a:pPr>
+            <a:r>
+              <a:t>Penalizes wrong-way lateral movement and pure forward/backward drift.</a:t>
+            </a:r>
+          </a:p>
+          <a:p>
+            <a:pPr>
+              <a:spcAft>
+                <a:spcPts val="700"/>
+              </a:spcAft>
+              <a:defRPr sz="1600">
+                <a:solidFill>
+                  <a:srgbClr val="475569"/>
+                </a:solidFill>
+                <a:latin typeface="Aptos"/>
+              </a:defRPr>
+            </a:pPr>
+            <a:r>
+              <a:t>Evolution search keeps best candidates because generation outputs are non-smooth.</a:t>
+            </a:r>
+          </a:p>
+        </p:txBody>
+      </p:sp>
+      <p:sp>
+        <p:nvSpPr>
+          <p:cNvPr id="36" name="Rounded Rectangle 35"/>
+          <p:cNvSpPr/>
+          <p:nvPr/>
+        </p:nvSpPr>
+        <p:spPr>
+          <a:xfrm>
+            <a:off x="5349240" y="3246120"/>
+            <a:ext cx="6263640" cy="2834640"/>
+          </a:xfrm>
+          <a:prstGeom prst="roundRect">
+            <a:avLst/>
+          </a:prstGeom>
+          <a:solidFill>
+            <a:srgbClr val="FFFFFF"/>
+          </a:solidFill>
+          <a:ln w="12700">
+            <a:solidFill>
+              <a:srgbClr val="CBD5E1"/>
+            </a:solidFill>
+          </a:ln>
+        </p:spPr>
+        <p:style>
+          <a:lnRef idx="1">
+            <a:schemeClr val="accent1"/>
+          </a:lnRef>
+          <a:fillRef idx="3">
+            <a:schemeClr val="accent1"/>
+          </a:fillRef>
+          <a:effectRef idx="2">
+            <a:schemeClr val="accent1"/>
+          </a:effectRef>
+          <a:fontRef idx="minor">
+            <a:schemeClr val="lt1"/>
+          </a:fontRef>
+        </p:style>
+        <p:txBody>
+          <a:bodyPr rtlCol="0" anchor="ctr"/>
+          <a:lstStyle/>
+          <a:p>
+            <a:pPr algn="ctr"/>
+          </a:p>
+        </p:txBody>
+      </p:sp>
+      <p:sp>
+        <p:nvSpPr>
+          <p:cNvPr id="37" name="TextBox 36"/>
+          <p:cNvSpPr txBox="1"/>
+          <p:nvPr/>
+        </p:nvSpPr>
+        <p:spPr>
+          <a:xfrm>
+            <a:off x="5577840" y="3520440"/>
+            <a:ext cx="4114800" cy="320040"/>
+          </a:xfrm>
+          <a:prstGeom prst="rect">
+            <a:avLst/>
+          </a:prstGeom>
+          <a:noFill/>
+        </p:spPr>
+        <p:txBody>
+          <a:bodyPr wrap="square" lIns="18288" rIns="18288" tIns="18288" bIns="18288">
+            <a:spAutoFit/>
+          </a:bodyPr>
+          <a:lstStyle/>
+          <a:p>
+            <a:r>
+              <a:rPr sz="2200" b="1">
+                <a:solidFill>
+                  <a:srgbClr val="0F172A"/>
+                </a:solidFill>
+                <a:latin typeface="Aptos"/>
+              </a:rPr>
+              <a:t>Scene-aware placement</a:t>
+            </a:r>
+          </a:p>
+        </p:txBody>
+      </p:sp>
       <p:pic>
         <p:nvPicPr>
-          <p:cNvPr id="2" name="Picture 1" descr="slide_01.png"/>
+          <p:cNvPr id="38" name="Picture 37" descr="overlay.jpg"/>
           <p:cNvPicPr>
             <a:picLocks noChangeAspect="1"/>
           </p:cNvPicPr>
@@ -3595,14 +4531,48 @@
         </p:blipFill>
         <p:spPr>
           <a:xfrm>
-            <a:off x="0" y="0"/>
-            <a:ext cx="12191999" cy="6858000"/>
+            <a:off x="6720840" y="3858768"/>
+            <a:ext cx="1076886" cy="1783080"/>
           </a:xfrm>
           <a:prstGeom prst="rect">
             <a:avLst/>
           </a:prstGeom>
         </p:spPr>
       </p:pic>
+      <p:sp>
+        <p:nvSpPr>
+          <p:cNvPr id="39" name="TextBox 38"/>
+          <p:cNvSpPr txBox="1"/>
+          <p:nvPr/>
+        </p:nvSpPr>
+        <p:spPr>
+          <a:xfrm>
+            <a:off x="5577840" y="5623560"/>
+            <a:ext cx="5669280" cy="384048"/>
+          </a:xfrm>
+          <a:prstGeom prst="rect">
+            <a:avLst/>
+          </a:prstGeom>
+          <a:noFill/>
+        </p:spPr>
+        <p:txBody>
+          <a:bodyPr wrap="square" lIns="18288" rIns="18288" tIns="18288" bIns="18288">
+            <a:spAutoFit/>
+          </a:bodyPr>
+          <a:lstStyle/>
+          <a:p>
+            <a:r>
+              <a:rPr sz="1400" b="0">
+                <a:solidFill>
+                  <a:srgbClr val="475569"/>
+                </a:solidFill>
+                <a:latin typeface="Aptos"/>
+              </a:rPr>
+              <a:t>Heuristic probes construction cues, road/lane texture, and horizon fallback. Black-box sweep then selects the best position per scene.</a:t>
+            </a:r>
+          </a:p>
+        </p:txBody>
+      </p:sp>
     </p:spTree>
   </p:cSld>
   <p:clrMapOvr>
@@ -3614,6 +4584,14 @@
 <file path=ppt/slides/slide2.xml><?xml version="1.0" encoding="utf-8"?>
 <p:sld xmlns:a="http://schemas.openxmlformats.org/drawingml/2006/main" xmlns:p="http://schemas.openxmlformats.org/presentationml/2006/main" xmlns:r="http://schemas.openxmlformats.org/officeDocument/2006/relationships">
   <p:cSld>
+    <p:bg>
+      <p:bgPr>
+        <a:solidFill>
+          <a:srgbClr val="F8FAFC"/>
+        </a:solidFill>
+        <a:effectLst/>
+      </p:bgPr>
+    </p:bg>
     <p:spTree>
       <p:nvGrpSpPr>
         <p:cNvPr id="1" name=""/>
@@ -3621,9 +4599,744 @@
         <p:nvPr/>
       </p:nvGrpSpPr>
       <p:grpSpPr/>
+      <p:sp>
+        <p:nvSpPr>
+          <p:cNvPr id="2" name="TextBox 1"/>
+          <p:cNvSpPr txBox="1"/>
+          <p:nvPr/>
+        </p:nvSpPr>
+        <p:spPr>
+          <a:xfrm>
+            <a:off x="594360" y="384048"/>
+            <a:ext cx="10607040" cy="502920"/>
+          </a:xfrm>
+          <a:prstGeom prst="rect">
+            <a:avLst/>
+          </a:prstGeom>
+          <a:noFill/>
+        </p:spPr>
+        <p:txBody>
+          <a:bodyPr wrap="square" lIns="18288" rIns="18288" tIns="18288" bIns="18288">
+            <a:spAutoFit/>
+          </a:bodyPr>
+          <a:lstStyle/>
+          <a:p>
+            <a:r>
+              <a:rPr sz="3400" b="1">
+                <a:solidFill>
+                  <a:srgbClr val="0F172A"/>
+                </a:solidFill>
+                <a:latin typeface="Aptos"/>
+              </a:rPr>
+              <a:t>Results: Smaller Patch Helps, but Still Not Robust</a:t>
+            </a:r>
+          </a:p>
+        </p:txBody>
+      </p:sp>
+      <p:sp>
+        <p:nvSpPr>
+          <p:cNvPr id="3" name="TextBox 2"/>
+          <p:cNvSpPr txBox="1"/>
+          <p:nvPr/>
+        </p:nvSpPr>
+        <p:spPr>
+          <a:xfrm>
+            <a:off x="612648" y="896112"/>
+            <a:ext cx="8046720" cy="320040"/>
+          </a:xfrm>
+          <a:prstGeom prst="rect">
+            <a:avLst/>
+          </a:prstGeom>
+          <a:noFill/>
+        </p:spPr>
+        <p:txBody>
+          <a:bodyPr wrap="square" lIns="18288" rIns="18288" tIns="18288" bIns="18288">
+            <a:spAutoFit/>
+          </a:bodyPr>
+          <a:lstStyle/>
+          <a:p>
+            <a:r>
+              <a:rPr sz="1900" b="0">
+                <a:solidFill>
+                  <a:srgbClr val="475569"/>
+                </a:solidFill>
+                <a:latin typeface="Aptos"/>
+              </a:rPr>
+              <a:t>p20 front-camera patch, 5 nuScenes samples, scene-aware position sweep</a:t>
+            </a:r>
+          </a:p>
+        </p:txBody>
+      </p:sp>
+      <p:sp>
+        <p:nvSpPr>
+          <p:cNvPr id="4" name="Rounded Rectangle 3"/>
+          <p:cNvSpPr/>
+          <p:nvPr/>
+        </p:nvSpPr>
+        <p:spPr>
+          <a:xfrm>
+            <a:off x="594360" y="1417320"/>
+            <a:ext cx="2423160" cy="960120"/>
+          </a:xfrm>
+          <a:prstGeom prst="roundRect">
+            <a:avLst/>
+          </a:prstGeom>
+          <a:solidFill>
+            <a:srgbClr val="FFFFFF"/>
+          </a:solidFill>
+          <a:ln w="12700">
+            <a:solidFill>
+              <a:srgbClr val="CBD5E1"/>
+            </a:solidFill>
+          </a:ln>
+        </p:spPr>
+        <p:style>
+          <a:lnRef idx="1">
+            <a:schemeClr val="accent1"/>
+          </a:lnRef>
+          <a:fillRef idx="3">
+            <a:schemeClr val="accent1"/>
+          </a:fillRef>
+          <a:effectRef idx="2">
+            <a:schemeClr val="accent1"/>
+          </a:effectRef>
+          <a:fontRef idx="minor">
+            <a:schemeClr val="lt1"/>
+          </a:fontRef>
+        </p:style>
+        <p:txBody>
+          <a:bodyPr rtlCol="0" anchor="ctr"/>
+          <a:lstStyle/>
+          <a:p>
+            <a:pPr algn="ctr"/>
+          </a:p>
+        </p:txBody>
+      </p:sp>
+      <p:sp>
+        <p:nvSpPr>
+          <p:cNvPr id="5" name="TextBox 4"/>
+          <p:cNvSpPr txBox="1"/>
+          <p:nvPr/>
+        </p:nvSpPr>
+        <p:spPr>
+          <a:xfrm>
+            <a:off x="758952" y="1581912"/>
+            <a:ext cx="2093976" cy="228600"/>
+          </a:xfrm>
+          <a:prstGeom prst="rect">
+            <a:avLst/>
+          </a:prstGeom>
+          <a:noFill/>
+        </p:spPr>
+        <p:txBody>
+          <a:bodyPr wrap="square" lIns="18288" rIns="18288" tIns="18288" bIns="18288">
+            <a:spAutoFit/>
+          </a:bodyPr>
+          <a:lstStyle/>
+          <a:p>
+            <a:r>
+              <a:rPr sz="1500" b="1">
+                <a:solidFill>
+                  <a:srgbClr val="475569"/>
+                </a:solidFill>
+                <a:latin typeface="Aptos"/>
+              </a:rPr>
+              <a:t>Avg final shift</a:t>
+            </a:r>
+          </a:p>
+        </p:txBody>
+      </p:sp>
+      <p:sp>
+        <p:nvSpPr>
+          <p:cNvPr id="6" name="TextBox 5"/>
+          <p:cNvSpPr txBox="1"/>
+          <p:nvPr/>
+        </p:nvSpPr>
+        <p:spPr>
+          <a:xfrm>
+            <a:off x="758952" y="1856232"/>
+            <a:ext cx="2093976" cy="411480"/>
+          </a:xfrm>
+          <a:prstGeom prst="rect">
+            <a:avLst/>
+          </a:prstGeom>
+          <a:noFill/>
+        </p:spPr>
+        <p:txBody>
+          <a:bodyPr wrap="square" lIns="18288" rIns="18288" tIns="18288" bIns="18288">
+            <a:spAutoFit/>
+          </a:bodyPr>
+          <a:lstStyle/>
+          <a:p>
+            <a:r>
+              <a:rPr sz="3100" b="1">
+                <a:solidFill>
+                  <a:srgbClr val="2563EB"/>
+                </a:solidFill>
+                <a:latin typeface="Aptos"/>
+              </a:rPr>
+              <a:t>3.42 m</a:t>
+            </a:r>
+          </a:p>
+        </p:txBody>
+      </p:sp>
+      <p:sp>
+        <p:nvSpPr>
+          <p:cNvPr id="7" name="TextBox 6"/>
+          <p:cNvSpPr txBox="1"/>
+          <p:nvPr/>
+        </p:nvSpPr>
+        <p:spPr>
+          <a:xfrm>
+            <a:off x="758952" y="2313432"/>
+            <a:ext cx="2093976" cy="228600"/>
+          </a:xfrm>
+          <a:prstGeom prst="rect">
+            <a:avLst/>
+          </a:prstGeom>
+          <a:noFill/>
+        </p:spPr>
+        <p:txBody>
+          <a:bodyPr wrap="square" lIns="18288" rIns="18288" tIns="18288" bIns="18288">
+            <a:spAutoFit/>
+          </a:bodyPr>
+          <a:lstStyle/>
+          <a:p>
+            <a:r>
+              <a:rPr sz="1300" b="0">
+                <a:solidFill>
+                  <a:srgbClr val="475569"/>
+                </a:solidFill>
+                <a:latin typeface="Aptos"/>
+              </a:rPr>
+              <a:t>vs 2.95 m without scene-aware</a:t>
+            </a:r>
+          </a:p>
+        </p:txBody>
+      </p:sp>
+      <p:sp>
+        <p:nvSpPr>
+          <p:cNvPr id="8" name="Rounded Rectangle 7"/>
+          <p:cNvSpPr/>
+          <p:nvPr/>
+        </p:nvSpPr>
+        <p:spPr>
+          <a:xfrm>
+            <a:off x="3246120" y="1417320"/>
+            <a:ext cx="2423160" cy="960120"/>
+          </a:xfrm>
+          <a:prstGeom prst="roundRect">
+            <a:avLst/>
+          </a:prstGeom>
+          <a:solidFill>
+            <a:srgbClr val="FFFFFF"/>
+          </a:solidFill>
+          <a:ln w="12700">
+            <a:solidFill>
+              <a:srgbClr val="CBD5E1"/>
+            </a:solidFill>
+          </a:ln>
+        </p:spPr>
+        <p:style>
+          <a:lnRef idx="1">
+            <a:schemeClr val="accent1"/>
+          </a:lnRef>
+          <a:fillRef idx="3">
+            <a:schemeClr val="accent1"/>
+          </a:fillRef>
+          <a:effectRef idx="2">
+            <a:schemeClr val="accent1"/>
+          </a:effectRef>
+          <a:fontRef idx="minor">
+            <a:schemeClr val="lt1"/>
+          </a:fontRef>
+        </p:style>
+        <p:txBody>
+          <a:bodyPr rtlCol="0" anchor="ctr"/>
+          <a:lstStyle/>
+          <a:p>
+            <a:pPr algn="ctr"/>
+          </a:p>
+        </p:txBody>
+      </p:sp>
+      <p:sp>
+        <p:nvSpPr>
+          <p:cNvPr id="9" name="TextBox 8"/>
+          <p:cNvSpPr txBox="1"/>
+          <p:nvPr/>
+        </p:nvSpPr>
+        <p:spPr>
+          <a:xfrm>
+            <a:off x="3410712" y="1581912"/>
+            <a:ext cx="2093976" cy="228600"/>
+          </a:xfrm>
+          <a:prstGeom prst="rect">
+            <a:avLst/>
+          </a:prstGeom>
+          <a:noFill/>
+        </p:spPr>
+        <p:txBody>
+          <a:bodyPr wrap="square" lIns="18288" rIns="18288" tIns="18288" bIns="18288">
+            <a:spAutoFit/>
+          </a:bodyPr>
+          <a:lstStyle/>
+          <a:p>
+            <a:r>
+              <a:rPr sz="1500" b="1">
+                <a:solidFill>
+                  <a:srgbClr val="475569"/>
+                </a:solidFill>
+                <a:latin typeface="Aptos"/>
+              </a:rPr>
+              <a:t>Avg right shift</a:t>
+            </a:r>
+          </a:p>
+        </p:txBody>
+      </p:sp>
+      <p:sp>
+        <p:nvSpPr>
+          <p:cNvPr id="10" name="TextBox 9"/>
+          <p:cNvSpPr txBox="1"/>
+          <p:nvPr/>
+        </p:nvSpPr>
+        <p:spPr>
+          <a:xfrm>
+            <a:off x="3410712" y="1856232"/>
+            <a:ext cx="2093976" cy="411480"/>
+          </a:xfrm>
+          <a:prstGeom prst="rect">
+            <a:avLst/>
+          </a:prstGeom>
+          <a:noFill/>
+        </p:spPr>
+        <p:txBody>
+          <a:bodyPr wrap="square" lIns="18288" rIns="18288" tIns="18288" bIns="18288">
+            <a:spAutoFit/>
+          </a:bodyPr>
+          <a:lstStyle/>
+          <a:p>
+            <a:r>
+              <a:rPr sz="3100" b="1">
+                <a:solidFill>
+                  <a:srgbClr val="059669"/>
+                </a:solidFill>
+                <a:latin typeface="Aptos"/>
+              </a:rPr>
+              <a:t>0.95 m</a:t>
+            </a:r>
+          </a:p>
+        </p:txBody>
+      </p:sp>
+      <p:sp>
+        <p:nvSpPr>
+          <p:cNvPr id="11" name="TextBox 10"/>
+          <p:cNvSpPr txBox="1"/>
+          <p:nvPr/>
+        </p:nvSpPr>
+        <p:spPr>
+          <a:xfrm>
+            <a:off x="3410712" y="2313432"/>
+            <a:ext cx="2093976" cy="228600"/>
+          </a:xfrm>
+          <a:prstGeom prst="rect">
+            <a:avLst/>
+          </a:prstGeom>
+          <a:noFill/>
+        </p:spPr>
+        <p:txBody>
+          <a:bodyPr wrap="square" lIns="18288" rIns="18288" tIns="18288" bIns="18288">
+            <a:spAutoFit/>
+          </a:bodyPr>
+          <a:lstStyle/>
+          <a:p>
+            <a:r>
+              <a:rPr sz="1300" b="0">
+                <a:solidFill>
+                  <a:srgbClr val="475569"/>
+                </a:solidFill>
+                <a:latin typeface="Aptos"/>
+              </a:rPr>
+              <a:t>vs 0.61 m without scene-aware</a:t>
+            </a:r>
+          </a:p>
+        </p:txBody>
+      </p:sp>
+      <p:sp>
+        <p:nvSpPr>
+          <p:cNvPr id="12" name="Rounded Rectangle 11"/>
+          <p:cNvSpPr/>
+          <p:nvPr/>
+        </p:nvSpPr>
+        <p:spPr>
+          <a:xfrm>
+            <a:off x="5897880" y="1417320"/>
+            <a:ext cx="2423160" cy="960120"/>
+          </a:xfrm>
+          <a:prstGeom prst="roundRect">
+            <a:avLst/>
+          </a:prstGeom>
+          <a:solidFill>
+            <a:srgbClr val="FFFFFF"/>
+          </a:solidFill>
+          <a:ln w="12700">
+            <a:solidFill>
+              <a:srgbClr val="CBD5E1"/>
+            </a:solidFill>
+          </a:ln>
+        </p:spPr>
+        <p:style>
+          <a:lnRef idx="1">
+            <a:schemeClr val="accent1"/>
+          </a:lnRef>
+          <a:fillRef idx="3">
+            <a:schemeClr val="accent1"/>
+          </a:fillRef>
+          <a:effectRef idx="2">
+            <a:schemeClr val="accent1"/>
+          </a:effectRef>
+          <a:fontRef idx="minor">
+            <a:schemeClr val="lt1"/>
+          </a:fontRef>
+        </p:style>
+        <p:txBody>
+          <a:bodyPr rtlCol="0" anchor="ctr"/>
+          <a:lstStyle/>
+          <a:p>
+            <a:pPr algn="ctr"/>
+          </a:p>
+        </p:txBody>
+      </p:sp>
+      <p:sp>
+        <p:nvSpPr>
+          <p:cNvPr id="13" name="TextBox 12"/>
+          <p:cNvSpPr txBox="1"/>
+          <p:nvPr/>
+        </p:nvSpPr>
+        <p:spPr>
+          <a:xfrm>
+            <a:off x="6062472" y="1581912"/>
+            <a:ext cx="2093976" cy="228600"/>
+          </a:xfrm>
+          <a:prstGeom prst="rect">
+            <a:avLst/>
+          </a:prstGeom>
+          <a:noFill/>
+        </p:spPr>
+        <p:txBody>
+          <a:bodyPr wrap="square" lIns="18288" rIns="18288" tIns="18288" bIns="18288">
+            <a:spAutoFit/>
+          </a:bodyPr>
+          <a:lstStyle/>
+          <a:p>
+            <a:r>
+              <a:rPr sz="1500" b="1">
+                <a:solidFill>
+                  <a:srgbClr val="475569"/>
+                </a:solidFill>
+                <a:latin typeface="Aptos"/>
+              </a:rPr>
+              <a:t>Strong cases</a:t>
+            </a:r>
+          </a:p>
+        </p:txBody>
+      </p:sp>
+      <p:sp>
+        <p:nvSpPr>
+          <p:cNvPr id="14" name="TextBox 13"/>
+          <p:cNvSpPr txBox="1"/>
+          <p:nvPr/>
+        </p:nvSpPr>
+        <p:spPr>
+          <a:xfrm>
+            <a:off x="6062472" y="1856232"/>
+            <a:ext cx="2093976" cy="411480"/>
+          </a:xfrm>
+          <a:prstGeom prst="rect">
+            <a:avLst/>
+          </a:prstGeom>
+          <a:noFill/>
+        </p:spPr>
+        <p:txBody>
+          <a:bodyPr wrap="square" lIns="18288" rIns="18288" tIns="18288" bIns="18288">
+            <a:spAutoFit/>
+          </a:bodyPr>
+          <a:lstStyle/>
+          <a:p>
+            <a:r>
+              <a:rPr sz="3100" b="1">
+                <a:solidFill>
+                  <a:srgbClr val="D97706"/>
+                </a:solidFill>
+                <a:latin typeface="Aptos"/>
+              </a:rPr>
+              <a:t>2 / 5</a:t>
+            </a:r>
+          </a:p>
+        </p:txBody>
+      </p:sp>
+      <p:sp>
+        <p:nvSpPr>
+          <p:cNvPr id="15" name="TextBox 14"/>
+          <p:cNvSpPr txBox="1"/>
+          <p:nvPr/>
+        </p:nvSpPr>
+        <p:spPr>
+          <a:xfrm>
+            <a:off x="6062472" y="2313432"/>
+            <a:ext cx="2093976" cy="228600"/>
+          </a:xfrm>
+          <a:prstGeom prst="rect">
+            <a:avLst/>
+          </a:prstGeom>
+          <a:noFill/>
+        </p:spPr>
+        <p:txBody>
+          <a:bodyPr wrap="square" lIns="18288" rIns="18288" tIns="18288" bIns="18288">
+            <a:spAutoFit/>
+          </a:bodyPr>
+          <a:lstStyle/>
+          <a:p>
+            <a:r>
+              <a:rPr sz="1300" b="0">
+                <a:solidFill>
+                  <a:srgbClr val="475569"/>
+                </a:solidFill>
+                <a:latin typeface="Aptos"/>
+              </a:rPr>
+              <a:t>final shift &gt; 3 m</a:t>
+            </a:r>
+          </a:p>
+        </p:txBody>
+      </p:sp>
+      <p:sp>
+        <p:nvSpPr>
+          <p:cNvPr id="16" name="Rounded Rectangle 15"/>
+          <p:cNvSpPr/>
+          <p:nvPr/>
+        </p:nvSpPr>
+        <p:spPr>
+          <a:xfrm>
+            <a:off x="8549640" y="1417320"/>
+            <a:ext cx="2423160" cy="960120"/>
+          </a:xfrm>
+          <a:prstGeom prst="roundRect">
+            <a:avLst/>
+          </a:prstGeom>
+          <a:solidFill>
+            <a:srgbClr val="FFFFFF"/>
+          </a:solidFill>
+          <a:ln w="12700">
+            <a:solidFill>
+              <a:srgbClr val="CBD5E1"/>
+            </a:solidFill>
+          </a:ln>
+        </p:spPr>
+        <p:style>
+          <a:lnRef idx="1">
+            <a:schemeClr val="accent1"/>
+          </a:lnRef>
+          <a:fillRef idx="3">
+            <a:schemeClr val="accent1"/>
+          </a:fillRef>
+          <a:effectRef idx="2">
+            <a:schemeClr val="accent1"/>
+          </a:effectRef>
+          <a:fontRef idx="minor">
+            <a:schemeClr val="lt1"/>
+          </a:fontRef>
+        </p:style>
+        <p:txBody>
+          <a:bodyPr rtlCol="0" anchor="ctr"/>
+          <a:lstStyle/>
+          <a:p>
+            <a:pPr algn="ctr"/>
+          </a:p>
+        </p:txBody>
+      </p:sp>
+      <p:sp>
+        <p:nvSpPr>
+          <p:cNvPr id="17" name="TextBox 16"/>
+          <p:cNvSpPr txBox="1"/>
+          <p:nvPr/>
+        </p:nvSpPr>
+        <p:spPr>
+          <a:xfrm>
+            <a:off x="8714232" y="1581912"/>
+            <a:ext cx="2093976" cy="228600"/>
+          </a:xfrm>
+          <a:prstGeom prst="rect">
+            <a:avLst/>
+          </a:prstGeom>
+          <a:noFill/>
+        </p:spPr>
+        <p:txBody>
+          <a:bodyPr wrap="square" lIns="18288" rIns="18288" tIns="18288" bIns="18288">
+            <a:spAutoFit/>
+          </a:bodyPr>
+          <a:lstStyle/>
+          <a:p>
+            <a:r>
+              <a:rPr sz="1500" b="1">
+                <a:solidFill>
+                  <a:srgbClr val="475569"/>
+                </a:solidFill>
+                <a:latin typeface="Aptos"/>
+              </a:rPr>
+              <a:t>Best case</a:t>
+            </a:r>
+          </a:p>
+        </p:txBody>
+      </p:sp>
+      <p:sp>
+        <p:nvSpPr>
+          <p:cNvPr id="18" name="TextBox 17"/>
+          <p:cNvSpPr txBox="1"/>
+          <p:nvPr/>
+        </p:nvSpPr>
+        <p:spPr>
+          <a:xfrm>
+            <a:off x="8714232" y="1856232"/>
+            <a:ext cx="2093976" cy="411480"/>
+          </a:xfrm>
+          <a:prstGeom prst="rect">
+            <a:avLst/>
+          </a:prstGeom>
+          <a:noFill/>
+        </p:spPr>
+        <p:txBody>
+          <a:bodyPr wrap="square" lIns="18288" rIns="18288" tIns="18288" bIns="18288">
+            <a:spAutoFit/>
+          </a:bodyPr>
+          <a:lstStyle/>
+          <a:p>
+            <a:r>
+              <a:rPr sz="3100" b="1">
+                <a:solidFill>
+                  <a:srgbClr val="DC2626"/>
+                </a:solidFill>
+                <a:latin typeface="Aptos"/>
+              </a:rPr>
+              <a:t>9.25 m</a:t>
+            </a:r>
+          </a:p>
+        </p:txBody>
+      </p:sp>
+      <p:sp>
+        <p:nvSpPr>
+          <p:cNvPr id="19" name="TextBox 18"/>
+          <p:cNvSpPr txBox="1"/>
+          <p:nvPr/>
+        </p:nvSpPr>
+        <p:spPr>
+          <a:xfrm>
+            <a:off x="8714232" y="2313432"/>
+            <a:ext cx="2093976" cy="228600"/>
+          </a:xfrm>
+          <a:prstGeom prst="rect">
+            <a:avLst/>
+          </a:prstGeom>
+          <a:noFill/>
+        </p:spPr>
+        <p:txBody>
+          <a:bodyPr wrap="square" lIns="18288" rIns="18288" tIns="18288" bIns="18288">
+            <a:spAutoFit/>
+          </a:bodyPr>
+          <a:lstStyle/>
+          <a:p>
+            <a:r>
+              <a:rPr sz="1300" b="0">
+                <a:solidFill>
+                  <a:srgbClr val="475569"/>
+                </a:solidFill>
+                <a:latin typeface="Aptos"/>
+              </a:rPr>
+              <a:t>final shift, 3.19 m right</a:t>
+            </a:r>
+          </a:p>
+        </p:txBody>
+      </p:sp>
+      <p:sp>
+        <p:nvSpPr>
+          <p:cNvPr id="20" name="Rounded Rectangle 19"/>
+          <p:cNvSpPr/>
+          <p:nvPr/>
+        </p:nvSpPr>
+        <p:spPr>
+          <a:xfrm>
+            <a:off x="594360" y="2788920"/>
+            <a:ext cx="5440680" cy="3154680"/>
+          </a:xfrm>
+          <a:prstGeom prst="roundRect">
+            <a:avLst/>
+          </a:prstGeom>
+          <a:solidFill>
+            <a:srgbClr val="FFFFFF"/>
+          </a:solidFill>
+          <a:ln w="12700">
+            <a:solidFill>
+              <a:srgbClr val="CBD5E1"/>
+            </a:solidFill>
+          </a:ln>
+        </p:spPr>
+        <p:style>
+          <a:lnRef idx="1">
+            <a:schemeClr val="accent1"/>
+          </a:lnRef>
+          <a:fillRef idx="3">
+            <a:schemeClr val="accent1"/>
+          </a:fillRef>
+          <a:effectRef idx="2">
+            <a:schemeClr val="accent1"/>
+          </a:effectRef>
+          <a:fontRef idx="minor">
+            <a:schemeClr val="lt1"/>
+          </a:fontRef>
+        </p:style>
+        <p:txBody>
+          <a:bodyPr rtlCol="0" anchor="ctr"/>
+          <a:lstStyle/>
+          <a:p>
+            <a:pPr algn="ctr"/>
+          </a:p>
+        </p:txBody>
+      </p:sp>
+      <p:sp>
+        <p:nvSpPr>
+          <p:cNvPr id="21" name="TextBox 20"/>
+          <p:cNvSpPr txBox="1"/>
+          <p:nvPr/>
+        </p:nvSpPr>
+        <p:spPr>
+          <a:xfrm>
+            <a:off x="841248" y="3063240"/>
+            <a:ext cx="4297680" cy="320040"/>
+          </a:xfrm>
+          <a:prstGeom prst="rect">
+            <a:avLst/>
+          </a:prstGeom>
+          <a:noFill/>
+        </p:spPr>
+        <p:txBody>
+          <a:bodyPr wrap="square" lIns="18288" rIns="18288" tIns="18288" bIns="18288">
+            <a:spAutoFit/>
+          </a:bodyPr>
+          <a:lstStyle/>
+          <a:p>
+            <a:r>
+              <a:rPr sz="2200" b="1">
+                <a:solidFill>
+                  <a:srgbClr val="0F172A"/>
+                </a:solidFill>
+                <a:latin typeface="Aptos"/>
+              </a:rPr>
+              <a:t>Best case: horizon-center patch</a:t>
+            </a:r>
+          </a:p>
+        </p:txBody>
+      </p:sp>
       <p:pic>
         <p:nvPicPr>
-          <p:cNvPr id="2" name="Picture 1" descr="slide_02.png"/>
+          <p:cNvPr id="22" name="Picture 21" descr="best_traj.jpg"/>
           <p:cNvPicPr>
             <a:picLocks noChangeAspect="1"/>
           </p:cNvPicPr>
@@ -3637,14 +5350,264 @@
         </p:blipFill>
         <p:spPr>
           <a:xfrm>
-            <a:off x="0" y="0"/>
-            <a:ext cx="12191999" cy="6858000"/>
+            <a:off x="822960" y="3657600"/>
+            <a:ext cx="4983480" cy="1943557"/>
           </a:xfrm>
           <a:prstGeom prst="rect">
             <a:avLst/>
           </a:prstGeom>
         </p:spPr>
       </p:pic>
+      <p:sp>
+        <p:nvSpPr>
+          <p:cNvPr id="23" name="TextBox 22"/>
+          <p:cNvSpPr txBox="1"/>
+          <p:nvPr/>
+        </p:nvSpPr>
+        <p:spPr>
+          <a:xfrm>
+            <a:off x="841248" y="5532120"/>
+            <a:ext cx="4389120" cy="228600"/>
+          </a:xfrm>
+          <a:prstGeom prst="rect">
+            <a:avLst/>
+          </a:prstGeom>
+          <a:noFill/>
+        </p:spPr>
+        <p:txBody>
+          <a:bodyPr wrap="square" lIns="18288" rIns="18288" tIns="18288" bIns="18288">
+            <a:spAutoFit/>
+          </a:bodyPr>
+          <a:lstStyle/>
+          <a:p>
+            <a:r>
+              <a:rPr sz="1400" b="0">
+                <a:solidFill>
+                  <a:srgbClr val="475569"/>
+                </a:solidFill>
+                <a:latin typeface="Aptos"/>
+              </a:rPr>
+              <a:t>Token 01bbf47b: final 9.25 m, right +3.19 m</a:t>
+            </a:r>
+          </a:p>
+        </p:txBody>
+      </p:sp>
+      <p:sp>
+        <p:nvSpPr>
+          <p:cNvPr id="24" name="Rounded Rectangle 23"/>
+          <p:cNvSpPr/>
+          <p:nvPr/>
+        </p:nvSpPr>
+        <p:spPr>
+          <a:xfrm>
+            <a:off x="6446520" y="2788920"/>
+            <a:ext cx="5166360" cy="3154680"/>
+          </a:xfrm>
+          <a:prstGeom prst="roundRect">
+            <a:avLst/>
+          </a:prstGeom>
+          <a:solidFill>
+            <a:srgbClr val="FFFFFF"/>
+          </a:solidFill>
+          <a:ln w="12700">
+            <a:solidFill>
+              <a:srgbClr val="CBD5E1"/>
+            </a:solidFill>
+          </a:ln>
+        </p:spPr>
+        <p:style>
+          <a:lnRef idx="1">
+            <a:schemeClr val="accent1"/>
+          </a:lnRef>
+          <a:fillRef idx="3">
+            <a:schemeClr val="accent1"/>
+          </a:fillRef>
+          <a:effectRef idx="2">
+            <a:schemeClr val="accent1"/>
+          </a:effectRef>
+          <a:fontRef idx="minor">
+            <a:schemeClr val="lt1"/>
+          </a:fontRef>
+        </p:style>
+        <p:txBody>
+          <a:bodyPr rtlCol="0" anchor="ctr"/>
+          <a:lstStyle/>
+          <a:p>
+            <a:pPr algn="ctr"/>
+          </a:p>
+        </p:txBody>
+      </p:sp>
+      <p:sp>
+        <p:nvSpPr>
+          <p:cNvPr id="25" name="TextBox 24"/>
+          <p:cNvSpPr txBox="1"/>
+          <p:nvPr/>
+        </p:nvSpPr>
+        <p:spPr>
+          <a:xfrm>
+            <a:off x="6693408" y="3063240"/>
+            <a:ext cx="4389120" cy="320040"/>
+          </a:xfrm>
+          <a:prstGeom prst="rect">
+            <a:avLst/>
+          </a:prstGeom>
+          <a:noFill/>
+        </p:spPr>
+        <p:txBody>
+          <a:bodyPr wrap="square" lIns="18288" rIns="18288" tIns="18288" bIns="18288">
+            <a:spAutoFit/>
+          </a:bodyPr>
+          <a:lstStyle/>
+          <a:p>
+            <a:r>
+              <a:rPr sz="2200" b="1">
+                <a:solidFill>
+                  <a:srgbClr val="0F172A"/>
+                </a:solidFill>
+                <a:latin typeface="Aptos"/>
+              </a:rPr>
+              <a:t>Scene-aware gain: construction cue</a:t>
+            </a:r>
+          </a:p>
+        </p:txBody>
+      </p:sp>
+      <p:pic>
+        <p:nvPicPr>
+          <p:cNvPr id="26" name="Picture 25" descr="sceneaware_traj.jpg"/>
+          <p:cNvPicPr>
+            <a:picLocks noChangeAspect="1"/>
+          </p:cNvPicPr>
+          <p:nvPr/>
+        </p:nvPicPr>
+        <p:blipFill>
+          <a:blip r:embed="rId3"/>
+          <a:stretch>
+            <a:fillRect/>
+          </a:stretch>
+        </p:blipFill>
+        <p:spPr>
+          <a:xfrm>
+            <a:off x="6675120" y="3657600"/>
+            <a:ext cx="4709160" cy="1836572"/>
+          </a:xfrm>
+          <a:prstGeom prst="rect">
+            <a:avLst/>
+          </a:prstGeom>
+        </p:spPr>
+      </p:pic>
+      <p:sp>
+        <p:nvSpPr>
+          <p:cNvPr id="27" name="TextBox 26"/>
+          <p:cNvSpPr txBox="1"/>
+          <p:nvPr/>
+        </p:nvSpPr>
+        <p:spPr>
+          <a:xfrm>
+            <a:off x="6693408" y="5532120"/>
+            <a:ext cx="4480560" cy="228600"/>
+          </a:xfrm>
+          <a:prstGeom prst="rect">
+            <a:avLst/>
+          </a:prstGeom>
+          <a:noFill/>
+        </p:spPr>
+        <p:txBody>
+          <a:bodyPr wrap="square" lIns="18288" rIns="18288" tIns="18288" bIns="18288">
+            <a:spAutoFit/>
+          </a:bodyPr>
+          <a:lstStyle/>
+          <a:p>
+            <a:r>
+              <a:rPr sz="1400" b="0">
+                <a:solidFill>
+                  <a:srgbClr val="475569"/>
+                </a:solidFill>
+                <a:latin typeface="Aptos"/>
+              </a:rPr>
+              <a:t>Token 01a7d01c: scene-aware improves final 1.31 m -&gt; 3.69 m</a:t>
+            </a:r>
+          </a:p>
+        </p:txBody>
+      </p:sp>
+      <p:sp>
+        <p:nvSpPr>
+          <p:cNvPr id="28" name="Rounded Rectangle 27"/>
+          <p:cNvSpPr/>
+          <p:nvPr/>
+        </p:nvSpPr>
+        <p:spPr>
+          <a:xfrm>
+            <a:off x="594360" y="6080760"/>
+            <a:ext cx="11018520" cy="429768"/>
+          </a:xfrm>
+          <a:prstGeom prst="roundRect">
+            <a:avLst/>
+          </a:prstGeom>
+          <a:solidFill>
+            <a:srgbClr val="EFF6FF"/>
+          </a:solidFill>
+          <a:ln w="12700">
+            <a:solidFill>
+              <a:srgbClr val="93C5FD"/>
+            </a:solidFill>
+          </a:ln>
+        </p:spPr>
+        <p:style>
+          <a:lnRef idx="1">
+            <a:schemeClr val="accent1"/>
+          </a:lnRef>
+          <a:fillRef idx="3">
+            <a:schemeClr val="accent1"/>
+          </a:fillRef>
+          <a:effectRef idx="2">
+            <a:schemeClr val="accent1"/>
+          </a:effectRef>
+          <a:fontRef idx="minor">
+            <a:schemeClr val="lt1"/>
+          </a:fontRef>
+        </p:style>
+        <p:txBody>
+          <a:bodyPr rtlCol="0" anchor="ctr"/>
+          <a:lstStyle/>
+          <a:p>
+            <a:pPr algn="ctr"/>
+          </a:p>
+        </p:txBody>
+      </p:sp>
+      <p:sp>
+        <p:nvSpPr>
+          <p:cNvPr id="29" name="TextBox 28"/>
+          <p:cNvSpPr txBox="1"/>
+          <p:nvPr/>
+        </p:nvSpPr>
+        <p:spPr>
+          <a:xfrm>
+            <a:off x="777240" y="6181344"/>
+            <a:ext cx="10561320" cy="228600"/>
+          </a:xfrm>
+          <a:prstGeom prst="rect">
+            <a:avLst/>
+          </a:prstGeom>
+          <a:noFill/>
+        </p:spPr>
+        <p:txBody>
+          <a:bodyPr wrap="square" lIns="18288" rIns="18288" tIns="18288" bIns="18288">
+            <a:spAutoFit/>
+          </a:bodyPr>
+          <a:lstStyle/>
+          <a:p>
+            <a:r>
+              <a:rPr sz="1500" b="1">
+                <a:solidFill>
+                  <a:srgbClr val="0F172A"/>
+                </a:solidFill>
+                <a:latin typeface="Aptos"/>
+              </a:rPr>
+              <a:t>Takeaway: scene-aware placement improves targeted lateral shift, but black-box front-only attacks remain inconsistent. Next: object-aware placement for cars, pedestrians, and traffic lights.</a:t>
+            </a:r>
+          </a:p>
+        </p:txBody>
+      </p:sp>
     </p:spTree>
   </p:cSld>
   <p:clrMapOvr>
@@ -3971,324 +5934,4 @@
   </a:objectDefaults>
   <a:extraClrSchemeLst/>
 </a:theme>
-</file>
-
-<file path=ppt/theme/theme2.xml><?xml version="1.0" encoding="utf-8"?>
-<a:theme xmlns:a="http://schemas.openxmlformats.org/drawingml/2006/main" name="Office Theme">
-  <a:themeElements>
-    <a:clrScheme name="Office">
-      <a:dk1>
-        <a:sysClr val="windowText" lastClr="000000"/>
-      </a:dk1>
-      <a:lt1>
-        <a:sysClr val="window" lastClr="FFFFFF"/>
-      </a:lt1>
-      <a:dk2>
-        <a:srgbClr val="1F497D"/>
-      </a:dk2>
-      <a:lt2>
-        <a:srgbClr val="EEECE1"/>
-      </a:lt2>
-      <a:accent1>
-        <a:srgbClr val="4F81BD"/>
-      </a:accent1>
-      <a:accent2>
-        <a:srgbClr val="C0504D"/>
-      </a:accent2>
-      <a:accent3>
-        <a:srgbClr val="9BBB59"/>
-      </a:accent3>
-      <a:accent4>
-        <a:srgbClr val="8064A2"/>
-      </a:accent4>
-      <a:accent5>
-        <a:srgbClr val="4BACC6"/>
-      </a:accent5>
-      <a:accent6>
-        <a:srgbClr val="F79646"/>
-      </a:accent6>
-      <a:hlink>
-        <a:srgbClr val="0000FF"/>
-      </a:hlink>
-      <a:folHlink>
-        <a:srgbClr val="800080"/>
-      </a:folHlink>
-    </a:clrScheme>
-    <a:fontScheme name="Office">
-      <a:majorFont>
-        <a:latin typeface="Calibri"/>
-        <a:ea typeface=""/>
-        <a:cs typeface=""/>
-        <a:font script="Jpan" typeface="ＭＳ Ｐゴシック"/>
-        <a:font script="Hang" typeface="맑은 고딕"/>
-        <a:font script="Hans" typeface="宋体"/>
-        <a:font script="Hant" typeface="新細明體"/>
-        <a:font script="Arab" typeface="Times New Roman"/>
-        <a:font script="Hebr" typeface="Times New Roman"/>
-        <a:font script="Thai" typeface="Angsana New"/>
-        <a:font script="Ethi" typeface="Nyala"/>
-        <a:font script="Beng" typeface="Vrinda"/>
-        <a:font script="Gujr" typeface="Shruti"/>
-        <a:font script="Khmr" typeface="MoolBoran"/>
-        <a:font script="Knda" typeface="Tunga"/>
-        <a:font script="Guru" typeface="Raavi"/>
-        <a:font script="Cans" typeface="Euphemia"/>
-        <a:font script="Cher" typeface="Plantagenet Cherokee"/>
-        <a:font script="Yiii" typeface="Microsoft Yi Baiti"/>
-        <a:font script="Tibt" typeface="Microsoft Himalaya"/>
-        <a:font script="Thaa" typeface="MV Boli"/>
-        <a:font script="Deva" typeface="Mangal"/>
-        <a:font script="Telu" typeface="Gautami"/>
-        <a:font script="Taml" typeface="Latha"/>
-        <a:font script="Syrc" typeface="Estrangelo Edessa"/>
-        <a:font script="Orya" typeface="Kalinga"/>
-        <a:font script="Mlym" typeface="Kartika"/>
-        <a:font script="Laoo" typeface="DokChampa"/>
-        <a:font script="Sinh" typeface="Iskoola Pota"/>
-        <a:font script="Mong" typeface="Mongolian Baiti"/>
-        <a:font script="Viet" typeface="Times New Roman"/>
-        <a:font script="Uigh" typeface="Microsoft Uighur"/>
-        <a:font script="Geor" typeface="Sylfaen"/>
-      </a:majorFont>
-      <a:minorFont>
-        <a:latin typeface="Calibri"/>
-        <a:ea typeface=""/>
-        <a:cs typeface=""/>
-        <a:font script="Jpan" typeface="ＭＳ Ｐゴシック"/>
-        <a:font script="Hang" typeface="맑은 고딕"/>
-        <a:font script="Hans" typeface="宋体"/>
-        <a:font script="Hant" typeface="新細明體"/>
-        <a:font script="Arab" typeface="Arial"/>
-        <a:font script="Hebr" typeface="Arial"/>
-        <a:font script="Thai" typeface="Cordia New"/>
-        <a:font script="Ethi" typeface="Nyala"/>
-        <a:font script="Beng" typeface="Vrinda"/>
-        <a:font script="Gujr" typeface="Shruti"/>
-        <a:font script="Khmr" typeface="DaunPenh"/>
-        <a:font script="Knda" typeface="Tunga"/>
-        <a:font script="Guru" typeface="Raavi"/>
-        <a:font script="Cans" typeface="Euphemia"/>
-        <a:font script="Cher" typeface="Plantagenet Cherokee"/>
-        <a:font script="Yiii" typeface="Microsoft Yi Baiti"/>
-        <a:font script="Tibt" typeface="Microsoft Himalaya"/>
-        <a:font script="Thaa" typeface="MV Boli"/>
-        <a:font script="Deva" typeface="Mangal"/>
-        <a:font script="Telu" typeface="Gautami"/>
-        <a:font script="Taml" typeface="Latha"/>
-        <a:font script="Syrc" typeface="Estrangelo Edessa"/>
-        <a:font script="Orya" typeface="Kalinga"/>
-        <a:font script="Mlym" typeface="Kartika"/>
-        <a:font script="Laoo" typeface="DokChampa"/>
-        <a:font script="Sinh" typeface="Iskoola Pota"/>
-        <a:font script="Mong" typeface="Mongolian Baiti"/>
-        <a:font script="Viet" typeface="Arial"/>
-        <a:font script="Uigh" typeface="Microsoft Uighur"/>
-        <a:font script="Geor" typeface="Sylfaen"/>
-      </a:minorFont>
-    </a:fontScheme>
-    <a:fmtScheme name="Office">
-      <a:fillStyleLst>
-        <a:solidFill>
-          <a:schemeClr val="phClr"/>
-        </a:solidFill>
-        <a:gradFill rotWithShape="1">
-          <a:gsLst>
-            <a:gs pos="0">
-              <a:schemeClr val="phClr">
-                <a:tint val="50000"/>
-                <a:satMod val="300000"/>
-              </a:schemeClr>
-            </a:gs>
-            <a:gs pos="35000">
-              <a:schemeClr val="phClr">
-                <a:tint val="37000"/>
-                <a:satMod val="300000"/>
-              </a:schemeClr>
-            </a:gs>
-            <a:gs pos="100000">
-              <a:schemeClr val="phClr">
-                <a:tint val="15000"/>
-                <a:satMod val="350000"/>
-              </a:schemeClr>
-            </a:gs>
-          </a:gsLst>
-          <a:lin ang="16200000" scaled="1"/>
-        </a:gradFill>
-        <a:gradFill rotWithShape="1">
-          <a:gsLst>
-            <a:gs pos="0">
-              <a:schemeClr val="phClr">
-                <a:tint val="100000"/>
-                <a:shade val="100000"/>
-                <a:satMod val="130000"/>
-              </a:schemeClr>
-            </a:gs>
-            <a:gs pos="100000">
-              <a:schemeClr val="phClr">
-                <a:tint val="50000"/>
-                <a:shade val="100000"/>
-                <a:satMod val="350000"/>
-              </a:schemeClr>
-            </a:gs>
-          </a:gsLst>
-          <a:lin ang="16200000" scaled="0"/>
-        </a:gradFill>
-      </a:fillStyleLst>
-      <a:lnStyleLst>
-        <a:ln w="9525" cap="flat" cmpd="sng" algn="ctr">
-          <a:solidFill>
-            <a:schemeClr val="phClr">
-              <a:shade val="95000"/>
-              <a:satMod val="105000"/>
-            </a:schemeClr>
-          </a:solidFill>
-          <a:prstDash val="solid"/>
-        </a:ln>
-        <a:ln w="25400" cap="flat" cmpd="sng" algn="ctr">
-          <a:solidFill>
-            <a:schemeClr val="phClr"/>
-          </a:solidFill>
-          <a:prstDash val="solid"/>
-        </a:ln>
-        <a:ln w="38100" cap="flat" cmpd="sng" algn="ctr">
-          <a:solidFill>
-            <a:schemeClr val="phClr"/>
-          </a:solidFill>
-          <a:prstDash val="solid"/>
-        </a:ln>
-      </a:lnStyleLst>
-      <a:effectStyleLst>
-        <a:effectStyle>
-          <a:effectLst>
-            <a:outerShdw blurRad="40000" dist="20000" dir="5400000" rotWithShape="0">
-              <a:srgbClr val="000000">
-                <a:alpha val="38000"/>
-              </a:srgbClr>
-            </a:outerShdw>
-          </a:effectLst>
-        </a:effectStyle>
-        <a:effectStyle>
-          <a:effectLst>
-            <a:outerShdw blurRad="40000" dist="23000" dir="5400000" rotWithShape="0">
-              <a:srgbClr val="000000">
-                <a:alpha val="35000"/>
-              </a:srgbClr>
-            </a:outerShdw>
-          </a:effectLst>
-        </a:effectStyle>
-        <a:effectStyle>
-          <a:effectLst>
-            <a:outerShdw blurRad="40000" dist="23000" dir="5400000" rotWithShape="0">
-              <a:srgbClr val="000000">
-                <a:alpha val="35000"/>
-              </a:srgbClr>
-            </a:outerShdw>
-          </a:effectLst>
-          <a:scene3d>
-            <a:camera prst="orthographicFront">
-              <a:rot lat="0" lon="0" rev="0"/>
-            </a:camera>
-            <a:lightRig rig="threePt" dir="t">
-              <a:rot lat="0" lon="0" rev="1200000"/>
-            </a:lightRig>
-          </a:scene3d>
-          <a:sp3d>
-            <a:bevelT w="63500" h="25400"/>
-          </a:sp3d>
-        </a:effectStyle>
-      </a:effectStyleLst>
-      <a:bgFillStyleLst>
-        <a:solidFill>
-          <a:schemeClr val="phClr"/>
-        </a:solidFill>
-        <a:gradFill rotWithShape="1">
-          <a:gsLst>
-            <a:gs pos="0">
-              <a:schemeClr val="phClr">
-                <a:tint val="40000"/>
-                <a:satMod val="350000"/>
-              </a:schemeClr>
-            </a:gs>
-            <a:gs pos="40000">
-              <a:schemeClr val="phClr">
-                <a:tint val="45000"/>
-                <a:shade val="99000"/>
-                <a:satMod val="350000"/>
-              </a:schemeClr>
-            </a:gs>
-            <a:gs pos="100000">
-              <a:schemeClr val="phClr">
-                <a:shade val="20000"/>
-                <a:satMod val="255000"/>
-              </a:schemeClr>
-            </a:gs>
-          </a:gsLst>
-          <a:path path="circle">
-            <a:fillToRect l="50000" t="-80000" r="50000" b="180000"/>
-          </a:path>
-        </a:gradFill>
-        <a:gradFill rotWithShape="1">
-          <a:gsLst>
-            <a:gs pos="0">
-              <a:schemeClr val="phClr">
-                <a:tint val="80000"/>
-                <a:satMod val="300000"/>
-              </a:schemeClr>
-            </a:gs>
-            <a:gs pos="100000">
-              <a:schemeClr val="phClr">
-                <a:shade val="30000"/>
-                <a:satMod val="200000"/>
-              </a:schemeClr>
-            </a:gs>
-          </a:gsLst>
-          <a:path path="circle">
-            <a:fillToRect l="50000" t="50000" r="50000" b="50000"/>
-          </a:path>
-        </a:gradFill>
-      </a:bgFillStyleLst>
-    </a:fmtScheme>
-  </a:themeElements>
-  <a:objectDefaults>
-    <a:spDef>
-      <a:spPr/>
-      <a:bodyPr/>
-      <a:lstStyle/>
-      <a:style>
-        <a:lnRef idx="1">
-          <a:schemeClr val="accent1"/>
-        </a:lnRef>
-        <a:fillRef idx="3">
-          <a:schemeClr val="accent1"/>
-        </a:fillRef>
-        <a:effectRef idx="2">
-          <a:schemeClr val="accent1"/>
-        </a:effectRef>
-        <a:fontRef idx="minor">
-          <a:schemeClr val="lt1"/>
-        </a:fontRef>
-      </a:style>
-    </a:spDef>
-    <a:lnDef>
-      <a:spPr/>
-      <a:bodyPr/>
-      <a:lstStyle/>
-      <a:style>
-        <a:lnRef idx="2">
-          <a:schemeClr val="accent1"/>
-        </a:lnRef>
-        <a:fillRef idx="0">
-          <a:schemeClr val="accent1"/>
-        </a:fillRef>
-        <a:effectRef idx="1">
-          <a:schemeClr val="accent1"/>
-        </a:effectRef>
-        <a:fontRef idx="minor">
-          <a:schemeClr val="tx1"/>
-        </a:fontRef>
-      </a:style>
-    </a:lnDef>
-  </a:objectDefaults>
-  <a:extraClrSchemeLst/>
-</a:theme>
 </file>
</xml_diff>

<commit_message>
Refine AutoVLA attack slides as editable showcases
</commit_message>
<xml_diff>
--- a/report/autovla_blackbox_attack_2slides.pptx
+++ b/report/autovla_blackbox_attack_2slides.pptx
@@ -3105,8 +3105,8 @@
         </p:nvSpPr>
         <p:spPr>
           <a:xfrm>
-            <a:off x="594360" y="384048"/>
-            <a:ext cx="8961120" cy="502920"/>
+            <a:off x="502920" y="292608"/>
+            <a:ext cx="8138160" cy="411480"/>
           </a:xfrm>
           <a:prstGeom prst="rect">
             <a:avLst/>
@@ -3120,13 +3120,13 @@
           <a:lstStyle/>
           <a:p>
             <a:r>
-              <a:rPr sz="3400" b="1">
+              <a:rPr sz="2800" b="1">
                 <a:solidFill>
                   <a:srgbClr val="0F172A"/>
                 </a:solidFill>
                 <a:latin typeface="Aptos"/>
               </a:rPr>
-              <a:t>Black-box Patch Attack on AutoVLA</a:t>
+              <a:t>Showcase 1: Strongest Black-box Patch Effect</a:t>
             </a:r>
           </a:p>
         </p:txBody>
@@ -3139,8 +3139,8 @@
         </p:nvSpPr>
         <p:spPr>
           <a:xfrm>
-            <a:off x="612648" y="896112"/>
-            <a:ext cx="8412480" cy="320040"/>
+            <a:off x="521207" y="749808"/>
+            <a:ext cx="7680960" cy="256032"/>
           </a:xfrm>
           <a:prstGeom prst="rect">
             <a:avLst/>
@@ -3154,13 +3154,13 @@
           <a:lstStyle/>
           <a:p>
             <a:r>
-              <a:rPr sz="1900" b="0">
+              <a:rPr sz="1500" b="0">
                 <a:solidFill>
                   <a:srgbClr val="475569"/>
                 </a:solidFill>
                 <a:latin typeface="Aptos"/>
               </a:rPr>
-              <a:t>Query-only trajectory manipulation on nuScenes front camera inputs</a:t>
+              <a:t>Horizon-center patch on front camera causes a large final trajectory deviation.</a:t>
             </a:r>
           </a:p>
         </p:txBody>
@@ -3173,18 +3173,18 @@
         </p:nvSpPr>
         <p:spPr>
           <a:xfrm>
-            <a:off x="594360" y="1508760"/>
-            <a:ext cx="1783080" cy="1143000"/>
+            <a:off x="502920" y="1078992"/>
+            <a:ext cx="11201400" cy="493776"/>
           </a:xfrm>
           <a:prstGeom prst="roundRect">
             <a:avLst/>
           </a:prstGeom>
           <a:solidFill>
-            <a:srgbClr val="FFFFFF"/>
+            <a:srgbClr val="EFF6FF"/>
           </a:solidFill>
           <a:ln w="12700">
             <a:solidFill>
-              <a:srgbClr val="CBD5E1"/>
+              <a:srgbClr val="BFDBFE"/>
             </a:solidFill>
           </a:ln>
         </p:spPr>
@@ -3212,24 +3212,58 @@
       </p:sp>
       <p:sp>
         <p:nvSpPr>
-          <p:cNvPr id="5" name="Oval 4"/>
+          <p:cNvPr id="5" name="TextBox 4"/>
+          <p:cNvSpPr txBox="1"/>
+          <p:nvPr/>
+        </p:nvSpPr>
+        <p:spPr>
+          <a:xfrm>
+            <a:off x="713232" y="1234440"/>
+            <a:ext cx="10607040" cy="201168"/>
+          </a:xfrm>
+          <a:prstGeom prst="rect">
+            <a:avLst/>
+          </a:prstGeom>
+          <a:noFill/>
+        </p:spPr>
+        <p:txBody>
+          <a:bodyPr wrap="square" lIns="18288" rIns="18288" tIns="18288" bIns="18288">
+            <a:spAutoFit/>
+          </a:bodyPr>
+          <a:lstStyle/>
+          <a:p>
+            <a:r>
+              <a:rPr sz="1300" b="1">
+                <a:solidFill>
+                  <a:srgbClr val="0F172A"/>
+                </a:solidFill>
+                <a:latin typeface="Aptos"/>
+              </a:rPr>
+              <a:t>Black-box: front camera only | no gradients | position sweep | trajectory-shift objective</a:t>
+            </a:r>
+          </a:p>
+        </p:txBody>
+      </p:sp>
+      <p:sp>
+        <p:nvSpPr>
+          <p:cNvPr id="6" name="Rounded Rectangle 5"/>
           <p:cNvSpPr/>
           <p:nvPr/>
         </p:nvSpPr>
         <p:spPr>
           <a:xfrm>
-            <a:off x="740664" y="1673351"/>
-            <a:ext cx="347472" cy="347472"/>
-          </a:xfrm>
-          <a:prstGeom prst="ellipse">
+            <a:off x="502920" y="1783080"/>
+            <a:ext cx="6903720" cy="2788920"/>
+          </a:xfrm>
+          <a:prstGeom prst="roundRect">
             <a:avLst/>
           </a:prstGeom>
           <a:solidFill>
-            <a:srgbClr val="2563EB"/>
+            <a:srgbClr val="FFFFFF"/>
           </a:solidFill>
-          <a:ln>
+          <a:ln w="12700">
             <a:solidFill>
-              <a:srgbClr val="2563EB"/>
+              <a:srgbClr val="CBD5E1"/>
             </a:solidFill>
           </a:ln>
         </p:spPr>
@@ -3255,16 +3289,40 @@
           </a:p>
         </p:txBody>
       </p:sp>
-      <p:sp>
-        <p:nvSpPr>
-          <p:cNvPr id="6" name="TextBox 5"/>
+      <p:pic>
+        <p:nvPicPr>
+          <p:cNvPr id="7" name="Picture 6" descr="01bbf47b_inputs.jpg"/>
+          <p:cNvPicPr>
+            <a:picLocks noChangeAspect="1"/>
+          </p:cNvPicPr>
+          <p:nvPr/>
+        </p:nvPicPr>
+        <p:blipFill>
+          <a:blip r:embed="rId2"/>
+          <a:stretch>
+            <a:fillRect/>
+          </a:stretch>
+        </p:blipFill>
+        <p:spPr>
+          <a:xfrm>
+            <a:off x="658368" y="1993392"/>
+            <a:ext cx="6601968" cy="2096024"/>
+          </a:xfrm>
+          <a:prstGeom prst="rect">
+            <a:avLst/>
+          </a:prstGeom>
+        </p:spPr>
+      </p:pic>
+      <p:sp>
+        <p:nvSpPr>
+          <p:cNvPr id="8" name="TextBox 7"/>
           <p:cNvSpPr txBox="1"/>
           <p:nvPr/>
         </p:nvSpPr>
         <p:spPr>
           <a:xfrm>
-            <a:off x="850392" y="1723643"/>
-            <a:ext cx="182880" cy="164592"/>
+            <a:off x="658368" y="4315968"/>
+            <a:ext cx="6583680" cy="201168"/>
           </a:xfrm>
           <a:prstGeom prst="rect">
             <a:avLst/>
@@ -3277,132 +3335,28 @@
           </a:bodyPr>
           <a:lstStyle/>
           <a:p>
-            <a:pPr algn="ctr"/>
-            <a:r>
-              <a:rPr sz="1700" b="1">
-                <a:solidFill>
-                  <a:srgbClr val="FFFFFF"/>
-                </a:solidFill>
-                <a:latin typeface="Aptos"/>
-              </a:rPr>
-              <a:t>1</a:t>
-            </a:r>
-          </a:p>
-        </p:txBody>
-      </p:sp>
-      <p:sp>
-        <p:nvSpPr>
-          <p:cNvPr id="7" name="TextBox 6"/>
-          <p:cNvSpPr txBox="1"/>
-          <p:nvPr/>
-        </p:nvSpPr>
-        <p:spPr>
-          <a:xfrm>
-            <a:off x="758952" y="2130552"/>
-            <a:ext cx="1417320" cy="219456"/>
-          </a:xfrm>
-          <a:prstGeom prst="rect">
-            <a:avLst/>
-          </a:prstGeom>
-          <a:noFill/>
-        </p:spPr>
-        <p:txBody>
-          <a:bodyPr wrap="square" lIns="18288" rIns="18288" tIns="18288" bIns="18288">
-            <a:spAutoFit/>
-          </a:bodyPr>
-          <a:lstStyle/>
-          <a:p>
-            <a:r>
-              <a:rPr sz="1600" b="1">
-                <a:solidFill>
-                  <a:srgbClr val="0F172A"/>
-                </a:solidFill>
-                <a:latin typeface="Aptos"/>
-              </a:rPr>
-              <a:t>Clean AutoVLA</a:t>
-            </a:r>
-          </a:p>
-        </p:txBody>
-      </p:sp>
-      <p:sp>
-        <p:nvSpPr>
-          <p:cNvPr id="8" name="TextBox 7"/>
-          <p:cNvSpPr txBox="1"/>
-          <p:nvPr/>
-        </p:nvSpPr>
-        <p:spPr>
-          <a:xfrm>
-            <a:off x="758952" y="2377439"/>
-            <a:ext cx="1417320" cy="256032"/>
-          </a:xfrm>
-          <a:prstGeom prst="rect">
-            <a:avLst/>
-          </a:prstGeom>
-          <a:noFill/>
-        </p:spPr>
-        <p:txBody>
-          <a:bodyPr wrap="square" lIns="18288" rIns="18288" tIns="18288" bIns="18288">
-            <a:spAutoFit/>
-          </a:bodyPr>
-          <a:lstStyle/>
-          <a:p>
-            <a:r>
-              <a:rPr sz="1300" b="0">
+            <a:r>
+              <a:rPr sz="1200" b="0">
                 <a:solidFill>
                   <a:srgbClr val="475569"/>
                 </a:solidFill>
                 <a:latin typeface="Aptos"/>
               </a:rPr>
-              <a:t>decode clean trajectory</a:t>
-            </a:r>
-          </a:p>
-        </p:txBody>
-      </p:sp>
-      <p:cxnSp>
-        <p:nvCxnSpPr>
-          <p:cNvPr id="9" name="Connector 8"/>
-          <p:cNvCxnSpPr/>
-          <p:nvPr/>
-        </p:nvCxnSpPr>
-        <p:spPr>
-          <a:xfrm>
-            <a:off x="2404872" y="2075688"/>
-            <a:ext cx="310896" cy="0"/>
-          </a:xfrm>
-          <a:prstGeom prst="line">
-            <a:avLst/>
-          </a:prstGeom>
-          <a:ln w="27940">
-            <a:solidFill>
-              <a:srgbClr val="2563EB"/>
-            </a:solidFill>
-          </a:ln>
-        </p:spPr>
-        <p:style>
-          <a:lnRef idx="2">
-            <a:schemeClr val="accent1"/>
-          </a:lnRef>
-          <a:fillRef idx="0">
-            <a:schemeClr val="accent1"/>
-          </a:fillRef>
-          <a:effectRef idx="1">
-            <a:schemeClr val="accent1"/>
-          </a:effectRef>
-          <a:fontRef idx="minor">
-            <a:schemeClr val="tx1"/>
-          </a:fontRef>
-        </p:style>
-      </p:cxnSp>
-      <p:sp>
-        <p:nvSpPr>
-          <p:cNvPr id="10" name="Rounded Rectangle 9"/>
+              <a:t>Input observation: clean front image vs patched front image</a:t>
+            </a:r>
+          </a:p>
+        </p:txBody>
+      </p:sp>
+      <p:sp>
+        <p:nvSpPr>
+          <p:cNvPr id="9" name="Rounded Rectangle 8"/>
           <p:cNvSpPr/>
           <p:nvPr/>
         </p:nvSpPr>
         <p:spPr>
           <a:xfrm>
-            <a:off x="2788920" y="1508760"/>
-            <a:ext cx="1783080" cy="1143000"/>
+            <a:off x="7635240" y="1783080"/>
+            <a:ext cx="4069080" cy="4160520"/>
           </a:xfrm>
           <a:prstGeom prst="roundRect">
             <a:avLst/>
@@ -3438,26 +3392,85 @@
           </a:p>
         </p:txBody>
       </p:sp>
-      <p:sp>
-        <p:nvSpPr>
-          <p:cNvPr id="11" name="Oval 10"/>
+      <p:pic>
+        <p:nvPicPr>
+          <p:cNvPr id="10" name="Picture 9" descr="01bbf47b_traj_overlay.png"/>
+          <p:cNvPicPr>
+            <a:picLocks noChangeAspect="1"/>
+          </p:cNvPicPr>
+          <p:nvPr/>
+        </p:nvPicPr>
+        <p:blipFill>
+          <a:blip r:embed="rId3"/>
+          <a:stretch>
+            <a:fillRect/>
+          </a:stretch>
+        </p:blipFill>
+        <p:spPr>
+          <a:xfrm>
+            <a:off x="7982712" y="1993392"/>
+            <a:ext cx="2725042" cy="3493008"/>
+          </a:xfrm>
+          <a:prstGeom prst="rect">
+            <a:avLst/>
+          </a:prstGeom>
+        </p:spPr>
+      </p:pic>
+      <p:sp>
+        <p:nvSpPr>
+          <p:cNvPr id="11" name="TextBox 10"/>
+          <p:cNvSpPr txBox="1"/>
+          <p:nvPr/>
+        </p:nvSpPr>
+        <p:spPr>
+          <a:xfrm>
+            <a:off x="7891272" y="5559552"/>
+            <a:ext cx="3566160" cy="201168"/>
+          </a:xfrm>
+          <a:prstGeom prst="rect">
+            <a:avLst/>
+          </a:prstGeom>
+          <a:noFill/>
+        </p:spPr>
+        <p:txBody>
+          <a:bodyPr wrap="square" lIns="18288" rIns="18288" tIns="18288" bIns="18288">
+            <a:spAutoFit/>
+          </a:bodyPr>
+          <a:lstStyle/>
+          <a:p>
+            <a:pPr algn="ctr"/>
+            <a:r>
+              <a:rPr sz="1200" b="0">
+                <a:solidFill>
+                  <a:srgbClr val="475569"/>
+                </a:solidFill>
+                <a:latin typeface="Aptos"/>
+              </a:rPr>
+              <a:t>Trajectory overlay: GT / clean pred / attacked pred</a:t>
+            </a:r>
+          </a:p>
+        </p:txBody>
+      </p:sp>
+      <p:sp>
+        <p:nvSpPr>
+          <p:cNvPr id="12" name="Rounded Rectangle 11"/>
           <p:cNvSpPr/>
           <p:nvPr/>
         </p:nvSpPr>
         <p:spPr>
           <a:xfrm>
-            <a:off x="2935224" y="1673351"/>
-            <a:ext cx="347472" cy="347472"/>
-          </a:xfrm>
-          <a:prstGeom prst="ellipse">
+            <a:off x="502920" y="4800600"/>
+            <a:ext cx="1783080" cy="566928"/>
+          </a:xfrm>
+          <a:prstGeom prst="roundRect">
             <a:avLst/>
           </a:prstGeom>
           <a:solidFill>
-            <a:srgbClr val="2563EB"/>
+            <a:srgbClr val="FFFFFF"/>
           </a:solidFill>
-          <a:ln>
+          <a:ln w="12700">
             <a:solidFill>
-              <a:srgbClr val="2563EB"/>
+              <a:srgbClr val="CBD5E1"/>
             </a:solidFill>
           </a:ln>
         </p:spPr>
@@ -3485,14 +3498,14 @@
       </p:sp>
       <p:sp>
         <p:nvSpPr>
-          <p:cNvPr id="12" name="TextBox 11"/>
+          <p:cNvPr id="13" name="TextBox 12"/>
           <p:cNvSpPr txBox="1"/>
           <p:nvPr/>
         </p:nvSpPr>
         <p:spPr>
           <a:xfrm>
-            <a:off x="3044952" y="1723643"/>
-            <a:ext cx="182880" cy="164592"/>
+            <a:off x="612648" y="4882896"/>
+            <a:ext cx="713232" cy="182880"/>
           </a:xfrm>
           <a:prstGeom prst="rect">
             <a:avLst/>
@@ -3505,132 +3518,63 @@
           </a:bodyPr>
           <a:lstStyle/>
           <a:p>
-            <a:pPr algn="ctr"/>
-            <a:r>
-              <a:rPr sz="1700" b="1">
-                <a:solidFill>
-                  <a:srgbClr val="FFFFFF"/>
-                </a:solidFill>
-                <a:latin typeface="Aptos"/>
-              </a:rPr>
-              <a:t>2</a:t>
-            </a:r>
-          </a:p>
-        </p:txBody>
-      </p:sp>
-      <p:sp>
-        <p:nvSpPr>
-          <p:cNvPr id="13" name="TextBox 12"/>
-          <p:cNvSpPr txBox="1"/>
-          <p:nvPr/>
-        </p:nvSpPr>
-        <p:spPr>
-          <a:xfrm>
-            <a:off x="2953512" y="2130552"/>
-            <a:ext cx="1417320" cy="219456"/>
-          </a:xfrm>
-          <a:prstGeom prst="rect">
-            <a:avLst/>
-          </a:prstGeom>
-          <a:noFill/>
-        </p:spPr>
-        <p:txBody>
-          <a:bodyPr wrap="square" lIns="18288" rIns="18288" tIns="18288" bIns="18288">
-            <a:spAutoFit/>
-          </a:bodyPr>
-          <a:lstStyle/>
-          <a:p>
-            <a:r>
-              <a:rPr sz="1600" b="1">
-                <a:solidFill>
-                  <a:srgbClr val="0F172A"/>
-                </a:solidFill>
-                <a:latin typeface="Aptos"/>
-              </a:rPr>
-              <a:t>Patch placement</a:t>
-            </a:r>
-          </a:p>
-        </p:txBody>
-      </p:sp>
-      <p:sp>
-        <p:nvSpPr>
-          <p:cNvPr id="14" name="TextBox 13"/>
-          <p:cNvSpPr txBox="1"/>
-          <p:nvPr/>
-        </p:nvSpPr>
-        <p:spPr>
-          <a:xfrm>
-            <a:off x="2953512" y="2377439"/>
-            <a:ext cx="1417320" cy="256032"/>
-          </a:xfrm>
-          <a:prstGeom prst="rect">
-            <a:avLst/>
-          </a:prstGeom>
-          <a:noFill/>
-        </p:spPr>
-        <p:txBody>
-          <a:bodyPr wrap="square" lIns="18288" rIns="18288" tIns="18288" bIns="18288">
-            <a:spAutoFit/>
-          </a:bodyPr>
-          <a:lstStyle/>
-          <a:p>
-            <a:r>
-              <a:rPr sz="1300" b="0">
+            <a:r>
+              <a:rPr sz="1000" b="1">
                 <a:solidFill>
                   <a:srgbClr val="475569"/>
                 </a:solidFill>
                 <a:latin typeface="Aptos"/>
               </a:rPr>
-              <a:t>scene-aware + sweep</a:t>
-            </a:r>
-          </a:p>
-        </p:txBody>
-      </p:sp>
-      <p:cxnSp>
-        <p:nvCxnSpPr>
-          <p:cNvPr id="15" name="Connector 14"/>
-          <p:cNvCxnSpPr/>
+              <a:t>final</a:t>
+            </a:r>
+          </a:p>
+        </p:txBody>
+      </p:sp>
+      <p:sp>
+        <p:nvSpPr>
+          <p:cNvPr id="14" name="TextBox 13"/>
+          <p:cNvSpPr txBox="1"/>
           <p:nvPr/>
-        </p:nvCxnSpPr>
-        <p:spPr>
-          <a:xfrm>
-            <a:off x="4599431" y="2075688"/>
-            <a:ext cx="310897" cy="0"/>
-          </a:xfrm>
-          <a:prstGeom prst="line">
+        </p:nvSpPr>
+        <p:spPr>
+          <a:xfrm>
+            <a:off x="1069848" y="4864608"/>
+            <a:ext cx="1115568" cy="320040"/>
+          </a:xfrm>
+          <a:prstGeom prst="rect">
             <a:avLst/>
           </a:prstGeom>
-          <a:ln w="27940">
-            <a:solidFill>
-              <a:srgbClr val="2563EB"/>
-            </a:solidFill>
-          </a:ln>
-        </p:spPr>
-        <p:style>
-          <a:lnRef idx="2">
-            <a:schemeClr val="accent1"/>
-          </a:lnRef>
-          <a:fillRef idx="0">
-            <a:schemeClr val="accent1"/>
-          </a:fillRef>
-          <a:effectRef idx="1">
-            <a:schemeClr val="accent1"/>
-          </a:effectRef>
-          <a:fontRef idx="minor">
-            <a:schemeClr val="tx1"/>
-          </a:fontRef>
-        </p:style>
-      </p:cxnSp>
-      <p:sp>
-        <p:nvSpPr>
-          <p:cNvPr id="16" name="Rounded Rectangle 15"/>
+          <a:noFill/>
+        </p:spPr>
+        <p:txBody>
+          <a:bodyPr wrap="square" lIns="18288" rIns="18288" tIns="18288" bIns="18288">
+            <a:spAutoFit/>
+          </a:bodyPr>
+          <a:lstStyle/>
+          <a:p>
+            <a:pPr algn="r"/>
+            <a:r>
+              <a:rPr sz="1800" b="1">
+                <a:solidFill>
+                  <a:srgbClr val="DC2626"/>
+                </a:solidFill>
+                <a:latin typeface="Aptos"/>
+              </a:rPr>
+              <a:t>9.25m</a:t>
+            </a:r>
+          </a:p>
+        </p:txBody>
+      </p:sp>
+      <p:sp>
+        <p:nvSpPr>
+          <p:cNvPr id="15" name="Rounded Rectangle 14"/>
           <p:cNvSpPr/>
           <p:nvPr/>
         </p:nvSpPr>
         <p:spPr>
           <a:xfrm>
-            <a:off x="4983480" y="1508760"/>
-            <a:ext cx="1783080" cy="1143000"/>
+            <a:off x="2468880" y="4800600"/>
+            <a:ext cx="1783080" cy="566928"/>
           </a:xfrm>
           <a:prstGeom prst="roundRect">
             <a:avLst/>
@@ -3668,24 +3612,93 @@
       </p:sp>
       <p:sp>
         <p:nvSpPr>
-          <p:cNvPr id="17" name="Oval 16"/>
+          <p:cNvPr id="16" name="TextBox 15"/>
+          <p:cNvSpPr txBox="1"/>
+          <p:nvPr/>
+        </p:nvSpPr>
+        <p:spPr>
+          <a:xfrm>
+            <a:off x="2578608" y="4882896"/>
+            <a:ext cx="713232" cy="182880"/>
+          </a:xfrm>
+          <a:prstGeom prst="rect">
+            <a:avLst/>
+          </a:prstGeom>
+          <a:noFill/>
+        </p:spPr>
+        <p:txBody>
+          <a:bodyPr wrap="square" lIns="18288" rIns="18288" tIns="18288" bIns="18288">
+            <a:spAutoFit/>
+          </a:bodyPr>
+          <a:lstStyle/>
+          <a:p>
+            <a:r>
+              <a:rPr sz="1000" b="1">
+                <a:solidFill>
+                  <a:srgbClr val="475569"/>
+                </a:solidFill>
+                <a:latin typeface="Aptos"/>
+              </a:rPr>
+              <a:t>right</a:t>
+            </a:r>
+          </a:p>
+        </p:txBody>
+      </p:sp>
+      <p:sp>
+        <p:nvSpPr>
+          <p:cNvPr id="17" name="TextBox 16"/>
+          <p:cNvSpPr txBox="1"/>
+          <p:nvPr/>
+        </p:nvSpPr>
+        <p:spPr>
+          <a:xfrm>
+            <a:off x="3035808" y="4864608"/>
+            <a:ext cx="1115568" cy="320040"/>
+          </a:xfrm>
+          <a:prstGeom prst="rect">
+            <a:avLst/>
+          </a:prstGeom>
+          <a:noFill/>
+        </p:spPr>
+        <p:txBody>
+          <a:bodyPr wrap="square" lIns="18288" rIns="18288" tIns="18288" bIns="18288">
+            <a:spAutoFit/>
+          </a:bodyPr>
+          <a:lstStyle/>
+          <a:p>
+            <a:pPr algn="r"/>
+            <a:r>
+              <a:rPr sz="1800" b="1">
+                <a:solidFill>
+                  <a:srgbClr val="059669"/>
+                </a:solidFill>
+                <a:latin typeface="Aptos"/>
+              </a:rPr>
+              <a:t>+3.19m</a:t>
+            </a:r>
+          </a:p>
+        </p:txBody>
+      </p:sp>
+      <p:sp>
+        <p:nvSpPr>
+          <p:cNvPr id="18" name="Rounded Rectangle 17"/>
           <p:cNvSpPr/>
           <p:nvPr/>
         </p:nvSpPr>
         <p:spPr>
           <a:xfrm>
-            <a:off x="5129784" y="1673351"/>
-            <a:ext cx="347472" cy="347472"/>
-          </a:xfrm>
-          <a:prstGeom prst="ellipse">
+            <a:off x="4434840" y="4800600"/>
+            <a:ext cx="1783080" cy="566928"/>
+          </a:xfrm>
+          <a:prstGeom prst="roundRect">
             <a:avLst/>
           </a:prstGeom>
           <a:solidFill>
-            <a:srgbClr val="2563EB"/>
+            <a:srgbClr val="FFFFFF"/>
           </a:solidFill>
-          <a:ln>
+          <a:ln w="12700">
             <a:solidFill>
-              <a:srgbClr val="2563EB"/>
+              <a:srgbClr val="CBD5E1"/>
             </a:solidFill>
           </a:ln>
         </p:spPr>
@@ -3713,14 +3726,14 @@
       </p:sp>
       <p:sp>
         <p:nvSpPr>
-          <p:cNvPr id="18" name="TextBox 17"/>
+          <p:cNvPr id="19" name="TextBox 18"/>
           <p:cNvSpPr txBox="1"/>
           <p:nvPr/>
         </p:nvSpPr>
         <p:spPr>
           <a:xfrm>
-            <a:off x="5239512" y="1723643"/>
-            <a:ext cx="182880" cy="164592"/>
+            <a:off x="4544568" y="4882896"/>
+            <a:ext cx="713232" cy="182880"/>
           </a:xfrm>
           <a:prstGeom prst="rect">
             <a:avLst/>
@@ -3733,132 +3746,63 @@
           </a:bodyPr>
           <a:lstStyle/>
           <a:p>
-            <a:pPr algn="ctr"/>
-            <a:r>
-              <a:rPr sz="1700" b="1">
-                <a:solidFill>
-                  <a:srgbClr val="FFFFFF"/>
-                </a:solidFill>
-                <a:latin typeface="Aptos"/>
-              </a:rPr>
-              <a:t>3</a:t>
-            </a:r>
-          </a:p>
-        </p:txBody>
-      </p:sp>
-      <p:sp>
-        <p:nvSpPr>
-          <p:cNvPr id="19" name="TextBox 18"/>
-          <p:cNvSpPr txBox="1"/>
-          <p:nvPr/>
-        </p:nvSpPr>
-        <p:spPr>
-          <a:xfrm>
-            <a:off x="5148072" y="2130552"/>
-            <a:ext cx="1417320" cy="219456"/>
-          </a:xfrm>
-          <a:prstGeom prst="rect">
-            <a:avLst/>
-          </a:prstGeom>
-          <a:noFill/>
-        </p:spPr>
-        <p:txBody>
-          <a:bodyPr wrap="square" lIns="18288" rIns="18288" tIns="18288" bIns="18288">
-            <a:spAutoFit/>
-          </a:bodyPr>
-          <a:lstStyle/>
-          <a:p>
-            <a:r>
-              <a:rPr sz="1600" b="1">
-                <a:solidFill>
-                  <a:srgbClr val="0F172A"/>
-                </a:solidFill>
-                <a:latin typeface="Aptos"/>
-              </a:rPr>
-              <a:t>Black-box search</a:t>
-            </a:r>
-          </a:p>
-        </p:txBody>
-      </p:sp>
-      <p:sp>
-        <p:nvSpPr>
-          <p:cNvPr id="20" name="TextBox 19"/>
-          <p:cNvSpPr txBox="1"/>
-          <p:nvPr/>
-        </p:nvSpPr>
-        <p:spPr>
-          <a:xfrm>
-            <a:off x="5148072" y="2377439"/>
-            <a:ext cx="1417320" cy="256032"/>
-          </a:xfrm>
-          <a:prstGeom prst="rect">
-            <a:avLst/>
-          </a:prstGeom>
-          <a:noFill/>
-        </p:spPr>
-        <p:txBody>
-          <a:bodyPr wrap="square" lIns="18288" rIns="18288" tIns="18288" bIns="18288">
-            <a:spAutoFit/>
-          </a:bodyPr>
-          <a:lstStyle/>
-          <a:p>
-            <a:r>
-              <a:rPr sz="1300" b="0">
+            <a:r>
+              <a:rPr sz="1000" b="1">
                 <a:solidFill>
                   <a:srgbClr val="475569"/>
                 </a:solidFill>
                 <a:latin typeface="Aptos"/>
               </a:rPr>
-              <a:t>evolution / NES, no gradients</a:t>
-            </a:r>
-          </a:p>
-        </p:txBody>
-      </p:sp>
-      <p:cxnSp>
-        <p:nvCxnSpPr>
-          <p:cNvPr id="21" name="Connector 20"/>
-          <p:cNvCxnSpPr/>
+              <a:t>mean</a:t>
+            </a:r>
+          </a:p>
+        </p:txBody>
+      </p:sp>
+      <p:sp>
+        <p:nvSpPr>
+          <p:cNvPr id="20" name="TextBox 19"/>
+          <p:cNvSpPr txBox="1"/>
           <p:nvPr/>
-        </p:nvCxnSpPr>
-        <p:spPr>
-          <a:xfrm>
-            <a:off x="6793992" y="2075688"/>
-            <a:ext cx="310896" cy="0"/>
-          </a:xfrm>
-          <a:prstGeom prst="line">
+        </p:nvSpPr>
+        <p:spPr>
+          <a:xfrm>
+            <a:off x="5001768" y="4864608"/>
+            <a:ext cx="1115568" cy="320040"/>
+          </a:xfrm>
+          <a:prstGeom prst="rect">
             <a:avLst/>
           </a:prstGeom>
-          <a:ln w="27940">
-            <a:solidFill>
-              <a:srgbClr val="2563EB"/>
-            </a:solidFill>
-          </a:ln>
-        </p:spPr>
-        <p:style>
-          <a:lnRef idx="2">
-            <a:schemeClr val="accent1"/>
-          </a:lnRef>
-          <a:fillRef idx="0">
-            <a:schemeClr val="accent1"/>
-          </a:fillRef>
-          <a:effectRef idx="1">
-            <a:schemeClr val="accent1"/>
-          </a:effectRef>
-          <a:fontRef idx="minor">
-            <a:schemeClr val="tx1"/>
-          </a:fontRef>
-        </p:style>
-      </p:cxnSp>
-      <p:sp>
-        <p:nvSpPr>
-          <p:cNvPr id="22" name="Rounded Rectangle 21"/>
+          <a:noFill/>
+        </p:spPr>
+        <p:txBody>
+          <a:bodyPr wrap="square" lIns="18288" rIns="18288" tIns="18288" bIns="18288">
+            <a:spAutoFit/>
+          </a:bodyPr>
+          <a:lstStyle/>
+          <a:p>
+            <a:pPr algn="r"/>
+            <a:r>
+              <a:rPr sz="1800" b="1">
+                <a:solidFill>
+                  <a:srgbClr val="2563EB"/>
+                </a:solidFill>
+                <a:latin typeface="Aptos"/>
+              </a:rPr>
+              <a:t>3.44m</a:t>
+            </a:r>
+          </a:p>
+        </p:txBody>
+      </p:sp>
+      <p:sp>
+        <p:nvSpPr>
+          <p:cNvPr id="21" name="Rounded Rectangle 20"/>
           <p:cNvSpPr/>
           <p:nvPr/>
         </p:nvSpPr>
         <p:spPr>
           <a:xfrm>
-            <a:off x="7178040" y="1508760"/>
-            <a:ext cx="1783080" cy="1143000"/>
+            <a:off x="502920" y="5532120"/>
+            <a:ext cx="6903720" cy="566928"/>
           </a:xfrm>
           <a:prstGeom prst="roundRect">
             <a:avLst/>
@@ -3896,59 +3840,14 @@
       </p:sp>
       <p:sp>
         <p:nvSpPr>
-          <p:cNvPr id="23" name="Oval 22"/>
-          <p:cNvSpPr/>
-          <p:nvPr/>
-        </p:nvSpPr>
-        <p:spPr>
-          <a:xfrm>
-            <a:off x="7324344" y="1673351"/>
-            <a:ext cx="347472" cy="347472"/>
-          </a:xfrm>
-          <a:prstGeom prst="ellipse">
-            <a:avLst/>
-          </a:prstGeom>
-          <a:solidFill>
-            <a:srgbClr val="2563EB"/>
-          </a:solidFill>
-          <a:ln>
-            <a:solidFill>
-              <a:srgbClr val="2563EB"/>
-            </a:solidFill>
-          </a:ln>
-        </p:spPr>
-        <p:style>
-          <a:lnRef idx="1">
-            <a:schemeClr val="accent1"/>
-          </a:lnRef>
-          <a:fillRef idx="3">
-            <a:schemeClr val="accent1"/>
-          </a:fillRef>
-          <a:effectRef idx="2">
-            <a:schemeClr val="accent1"/>
-          </a:effectRef>
-          <a:fontRef idx="minor">
-            <a:schemeClr val="lt1"/>
-          </a:fontRef>
-        </p:style>
-        <p:txBody>
-          <a:bodyPr rtlCol="0" anchor="ctr"/>
-          <a:lstStyle/>
-          <a:p>
-            <a:pPr algn="ctr"/>
-          </a:p>
-        </p:txBody>
-      </p:sp>
-      <p:sp>
-        <p:nvSpPr>
-          <p:cNvPr id="24" name="TextBox 23"/>
+          <p:cNvPr id="22" name="TextBox 21"/>
           <p:cNvSpPr txBox="1"/>
           <p:nvPr/>
         </p:nvSpPr>
         <p:spPr>
           <a:xfrm>
-            <a:off x="7434071" y="1723643"/>
-            <a:ext cx="182880" cy="164592"/>
+            <a:off x="685800" y="5660136"/>
+            <a:ext cx="6446520" cy="310896"/>
           </a:xfrm>
           <a:prstGeom prst="rect">
             <a:avLst/>
@@ -3961,63 +3860,28 @@
           </a:bodyPr>
           <a:lstStyle/>
           <a:p>
-            <a:pPr algn="ctr"/>
-            <a:r>
-              <a:rPr sz="1700" b="1">
-                <a:solidFill>
-                  <a:srgbClr val="FFFFFF"/>
-                </a:solidFill>
-                <a:latin typeface="Aptos"/>
-              </a:rPr>
-              <a:t>4</a:t>
-            </a:r>
-          </a:p>
-        </p:txBody>
-      </p:sp>
-      <p:sp>
-        <p:nvSpPr>
-          <p:cNvPr id="25" name="TextBox 24"/>
-          <p:cNvSpPr txBox="1"/>
-          <p:nvPr/>
-        </p:nvSpPr>
-        <p:spPr>
-          <a:xfrm>
-            <a:off x="7342631" y="2130552"/>
-            <a:ext cx="1417320" cy="219456"/>
-          </a:xfrm>
-          <a:prstGeom prst="rect">
-            <a:avLst/>
-          </a:prstGeom>
-          <a:noFill/>
-        </p:spPr>
-        <p:txBody>
-          <a:bodyPr wrap="square" lIns="18288" rIns="18288" tIns="18288" bIns="18288">
-            <a:spAutoFit/>
-          </a:bodyPr>
-          <a:lstStyle/>
-          <a:p>
-            <a:r>
-              <a:rPr sz="1600" b="1">
+            <a:r>
+              <a:rPr sz="1200" b="1">
                 <a:solidFill>
                   <a:srgbClr val="0F172A"/>
                 </a:solidFill>
                 <a:latin typeface="Aptos"/>
               </a:rPr>
-              <a:t>Objective</a:t>
-            </a:r>
-          </a:p>
-        </p:txBody>
-      </p:sp>
-      <p:sp>
-        <p:nvSpPr>
-          <p:cNvPr id="26" name="TextBox 25"/>
+              <a:t>Clean prediction goes straight; attacked prediction shifts right and slows/shortens the planned path.</a:t>
+            </a:r>
+          </a:p>
+        </p:txBody>
+      </p:sp>
+      <p:sp>
+        <p:nvSpPr>
+          <p:cNvPr id="23" name="TextBox 22"/>
           <p:cNvSpPr txBox="1"/>
           <p:nvPr/>
         </p:nvSpPr>
         <p:spPr>
           <a:xfrm>
-            <a:off x="7342631" y="2377439"/>
-            <a:ext cx="1417320" cy="256032"/>
+            <a:off x="10835640" y="329184"/>
+            <a:ext cx="822960" cy="201168"/>
           </a:xfrm>
           <a:prstGeom prst="rect">
             <a:avLst/>
@@ -4030,545 +3894,15 @@
           </a:bodyPr>
           <a:lstStyle/>
           <a:p>
-            <a:r>
-              <a:rPr sz="1300" b="0">
+            <a:pPr algn="r"/>
+            <a:r>
+              <a:rPr sz="1100" b="1">
                 <a:solidFill>
                   <a:srgbClr val="475569"/>
                 </a:solidFill>
                 <a:latin typeface="Aptos"/>
               </a:rPr>
-              <a:t>target-direction trajectory shift</a:t>
-            </a:r>
-          </a:p>
-        </p:txBody>
-      </p:sp>
-      <p:cxnSp>
-        <p:nvCxnSpPr>
-          <p:cNvPr id="27" name="Connector 26"/>
-          <p:cNvCxnSpPr/>
-          <p:nvPr/>
-        </p:nvCxnSpPr>
-        <p:spPr>
-          <a:xfrm>
-            <a:off x="8988552" y="2075688"/>
-            <a:ext cx="310896" cy="0"/>
-          </a:xfrm>
-          <a:prstGeom prst="line">
-            <a:avLst/>
-          </a:prstGeom>
-          <a:ln w="27940">
-            <a:solidFill>
-              <a:srgbClr val="2563EB"/>
-            </a:solidFill>
-          </a:ln>
-        </p:spPr>
-        <p:style>
-          <a:lnRef idx="2">
-            <a:schemeClr val="accent1"/>
-          </a:lnRef>
-          <a:fillRef idx="0">
-            <a:schemeClr val="accent1"/>
-          </a:fillRef>
-          <a:effectRef idx="1">
-            <a:schemeClr val="accent1"/>
-          </a:effectRef>
-          <a:fontRef idx="minor">
-            <a:schemeClr val="tx1"/>
-          </a:fontRef>
-        </p:style>
-      </p:cxnSp>
-      <p:sp>
-        <p:nvSpPr>
-          <p:cNvPr id="28" name="Rounded Rectangle 27"/>
-          <p:cNvSpPr/>
-          <p:nvPr/>
-        </p:nvSpPr>
-        <p:spPr>
-          <a:xfrm>
-            <a:off x="9372600" y="1508760"/>
-            <a:ext cx="1783080" cy="1143000"/>
-          </a:xfrm>
-          <a:prstGeom prst="roundRect">
-            <a:avLst/>
-          </a:prstGeom>
-          <a:solidFill>
-            <a:srgbClr val="FFFFFF"/>
-          </a:solidFill>
-          <a:ln w="12700">
-            <a:solidFill>
-              <a:srgbClr val="CBD5E1"/>
-            </a:solidFill>
-          </a:ln>
-        </p:spPr>
-        <p:style>
-          <a:lnRef idx="1">
-            <a:schemeClr val="accent1"/>
-          </a:lnRef>
-          <a:fillRef idx="3">
-            <a:schemeClr val="accent1"/>
-          </a:fillRef>
-          <a:effectRef idx="2">
-            <a:schemeClr val="accent1"/>
-          </a:effectRef>
-          <a:fontRef idx="minor">
-            <a:schemeClr val="lt1"/>
-          </a:fontRef>
-        </p:style>
-        <p:txBody>
-          <a:bodyPr rtlCol="0" anchor="ctr"/>
-          <a:lstStyle/>
-          <a:p>
-            <a:pPr algn="ctr"/>
-          </a:p>
-        </p:txBody>
-      </p:sp>
-      <p:sp>
-        <p:nvSpPr>
-          <p:cNvPr id="29" name="Oval 28"/>
-          <p:cNvSpPr/>
-          <p:nvPr/>
-        </p:nvSpPr>
-        <p:spPr>
-          <a:xfrm>
-            <a:off x="9518904" y="1673351"/>
-            <a:ext cx="347472" cy="347472"/>
-          </a:xfrm>
-          <a:prstGeom prst="ellipse">
-            <a:avLst/>
-          </a:prstGeom>
-          <a:solidFill>
-            <a:srgbClr val="2563EB"/>
-          </a:solidFill>
-          <a:ln>
-            <a:solidFill>
-              <a:srgbClr val="2563EB"/>
-            </a:solidFill>
-          </a:ln>
-        </p:spPr>
-        <p:style>
-          <a:lnRef idx="1">
-            <a:schemeClr val="accent1"/>
-          </a:lnRef>
-          <a:fillRef idx="3">
-            <a:schemeClr val="accent1"/>
-          </a:fillRef>
-          <a:effectRef idx="2">
-            <a:schemeClr val="accent1"/>
-          </a:effectRef>
-          <a:fontRef idx="minor">
-            <a:schemeClr val="lt1"/>
-          </a:fontRef>
-        </p:style>
-        <p:txBody>
-          <a:bodyPr rtlCol="0" anchor="ctr"/>
-          <a:lstStyle/>
-          <a:p>
-            <a:pPr algn="ctr"/>
-          </a:p>
-        </p:txBody>
-      </p:sp>
-      <p:sp>
-        <p:nvSpPr>
-          <p:cNvPr id="30" name="TextBox 29"/>
-          <p:cNvSpPr txBox="1"/>
-          <p:nvPr/>
-        </p:nvSpPr>
-        <p:spPr>
-          <a:xfrm>
-            <a:off x="9628632" y="1723643"/>
-            <a:ext cx="182880" cy="164592"/>
-          </a:xfrm>
-          <a:prstGeom prst="rect">
-            <a:avLst/>
-          </a:prstGeom>
-          <a:noFill/>
-        </p:spPr>
-        <p:txBody>
-          <a:bodyPr wrap="square" lIns="18288" rIns="18288" tIns="18288" bIns="18288">
-            <a:spAutoFit/>
-          </a:bodyPr>
-          <a:lstStyle/>
-          <a:p>
-            <a:pPr algn="ctr"/>
-            <a:r>
-              <a:rPr sz="1700" b="1">
-                <a:solidFill>
-                  <a:srgbClr val="FFFFFF"/>
-                </a:solidFill>
-                <a:latin typeface="Aptos"/>
-              </a:rPr>
-              <a:t>5</a:t>
-            </a:r>
-          </a:p>
-        </p:txBody>
-      </p:sp>
-      <p:sp>
-        <p:nvSpPr>
-          <p:cNvPr id="31" name="TextBox 30"/>
-          <p:cNvSpPr txBox="1"/>
-          <p:nvPr/>
-        </p:nvSpPr>
-        <p:spPr>
-          <a:xfrm>
-            <a:off x="9537192" y="2130552"/>
-            <a:ext cx="1417320" cy="219456"/>
-          </a:xfrm>
-          <a:prstGeom prst="rect">
-            <a:avLst/>
-          </a:prstGeom>
-          <a:noFill/>
-        </p:spPr>
-        <p:txBody>
-          <a:bodyPr wrap="square" lIns="18288" rIns="18288" tIns="18288" bIns="18288">
-            <a:spAutoFit/>
-          </a:bodyPr>
-          <a:lstStyle/>
-          <a:p>
-            <a:r>
-              <a:rPr sz="1600" b="1">
-                <a:solidFill>
-                  <a:srgbClr val="0F172A"/>
-                </a:solidFill>
-                <a:latin typeface="Aptos"/>
-              </a:rPr>
-              <a:t>Evaluate</a:t>
-            </a:r>
-          </a:p>
-        </p:txBody>
-      </p:sp>
-      <p:sp>
-        <p:nvSpPr>
-          <p:cNvPr id="32" name="TextBox 31"/>
-          <p:cNvSpPr txBox="1"/>
-          <p:nvPr/>
-        </p:nvSpPr>
-        <p:spPr>
-          <a:xfrm>
-            <a:off x="9537192" y="2377439"/>
-            <a:ext cx="1417320" cy="256032"/>
-          </a:xfrm>
-          <a:prstGeom prst="rect">
-            <a:avLst/>
-          </a:prstGeom>
-          <a:noFill/>
-        </p:spPr>
-        <p:txBody>
-          <a:bodyPr wrap="square" lIns="18288" rIns="18288" tIns="18288" bIns="18288">
-            <a:spAutoFit/>
-          </a:bodyPr>
-          <a:lstStyle/>
-          <a:p>
-            <a:r>
-              <a:rPr sz="1300" b="0">
-                <a:solidFill>
-                  <a:srgbClr val="475569"/>
-                </a:solidFill>
-                <a:latin typeface="Aptos"/>
-              </a:rPr>
-              <a:t>clean vs attacked trajectory</a:t>
-            </a:r>
-          </a:p>
-        </p:txBody>
-      </p:sp>
-      <p:sp>
-        <p:nvSpPr>
-          <p:cNvPr id="33" name="Rounded Rectangle 32"/>
-          <p:cNvSpPr/>
-          <p:nvPr/>
-        </p:nvSpPr>
-        <p:spPr>
-          <a:xfrm>
-            <a:off x="594360" y="3246120"/>
-            <a:ext cx="4389120" cy="2834640"/>
-          </a:xfrm>
-          <a:prstGeom prst="roundRect">
-            <a:avLst/>
-          </a:prstGeom>
-          <a:solidFill>
-            <a:srgbClr val="FFFFFF"/>
-          </a:solidFill>
-          <a:ln w="12700">
-            <a:solidFill>
-              <a:srgbClr val="CBD5E1"/>
-            </a:solidFill>
-          </a:ln>
-        </p:spPr>
-        <p:style>
-          <a:lnRef idx="1">
-            <a:schemeClr val="accent1"/>
-          </a:lnRef>
-          <a:fillRef idx="3">
-            <a:schemeClr val="accent1"/>
-          </a:fillRef>
-          <a:effectRef idx="2">
-            <a:schemeClr val="accent1"/>
-          </a:effectRef>
-          <a:fontRef idx="minor">
-            <a:schemeClr val="lt1"/>
-          </a:fontRef>
-        </p:style>
-        <p:txBody>
-          <a:bodyPr rtlCol="0" anchor="ctr"/>
-          <a:lstStyle/>
-          <a:p>
-            <a:pPr algn="ctr"/>
-          </a:p>
-        </p:txBody>
-      </p:sp>
-      <p:sp>
-        <p:nvSpPr>
-          <p:cNvPr id="34" name="TextBox 33"/>
-          <p:cNvSpPr txBox="1"/>
-          <p:nvPr/>
-        </p:nvSpPr>
-        <p:spPr>
-          <a:xfrm>
-            <a:off x="822960" y="3520440"/>
-            <a:ext cx="3840480" cy="320040"/>
-          </a:xfrm>
-          <a:prstGeom prst="rect">
-            <a:avLst/>
-          </a:prstGeom>
-          <a:noFill/>
-        </p:spPr>
-        <p:txBody>
-          <a:bodyPr wrap="square" lIns="18288" rIns="18288" tIns="18288" bIns="18288">
-            <a:spAutoFit/>
-          </a:bodyPr>
-          <a:lstStyle/>
-          <a:p>
-            <a:r>
-              <a:rPr sz="2200" b="1">
-                <a:solidFill>
-                  <a:srgbClr val="0F172A"/>
-                </a:solidFill>
-                <a:latin typeface="Aptos"/>
-              </a:rPr>
-              <a:t>Attack objective</a:t>
-            </a:r>
-          </a:p>
-        </p:txBody>
-      </p:sp>
-      <p:sp>
-        <p:nvSpPr>
-          <p:cNvPr id="35" name="TextBox 34"/>
-          <p:cNvSpPr txBox="1"/>
-          <p:nvPr/>
-        </p:nvSpPr>
-        <p:spPr>
-          <a:xfrm>
-            <a:off x="822960" y="3977639"/>
-            <a:ext cx="3886200" cy="1920240"/>
-          </a:xfrm>
-          <a:prstGeom prst="rect">
-            <a:avLst/>
-          </a:prstGeom>
-          <a:noFill/>
-        </p:spPr>
-        <p:txBody>
-          <a:bodyPr wrap="square" lIns="45720" rIns="45720" tIns="18288" bIns="18288">
-            <a:spAutoFit/>
-          </a:bodyPr>
-          <a:lstStyle/>
-          <a:p>
-            <a:pPr>
-              <a:spcAft>
-                <a:spcPts val="700"/>
-              </a:spcAft>
-              <a:defRPr sz="1600">
-                <a:solidFill>
-                  <a:srgbClr val="475569"/>
-                </a:solidFill>
-                <a:latin typeface="Aptos"/>
-              </a:defRPr>
-            </a:pPr>
-            <a:r>
-              <a:t>Use decoded trajectory only: clean prediction vs attacked prediction.</a:t>
-            </a:r>
-          </a:p>
-          <a:p>
-            <a:pPr>
-              <a:spcAft>
-                <a:spcPts val="700"/>
-              </a:spcAft>
-              <a:defRPr sz="1600">
-                <a:solidFill>
-                  <a:srgbClr val="475569"/>
-                </a:solidFill>
-                <a:latin typeface="Aptos"/>
-              </a:defRPr>
-            </a:pPr>
-            <a:r>
-              <a:t>Position-aware loss rewards target-direction lateral shift and final displacement.</a:t>
-            </a:r>
-          </a:p>
-          <a:p>
-            <a:pPr>
-              <a:spcAft>
-                <a:spcPts val="700"/>
-              </a:spcAft>
-              <a:defRPr sz="1600">
-                <a:solidFill>
-                  <a:srgbClr val="475569"/>
-                </a:solidFill>
-                <a:latin typeface="Aptos"/>
-              </a:defRPr>
-            </a:pPr>
-            <a:r>
-              <a:t>Penalizes wrong-way lateral movement and pure forward/backward drift.</a:t>
-            </a:r>
-          </a:p>
-          <a:p>
-            <a:pPr>
-              <a:spcAft>
-                <a:spcPts val="700"/>
-              </a:spcAft>
-              <a:defRPr sz="1600">
-                <a:solidFill>
-                  <a:srgbClr val="475569"/>
-                </a:solidFill>
-                <a:latin typeface="Aptos"/>
-              </a:defRPr>
-            </a:pPr>
-            <a:r>
-              <a:t>Evolution search keeps best candidates because generation outputs are non-smooth.</a:t>
-            </a:r>
-          </a:p>
-        </p:txBody>
-      </p:sp>
-      <p:sp>
-        <p:nvSpPr>
-          <p:cNvPr id="36" name="Rounded Rectangle 35"/>
-          <p:cNvSpPr/>
-          <p:nvPr/>
-        </p:nvSpPr>
-        <p:spPr>
-          <a:xfrm>
-            <a:off x="5349240" y="3246120"/>
-            <a:ext cx="6263640" cy="2834640"/>
-          </a:xfrm>
-          <a:prstGeom prst="roundRect">
-            <a:avLst/>
-          </a:prstGeom>
-          <a:solidFill>
-            <a:srgbClr val="FFFFFF"/>
-          </a:solidFill>
-          <a:ln w="12700">
-            <a:solidFill>
-              <a:srgbClr val="CBD5E1"/>
-            </a:solidFill>
-          </a:ln>
-        </p:spPr>
-        <p:style>
-          <a:lnRef idx="1">
-            <a:schemeClr val="accent1"/>
-          </a:lnRef>
-          <a:fillRef idx="3">
-            <a:schemeClr val="accent1"/>
-          </a:fillRef>
-          <a:effectRef idx="2">
-            <a:schemeClr val="accent1"/>
-          </a:effectRef>
-          <a:fontRef idx="minor">
-            <a:schemeClr val="lt1"/>
-          </a:fontRef>
-        </p:style>
-        <p:txBody>
-          <a:bodyPr rtlCol="0" anchor="ctr"/>
-          <a:lstStyle/>
-          <a:p>
-            <a:pPr algn="ctr"/>
-          </a:p>
-        </p:txBody>
-      </p:sp>
-      <p:sp>
-        <p:nvSpPr>
-          <p:cNvPr id="37" name="TextBox 36"/>
-          <p:cNvSpPr txBox="1"/>
-          <p:nvPr/>
-        </p:nvSpPr>
-        <p:spPr>
-          <a:xfrm>
-            <a:off x="5577840" y="3520440"/>
-            <a:ext cx="4114800" cy="320040"/>
-          </a:xfrm>
-          <a:prstGeom prst="rect">
-            <a:avLst/>
-          </a:prstGeom>
-          <a:noFill/>
-        </p:spPr>
-        <p:txBody>
-          <a:bodyPr wrap="square" lIns="18288" rIns="18288" tIns="18288" bIns="18288">
-            <a:spAutoFit/>
-          </a:bodyPr>
-          <a:lstStyle/>
-          <a:p>
-            <a:r>
-              <a:rPr sz="2200" b="1">
-                <a:solidFill>
-                  <a:srgbClr val="0F172A"/>
-                </a:solidFill>
-                <a:latin typeface="Aptos"/>
-              </a:rPr>
-              <a:t>Scene-aware placement</a:t>
-            </a:r>
-          </a:p>
-        </p:txBody>
-      </p:sp>
-      <p:pic>
-        <p:nvPicPr>
-          <p:cNvPr id="38" name="Picture 37" descr="overlay.jpg"/>
-          <p:cNvPicPr>
-            <a:picLocks noChangeAspect="1"/>
-          </p:cNvPicPr>
-          <p:nvPr/>
-        </p:nvPicPr>
-        <p:blipFill>
-          <a:blip r:embed="rId2"/>
-          <a:stretch>
-            <a:fillRect/>
-          </a:stretch>
-        </p:blipFill>
-        <p:spPr>
-          <a:xfrm>
-            <a:off x="6720840" y="3858768"/>
-            <a:ext cx="1076886" cy="1783080"/>
-          </a:xfrm>
-          <a:prstGeom prst="rect">
-            <a:avLst/>
-          </a:prstGeom>
-        </p:spPr>
-      </p:pic>
-      <p:sp>
-        <p:nvSpPr>
-          <p:cNvPr id="39" name="TextBox 38"/>
-          <p:cNvSpPr txBox="1"/>
-          <p:nvPr/>
-        </p:nvSpPr>
-        <p:spPr>
-          <a:xfrm>
-            <a:off x="5577840" y="5623560"/>
-            <a:ext cx="5669280" cy="384048"/>
-          </a:xfrm>
-          <a:prstGeom prst="rect">
-            <a:avLst/>
-          </a:prstGeom>
-          <a:noFill/>
-        </p:spPr>
-        <p:txBody>
-          <a:bodyPr wrap="square" lIns="18288" rIns="18288" tIns="18288" bIns="18288">
-            <a:spAutoFit/>
-          </a:bodyPr>
-          <a:lstStyle/>
-          <a:p>
-            <a:r>
-              <a:rPr sz="1400" b="0">
-                <a:solidFill>
-                  <a:srgbClr val="475569"/>
-                </a:solidFill>
-                <a:latin typeface="Aptos"/>
-              </a:rPr>
-              <a:t>Heuristic probes construction cues, road/lane texture, and horizon fallback. Black-box sweep then selects the best position per scene.</a:t>
+              <a:t>01bbf47b</a:t>
             </a:r>
           </a:p>
         </p:txBody>
@@ -4607,8 +3941,8 @@
         </p:nvSpPr>
         <p:spPr>
           <a:xfrm>
-            <a:off x="594360" y="384048"/>
-            <a:ext cx="10607040" cy="502920"/>
+            <a:off x="502920" y="292608"/>
+            <a:ext cx="8138160" cy="411480"/>
           </a:xfrm>
           <a:prstGeom prst="rect">
             <a:avLst/>
@@ -4622,13 +3956,13 @@
           <a:lstStyle/>
           <a:p>
             <a:r>
-              <a:rPr sz="3400" b="1">
+              <a:rPr sz="2800" b="1">
                 <a:solidFill>
                   <a:srgbClr val="0F172A"/>
                 </a:solidFill>
                 <a:latin typeface="Aptos"/>
               </a:rPr>
-              <a:t>Results: Smaller Patch Helps, but Still Not Robust</a:t>
+              <a:t>Showcase 2: Scene-aware Placement Helps</a:t>
             </a:r>
           </a:p>
         </p:txBody>
@@ -4641,8 +3975,8 @@
         </p:nvSpPr>
         <p:spPr>
           <a:xfrm>
-            <a:off x="612648" y="896112"/>
-            <a:ext cx="8046720" cy="320040"/>
+            <a:off x="521207" y="749808"/>
+            <a:ext cx="7680960" cy="256032"/>
           </a:xfrm>
           <a:prstGeom prst="rect">
             <a:avLst/>
@@ -4656,13 +3990,13 @@
           <a:lstStyle/>
           <a:p>
             <a:r>
-              <a:rPr sz="1900" b="0">
+              <a:rPr sz="1500" b="0">
                 <a:solidFill>
                   <a:srgbClr val="475569"/>
                 </a:solidFill>
                 <a:latin typeface="Aptos"/>
               </a:rPr>
-              <a:t>p20 front-camera patch, 5 nuScenes samples, scene-aware position sweep</a:t>
+              <a:t>Patch is placed on a salient construction/roadside cue selected from the front image.</a:t>
             </a:r>
           </a:p>
         </p:txBody>
@@ -4675,18 +4009,18 @@
         </p:nvSpPr>
         <p:spPr>
           <a:xfrm>
-            <a:off x="594360" y="1417320"/>
-            <a:ext cx="2423160" cy="960120"/>
+            <a:off x="502920" y="1078992"/>
+            <a:ext cx="11201400" cy="493776"/>
           </a:xfrm>
           <a:prstGeom prst="roundRect">
             <a:avLst/>
           </a:prstGeom>
           <a:solidFill>
-            <a:srgbClr val="FFFFFF"/>
+            <a:srgbClr val="EFF6FF"/>
           </a:solidFill>
           <a:ln w="12700">
             <a:solidFill>
-              <a:srgbClr val="CBD5E1"/>
+              <a:srgbClr val="BFDBFE"/>
             </a:solidFill>
           </a:ln>
         </p:spPr>
@@ -4720,8 +4054,8 @@
         </p:nvSpPr>
         <p:spPr>
           <a:xfrm>
-            <a:off x="758952" y="1581912"/>
-            <a:ext cx="2093976" cy="228600"/>
+            <a:off x="713232" y="1234440"/>
+            <a:ext cx="10607040" cy="201168"/>
           </a:xfrm>
           <a:prstGeom prst="rect">
             <a:avLst/>
@@ -4735,95 +4069,27 @@
           <a:lstStyle/>
           <a:p>
             <a:r>
-              <a:rPr sz="1500" b="1">
+              <a:rPr sz="1300" b="1">
                 <a:solidFill>
-                  <a:srgbClr val="475569"/>
+                  <a:srgbClr val="0F172A"/>
                 </a:solidFill>
                 <a:latin typeface="Aptos"/>
               </a:rPr>
-              <a:t>Avg final shift</a:t>
-            </a:r>
-          </a:p>
-        </p:txBody>
-      </p:sp>
-      <p:sp>
-        <p:nvSpPr>
-          <p:cNvPr id="6" name="TextBox 5"/>
-          <p:cNvSpPr txBox="1"/>
-          <p:nvPr/>
-        </p:nvSpPr>
-        <p:spPr>
-          <a:xfrm>
-            <a:off x="758952" y="1856232"/>
-            <a:ext cx="2093976" cy="411480"/>
-          </a:xfrm>
-          <a:prstGeom prst="rect">
-            <a:avLst/>
-          </a:prstGeom>
-          <a:noFill/>
-        </p:spPr>
-        <p:txBody>
-          <a:bodyPr wrap="square" lIns="18288" rIns="18288" tIns="18288" bIns="18288">
-            <a:spAutoFit/>
-          </a:bodyPr>
-          <a:lstStyle/>
-          <a:p>
-            <a:r>
-              <a:rPr sz="3100" b="1">
-                <a:solidFill>
-                  <a:srgbClr val="2563EB"/>
-                </a:solidFill>
-                <a:latin typeface="Aptos"/>
-              </a:rPr>
-              <a:t>3.42 m</a:t>
-            </a:r>
-          </a:p>
-        </p:txBody>
-      </p:sp>
-      <p:sp>
-        <p:nvSpPr>
-          <p:cNvPr id="7" name="TextBox 6"/>
-          <p:cNvSpPr txBox="1"/>
-          <p:nvPr/>
-        </p:nvSpPr>
-        <p:spPr>
-          <a:xfrm>
-            <a:off x="758952" y="2313432"/>
-            <a:ext cx="2093976" cy="228600"/>
-          </a:xfrm>
-          <a:prstGeom prst="rect">
-            <a:avLst/>
-          </a:prstGeom>
-          <a:noFill/>
-        </p:spPr>
-        <p:txBody>
-          <a:bodyPr wrap="square" lIns="18288" rIns="18288" tIns="18288" bIns="18288">
-            <a:spAutoFit/>
-          </a:bodyPr>
-          <a:lstStyle/>
-          <a:p>
-            <a:r>
-              <a:rPr sz="1300" b="0">
-                <a:solidFill>
-                  <a:srgbClr val="475569"/>
-                </a:solidFill>
-                <a:latin typeface="Aptos"/>
-              </a:rPr>
-              <a:t>vs 2.95 m without scene-aware</a:t>
-            </a:r>
-          </a:p>
-        </p:txBody>
-      </p:sp>
-      <p:sp>
-        <p:nvSpPr>
-          <p:cNvPr id="8" name="Rounded Rectangle 7"/>
+              <a:t>Black-box: front camera only | no gradients | position sweep | trajectory-shift objective</a:t>
+            </a:r>
+          </a:p>
+        </p:txBody>
+      </p:sp>
+      <p:sp>
+        <p:nvSpPr>
+          <p:cNvPr id="6" name="Rounded Rectangle 5"/>
           <p:cNvSpPr/>
           <p:nvPr/>
         </p:nvSpPr>
         <p:spPr>
           <a:xfrm>
-            <a:off x="3246120" y="1417320"/>
-            <a:ext cx="2423160" cy="960120"/>
+            <a:off x="502920" y="1783080"/>
+            <a:ext cx="6903720" cy="2788920"/>
           </a:xfrm>
           <a:prstGeom prst="roundRect">
             <a:avLst/>
@@ -4859,16 +4125,40 @@
           </a:p>
         </p:txBody>
       </p:sp>
-      <p:sp>
-        <p:nvSpPr>
-          <p:cNvPr id="9" name="TextBox 8"/>
+      <p:pic>
+        <p:nvPicPr>
+          <p:cNvPr id="7" name="Picture 6" descr="01a7d01c_inputs.jpg"/>
+          <p:cNvPicPr>
+            <a:picLocks noChangeAspect="1"/>
+          </p:cNvPicPr>
+          <p:nvPr/>
+        </p:nvPicPr>
+        <p:blipFill>
+          <a:blip r:embed="rId2"/>
+          <a:stretch>
+            <a:fillRect/>
+          </a:stretch>
+        </p:blipFill>
+        <p:spPr>
+          <a:xfrm>
+            <a:off x="658368" y="1993392"/>
+            <a:ext cx="6601968" cy="2096024"/>
+          </a:xfrm>
+          <a:prstGeom prst="rect">
+            <a:avLst/>
+          </a:prstGeom>
+        </p:spPr>
+      </p:pic>
+      <p:sp>
+        <p:nvSpPr>
+          <p:cNvPr id="8" name="TextBox 7"/>
           <p:cNvSpPr txBox="1"/>
           <p:nvPr/>
         </p:nvSpPr>
         <p:spPr>
           <a:xfrm>
-            <a:off x="3410712" y="1581912"/>
-            <a:ext cx="2093976" cy="228600"/>
+            <a:off x="658368" y="4315968"/>
+            <a:ext cx="6583680" cy="201168"/>
           </a:xfrm>
           <a:prstGeom prst="rect">
             <a:avLst/>
@@ -4882,95 +4172,27 @@
           <a:lstStyle/>
           <a:p>
             <a:r>
-              <a:rPr sz="1500" b="1">
+              <a:rPr sz="1200" b="0">
                 <a:solidFill>
                   <a:srgbClr val="475569"/>
                 </a:solidFill>
                 <a:latin typeface="Aptos"/>
               </a:rPr>
-              <a:t>Avg right shift</a:t>
-            </a:r>
-          </a:p>
-        </p:txBody>
-      </p:sp>
-      <p:sp>
-        <p:nvSpPr>
-          <p:cNvPr id="10" name="TextBox 9"/>
-          <p:cNvSpPr txBox="1"/>
-          <p:nvPr/>
-        </p:nvSpPr>
-        <p:spPr>
-          <a:xfrm>
-            <a:off x="3410712" y="1856232"/>
-            <a:ext cx="2093976" cy="411480"/>
-          </a:xfrm>
-          <a:prstGeom prst="rect">
-            <a:avLst/>
-          </a:prstGeom>
-          <a:noFill/>
-        </p:spPr>
-        <p:txBody>
-          <a:bodyPr wrap="square" lIns="18288" rIns="18288" tIns="18288" bIns="18288">
-            <a:spAutoFit/>
-          </a:bodyPr>
-          <a:lstStyle/>
-          <a:p>
-            <a:r>
-              <a:rPr sz="3100" b="1">
-                <a:solidFill>
-                  <a:srgbClr val="059669"/>
-                </a:solidFill>
-                <a:latin typeface="Aptos"/>
-              </a:rPr>
-              <a:t>0.95 m</a:t>
-            </a:r>
-          </a:p>
-        </p:txBody>
-      </p:sp>
-      <p:sp>
-        <p:nvSpPr>
-          <p:cNvPr id="11" name="TextBox 10"/>
-          <p:cNvSpPr txBox="1"/>
-          <p:nvPr/>
-        </p:nvSpPr>
-        <p:spPr>
-          <a:xfrm>
-            <a:off x="3410712" y="2313432"/>
-            <a:ext cx="2093976" cy="228600"/>
-          </a:xfrm>
-          <a:prstGeom prst="rect">
-            <a:avLst/>
-          </a:prstGeom>
-          <a:noFill/>
-        </p:spPr>
-        <p:txBody>
-          <a:bodyPr wrap="square" lIns="18288" rIns="18288" tIns="18288" bIns="18288">
-            <a:spAutoFit/>
-          </a:bodyPr>
-          <a:lstStyle/>
-          <a:p>
-            <a:r>
-              <a:rPr sz="1300" b="0">
-                <a:solidFill>
-                  <a:srgbClr val="475569"/>
-                </a:solidFill>
-                <a:latin typeface="Aptos"/>
-              </a:rPr>
-              <a:t>vs 0.61 m without scene-aware</a:t>
-            </a:r>
-          </a:p>
-        </p:txBody>
-      </p:sp>
-      <p:sp>
-        <p:nvSpPr>
-          <p:cNvPr id="12" name="Rounded Rectangle 11"/>
+              <a:t>Input observation: clean front image vs patched front image</a:t>
+            </a:r>
+          </a:p>
+        </p:txBody>
+      </p:sp>
+      <p:sp>
+        <p:nvSpPr>
+          <p:cNvPr id="9" name="Rounded Rectangle 8"/>
           <p:cNvSpPr/>
           <p:nvPr/>
         </p:nvSpPr>
         <p:spPr>
           <a:xfrm>
-            <a:off x="5897880" y="1417320"/>
-            <a:ext cx="2423160" cy="960120"/>
+            <a:off x="7635240" y="1783080"/>
+            <a:ext cx="4069080" cy="4160520"/>
           </a:xfrm>
           <a:prstGeom prst="roundRect">
             <a:avLst/>
@@ -5006,16 +4228,40 @@
           </a:p>
         </p:txBody>
       </p:sp>
-      <p:sp>
-        <p:nvSpPr>
-          <p:cNvPr id="13" name="TextBox 12"/>
+      <p:pic>
+        <p:nvPicPr>
+          <p:cNvPr id="10" name="Picture 9" descr="01a7d01c_traj_overlay.png"/>
+          <p:cNvPicPr>
+            <a:picLocks noChangeAspect="1"/>
+          </p:cNvPicPr>
+          <p:nvPr/>
+        </p:nvPicPr>
+        <p:blipFill>
+          <a:blip r:embed="rId3"/>
+          <a:stretch>
+            <a:fillRect/>
+          </a:stretch>
+        </p:blipFill>
+        <p:spPr>
+          <a:xfrm>
+            <a:off x="7982712" y="1993392"/>
+            <a:ext cx="2725042" cy="3493008"/>
+          </a:xfrm>
+          <a:prstGeom prst="rect">
+            <a:avLst/>
+          </a:prstGeom>
+        </p:spPr>
+      </p:pic>
+      <p:sp>
+        <p:nvSpPr>
+          <p:cNvPr id="11" name="TextBox 10"/>
           <p:cNvSpPr txBox="1"/>
           <p:nvPr/>
         </p:nvSpPr>
         <p:spPr>
           <a:xfrm>
-            <a:off x="6062472" y="1581912"/>
-            <a:ext cx="2093976" cy="228600"/>
+            <a:off x="7891272" y="5559552"/>
+            <a:ext cx="3566160" cy="201168"/>
           </a:xfrm>
           <a:prstGeom prst="rect">
             <a:avLst/>
@@ -5028,96 +4274,29 @@
           </a:bodyPr>
           <a:lstStyle/>
           <a:p>
-            <a:r>
-              <a:rPr sz="1500" b="1">
+            <a:pPr algn="ctr"/>
+            <a:r>
+              <a:rPr sz="1200" b="0">
                 <a:solidFill>
                   <a:srgbClr val="475569"/>
                 </a:solidFill>
                 <a:latin typeface="Aptos"/>
               </a:rPr>
-              <a:t>Strong cases</a:t>
-            </a:r>
-          </a:p>
-        </p:txBody>
-      </p:sp>
-      <p:sp>
-        <p:nvSpPr>
-          <p:cNvPr id="14" name="TextBox 13"/>
-          <p:cNvSpPr txBox="1"/>
-          <p:nvPr/>
-        </p:nvSpPr>
-        <p:spPr>
-          <a:xfrm>
-            <a:off x="6062472" y="1856232"/>
-            <a:ext cx="2093976" cy="411480"/>
-          </a:xfrm>
-          <a:prstGeom prst="rect">
-            <a:avLst/>
-          </a:prstGeom>
-          <a:noFill/>
-        </p:spPr>
-        <p:txBody>
-          <a:bodyPr wrap="square" lIns="18288" rIns="18288" tIns="18288" bIns="18288">
-            <a:spAutoFit/>
-          </a:bodyPr>
-          <a:lstStyle/>
-          <a:p>
-            <a:r>
-              <a:rPr sz="3100" b="1">
-                <a:solidFill>
-                  <a:srgbClr val="D97706"/>
-                </a:solidFill>
-                <a:latin typeface="Aptos"/>
-              </a:rPr>
-              <a:t>2 / 5</a:t>
-            </a:r>
-          </a:p>
-        </p:txBody>
-      </p:sp>
-      <p:sp>
-        <p:nvSpPr>
-          <p:cNvPr id="15" name="TextBox 14"/>
-          <p:cNvSpPr txBox="1"/>
-          <p:nvPr/>
-        </p:nvSpPr>
-        <p:spPr>
-          <a:xfrm>
-            <a:off x="6062472" y="2313432"/>
-            <a:ext cx="2093976" cy="228600"/>
-          </a:xfrm>
-          <a:prstGeom prst="rect">
-            <a:avLst/>
-          </a:prstGeom>
-          <a:noFill/>
-        </p:spPr>
-        <p:txBody>
-          <a:bodyPr wrap="square" lIns="18288" rIns="18288" tIns="18288" bIns="18288">
-            <a:spAutoFit/>
-          </a:bodyPr>
-          <a:lstStyle/>
-          <a:p>
-            <a:r>
-              <a:rPr sz="1300" b="0">
-                <a:solidFill>
-                  <a:srgbClr val="475569"/>
-                </a:solidFill>
-                <a:latin typeface="Aptos"/>
-              </a:rPr>
-              <a:t>final shift &gt; 3 m</a:t>
-            </a:r>
-          </a:p>
-        </p:txBody>
-      </p:sp>
-      <p:sp>
-        <p:nvSpPr>
-          <p:cNvPr id="16" name="Rounded Rectangle 15"/>
+              <a:t>Trajectory overlay: GT / clean pred / attacked pred</a:t>
+            </a:r>
+          </a:p>
+        </p:txBody>
+      </p:sp>
+      <p:sp>
+        <p:nvSpPr>
+          <p:cNvPr id="12" name="Rounded Rectangle 11"/>
           <p:cNvSpPr/>
           <p:nvPr/>
         </p:nvSpPr>
         <p:spPr>
           <a:xfrm>
-            <a:off x="8549640" y="1417320"/>
-            <a:ext cx="2423160" cy="960120"/>
+            <a:off x="502920" y="4800600"/>
+            <a:ext cx="1783080" cy="566928"/>
           </a:xfrm>
           <a:prstGeom prst="roundRect">
             <a:avLst/>
@@ -5155,14 +4334,14 @@
       </p:sp>
       <p:sp>
         <p:nvSpPr>
-          <p:cNvPr id="17" name="TextBox 16"/>
+          <p:cNvPr id="13" name="TextBox 12"/>
           <p:cNvSpPr txBox="1"/>
           <p:nvPr/>
         </p:nvSpPr>
         <p:spPr>
           <a:xfrm>
-            <a:off x="8714232" y="1581912"/>
-            <a:ext cx="2093976" cy="228600"/>
+            <a:off x="612648" y="4882896"/>
+            <a:ext cx="713232" cy="182880"/>
           </a:xfrm>
           <a:prstGeom prst="rect">
             <a:avLst/>
@@ -5176,27 +4355,27 @@
           <a:lstStyle/>
           <a:p>
             <a:r>
-              <a:rPr sz="1500" b="1">
+              <a:rPr sz="1000" b="1">
                 <a:solidFill>
                   <a:srgbClr val="475569"/>
                 </a:solidFill>
                 <a:latin typeface="Aptos"/>
               </a:rPr>
-              <a:t>Best case</a:t>
-            </a:r>
-          </a:p>
-        </p:txBody>
-      </p:sp>
-      <p:sp>
-        <p:nvSpPr>
-          <p:cNvPr id="18" name="TextBox 17"/>
+              <a:t>final</a:t>
+            </a:r>
+          </a:p>
+        </p:txBody>
+      </p:sp>
+      <p:sp>
+        <p:nvSpPr>
+          <p:cNvPr id="14" name="TextBox 13"/>
           <p:cNvSpPr txBox="1"/>
           <p:nvPr/>
         </p:nvSpPr>
         <p:spPr>
           <a:xfrm>
-            <a:off x="8714232" y="1856232"/>
-            <a:ext cx="2093976" cy="411480"/>
+            <a:off x="1069848" y="4864608"/>
+            <a:ext cx="1115568" cy="320040"/>
           </a:xfrm>
           <a:prstGeom prst="rect">
             <a:avLst/>
@@ -5209,62 +4388,29 @@
           </a:bodyPr>
           <a:lstStyle/>
           <a:p>
-            <a:r>
-              <a:rPr sz="3100" b="1">
+            <a:pPr algn="r"/>
+            <a:r>
+              <a:rPr sz="1800" b="1">
                 <a:solidFill>
                   <a:srgbClr val="DC2626"/>
                 </a:solidFill>
                 <a:latin typeface="Aptos"/>
               </a:rPr>
-              <a:t>9.25 m</a:t>
-            </a:r>
-          </a:p>
-        </p:txBody>
-      </p:sp>
-      <p:sp>
-        <p:nvSpPr>
-          <p:cNvPr id="19" name="TextBox 18"/>
-          <p:cNvSpPr txBox="1"/>
-          <p:nvPr/>
-        </p:nvSpPr>
-        <p:spPr>
-          <a:xfrm>
-            <a:off x="8714232" y="2313432"/>
-            <a:ext cx="2093976" cy="228600"/>
-          </a:xfrm>
-          <a:prstGeom prst="rect">
-            <a:avLst/>
-          </a:prstGeom>
-          <a:noFill/>
-        </p:spPr>
-        <p:txBody>
-          <a:bodyPr wrap="square" lIns="18288" rIns="18288" tIns="18288" bIns="18288">
-            <a:spAutoFit/>
-          </a:bodyPr>
-          <a:lstStyle/>
-          <a:p>
-            <a:r>
-              <a:rPr sz="1300" b="0">
-                <a:solidFill>
-                  <a:srgbClr val="475569"/>
-                </a:solidFill>
-                <a:latin typeface="Aptos"/>
-              </a:rPr>
-              <a:t>final shift, 3.19 m right</a:t>
-            </a:r>
-          </a:p>
-        </p:txBody>
-      </p:sp>
-      <p:sp>
-        <p:nvSpPr>
-          <p:cNvPr id="20" name="Rounded Rectangle 19"/>
+              <a:t>3.69m</a:t>
+            </a:r>
+          </a:p>
+        </p:txBody>
+      </p:sp>
+      <p:sp>
+        <p:nvSpPr>
+          <p:cNvPr id="15" name="Rounded Rectangle 14"/>
           <p:cNvSpPr/>
           <p:nvPr/>
         </p:nvSpPr>
         <p:spPr>
           <a:xfrm>
-            <a:off x="594360" y="2788920"/>
-            <a:ext cx="5440680" cy="3154680"/>
+            <a:off x="2468880" y="4800600"/>
+            <a:ext cx="1783080" cy="566928"/>
           </a:xfrm>
           <a:prstGeom prst="roundRect">
             <a:avLst/>
@@ -5302,14 +4448,14 @@
       </p:sp>
       <p:sp>
         <p:nvSpPr>
-          <p:cNvPr id="21" name="TextBox 20"/>
+          <p:cNvPr id="16" name="TextBox 15"/>
           <p:cNvSpPr txBox="1"/>
           <p:nvPr/>
         </p:nvSpPr>
         <p:spPr>
           <a:xfrm>
-            <a:off x="841248" y="3063240"/>
-            <a:ext cx="4297680" cy="320040"/>
+            <a:off x="2578608" y="4882896"/>
+            <a:ext cx="713232" cy="182880"/>
           </a:xfrm>
           <a:prstGeom prst="rect">
             <a:avLst/>
@@ -5323,85 +4469,62 @@
           <a:lstStyle/>
           <a:p>
             <a:r>
-              <a:rPr sz="2200" b="1">
-                <a:solidFill>
-                  <a:srgbClr val="0F172A"/>
-                </a:solidFill>
-                <a:latin typeface="Aptos"/>
-              </a:rPr>
-              <a:t>Best case: horizon-center patch</a:t>
-            </a:r>
-          </a:p>
-        </p:txBody>
-      </p:sp>
-      <p:pic>
-        <p:nvPicPr>
-          <p:cNvPr id="22" name="Picture 21" descr="best_traj.jpg"/>
-          <p:cNvPicPr>
-            <a:picLocks noChangeAspect="1"/>
-          </p:cNvPicPr>
-          <p:nvPr/>
-        </p:nvPicPr>
-        <p:blipFill>
-          <a:blip r:embed="rId2"/>
-          <a:stretch>
-            <a:fillRect/>
-          </a:stretch>
-        </p:blipFill>
-        <p:spPr>
-          <a:xfrm>
-            <a:off x="822960" y="3657600"/>
-            <a:ext cx="4983480" cy="1943557"/>
-          </a:xfrm>
-          <a:prstGeom prst="rect">
-            <a:avLst/>
-          </a:prstGeom>
-        </p:spPr>
-      </p:pic>
-      <p:sp>
-        <p:nvSpPr>
-          <p:cNvPr id="23" name="TextBox 22"/>
-          <p:cNvSpPr txBox="1"/>
-          <p:nvPr/>
-        </p:nvSpPr>
-        <p:spPr>
-          <a:xfrm>
-            <a:off x="841248" y="5532120"/>
-            <a:ext cx="4389120" cy="228600"/>
-          </a:xfrm>
-          <a:prstGeom prst="rect">
-            <a:avLst/>
-          </a:prstGeom>
-          <a:noFill/>
-        </p:spPr>
-        <p:txBody>
-          <a:bodyPr wrap="square" lIns="18288" rIns="18288" tIns="18288" bIns="18288">
-            <a:spAutoFit/>
-          </a:bodyPr>
-          <a:lstStyle/>
-          <a:p>
-            <a:r>
-              <a:rPr sz="1400" b="0">
+              <a:rPr sz="1000" b="1">
                 <a:solidFill>
                   <a:srgbClr val="475569"/>
                 </a:solidFill>
                 <a:latin typeface="Aptos"/>
               </a:rPr>
-              <a:t>Token 01bbf47b: final 9.25 m, right +3.19 m</a:t>
-            </a:r>
-          </a:p>
-        </p:txBody>
-      </p:sp>
-      <p:sp>
-        <p:nvSpPr>
-          <p:cNvPr id="24" name="Rounded Rectangle 23"/>
+              <a:t>right</a:t>
+            </a:r>
+          </a:p>
+        </p:txBody>
+      </p:sp>
+      <p:sp>
+        <p:nvSpPr>
+          <p:cNvPr id="17" name="TextBox 16"/>
+          <p:cNvSpPr txBox="1"/>
+          <p:nvPr/>
+        </p:nvSpPr>
+        <p:spPr>
+          <a:xfrm>
+            <a:off x="3035808" y="4864608"/>
+            <a:ext cx="1115568" cy="320040"/>
+          </a:xfrm>
+          <a:prstGeom prst="rect">
+            <a:avLst/>
+          </a:prstGeom>
+          <a:noFill/>
+        </p:spPr>
+        <p:txBody>
+          <a:bodyPr wrap="square" lIns="18288" rIns="18288" tIns="18288" bIns="18288">
+            <a:spAutoFit/>
+          </a:bodyPr>
+          <a:lstStyle/>
+          <a:p>
+            <a:pPr algn="r"/>
+            <a:r>
+              <a:rPr sz="1800" b="1">
+                <a:solidFill>
+                  <a:srgbClr val="059669"/>
+                </a:solidFill>
+                <a:latin typeface="Aptos"/>
+              </a:rPr>
+              <a:t>+2.35m</a:t>
+            </a:r>
+          </a:p>
+        </p:txBody>
+      </p:sp>
+      <p:sp>
+        <p:nvSpPr>
+          <p:cNvPr id="18" name="Rounded Rectangle 17"/>
           <p:cNvSpPr/>
           <p:nvPr/>
         </p:nvSpPr>
         <p:spPr>
           <a:xfrm>
-            <a:off x="6446520" y="2788920"/>
-            <a:ext cx="5166360" cy="3154680"/>
+            <a:off x="4434840" y="4800600"/>
+            <a:ext cx="1783080" cy="566928"/>
           </a:xfrm>
           <a:prstGeom prst="roundRect">
             <a:avLst/>
@@ -5439,14 +4562,14 @@
       </p:sp>
       <p:sp>
         <p:nvSpPr>
-          <p:cNvPr id="25" name="TextBox 24"/>
+          <p:cNvPr id="19" name="TextBox 18"/>
           <p:cNvSpPr txBox="1"/>
           <p:nvPr/>
         </p:nvSpPr>
         <p:spPr>
           <a:xfrm>
-            <a:off x="6693408" y="3063240"/>
-            <a:ext cx="4389120" cy="320040"/>
+            <a:off x="4544568" y="4882896"/>
+            <a:ext cx="713232" cy="182880"/>
           </a:xfrm>
           <a:prstGeom prst="rect">
             <a:avLst/>
@@ -5460,95 +4583,72 @@
           <a:lstStyle/>
           <a:p>
             <a:r>
-              <a:rPr sz="2200" b="1">
-                <a:solidFill>
-                  <a:srgbClr val="0F172A"/>
-                </a:solidFill>
-                <a:latin typeface="Aptos"/>
-              </a:rPr>
-              <a:t>Scene-aware gain: construction cue</a:t>
-            </a:r>
-          </a:p>
-        </p:txBody>
-      </p:sp>
-      <p:pic>
-        <p:nvPicPr>
-          <p:cNvPr id="26" name="Picture 25" descr="sceneaware_traj.jpg"/>
-          <p:cNvPicPr>
-            <a:picLocks noChangeAspect="1"/>
-          </p:cNvPicPr>
-          <p:nvPr/>
-        </p:nvPicPr>
-        <p:blipFill>
-          <a:blip r:embed="rId3"/>
-          <a:stretch>
-            <a:fillRect/>
-          </a:stretch>
-        </p:blipFill>
-        <p:spPr>
-          <a:xfrm>
-            <a:off x="6675120" y="3657600"/>
-            <a:ext cx="4709160" cy="1836572"/>
-          </a:xfrm>
-          <a:prstGeom prst="rect">
-            <a:avLst/>
-          </a:prstGeom>
-        </p:spPr>
-      </p:pic>
-      <p:sp>
-        <p:nvSpPr>
-          <p:cNvPr id="27" name="TextBox 26"/>
-          <p:cNvSpPr txBox="1"/>
-          <p:nvPr/>
-        </p:nvSpPr>
-        <p:spPr>
-          <a:xfrm>
-            <a:off x="6693408" y="5532120"/>
-            <a:ext cx="4480560" cy="228600"/>
-          </a:xfrm>
-          <a:prstGeom prst="rect">
-            <a:avLst/>
-          </a:prstGeom>
-          <a:noFill/>
-        </p:spPr>
-        <p:txBody>
-          <a:bodyPr wrap="square" lIns="18288" rIns="18288" tIns="18288" bIns="18288">
-            <a:spAutoFit/>
-          </a:bodyPr>
-          <a:lstStyle/>
-          <a:p>
-            <a:r>
-              <a:rPr sz="1400" b="0">
+              <a:rPr sz="1000" b="1">
                 <a:solidFill>
                   <a:srgbClr val="475569"/>
                 </a:solidFill>
                 <a:latin typeface="Aptos"/>
               </a:rPr>
-              <a:t>Token 01a7d01c: scene-aware improves final 1.31 m -&gt; 3.69 m</a:t>
-            </a:r>
-          </a:p>
-        </p:txBody>
-      </p:sp>
-      <p:sp>
-        <p:nvSpPr>
-          <p:cNvPr id="28" name="Rounded Rectangle 27"/>
+              <a:t>mean</a:t>
+            </a:r>
+          </a:p>
+        </p:txBody>
+      </p:sp>
+      <p:sp>
+        <p:nvSpPr>
+          <p:cNvPr id="20" name="TextBox 19"/>
+          <p:cNvSpPr txBox="1"/>
+          <p:nvPr/>
+        </p:nvSpPr>
+        <p:spPr>
+          <a:xfrm>
+            <a:off x="5001768" y="4864608"/>
+            <a:ext cx="1115568" cy="320040"/>
+          </a:xfrm>
+          <a:prstGeom prst="rect">
+            <a:avLst/>
+          </a:prstGeom>
+          <a:noFill/>
+        </p:spPr>
+        <p:txBody>
+          <a:bodyPr wrap="square" lIns="18288" rIns="18288" tIns="18288" bIns="18288">
+            <a:spAutoFit/>
+          </a:bodyPr>
+          <a:lstStyle/>
+          <a:p>
+            <a:pPr algn="r"/>
+            <a:r>
+              <a:rPr sz="1800" b="1">
+                <a:solidFill>
+                  <a:srgbClr val="2563EB"/>
+                </a:solidFill>
+                <a:latin typeface="Aptos"/>
+              </a:rPr>
+              <a:t>1.47m</a:t>
+            </a:r>
+          </a:p>
+        </p:txBody>
+      </p:sp>
+      <p:sp>
+        <p:nvSpPr>
+          <p:cNvPr id="21" name="Rounded Rectangle 20"/>
           <p:cNvSpPr/>
           <p:nvPr/>
         </p:nvSpPr>
         <p:spPr>
           <a:xfrm>
-            <a:off x="594360" y="6080760"/>
-            <a:ext cx="11018520" cy="429768"/>
+            <a:off x="502920" y="5532120"/>
+            <a:ext cx="6903720" cy="566928"/>
           </a:xfrm>
           <a:prstGeom prst="roundRect">
             <a:avLst/>
           </a:prstGeom>
           <a:solidFill>
-            <a:srgbClr val="EFF6FF"/>
+            <a:srgbClr val="FFFFFF"/>
           </a:solidFill>
           <a:ln w="12700">
             <a:solidFill>
-              <a:srgbClr val="93C5FD"/>
+              <a:srgbClr val="CBD5E1"/>
             </a:solidFill>
           </a:ln>
         </p:spPr>
@@ -5576,14 +4676,14 @@
       </p:sp>
       <p:sp>
         <p:nvSpPr>
-          <p:cNvPr id="29" name="TextBox 28"/>
+          <p:cNvPr id="22" name="TextBox 21"/>
           <p:cNvSpPr txBox="1"/>
           <p:nvPr/>
         </p:nvSpPr>
         <p:spPr>
           <a:xfrm>
-            <a:off x="777240" y="6181344"/>
-            <a:ext cx="10561320" cy="228600"/>
+            <a:off x="685800" y="5660136"/>
+            <a:ext cx="6446520" cy="310896"/>
           </a:xfrm>
           <a:prstGeom prst="rect">
             <a:avLst/>
@@ -5597,13 +4697,48 @@
           <a:lstStyle/>
           <a:p>
             <a:r>
-              <a:rPr sz="1500" b="1">
+              <a:rPr sz="1200" b="1">
                 <a:solidFill>
                   <a:srgbClr val="0F172A"/>
                 </a:solidFill>
                 <a:latin typeface="Aptos"/>
               </a:rPr>
-              <a:t>Takeaway: scene-aware placement improves targeted lateral shift, but black-box front-only attacks remain inconsistent. Next: object-aware placement for cars, pedestrians, and traffic lights.</a:t>
+              <a:t>Compared with fixed placement, scene-aware placement increases final shift from 1.31 m to 3.69 m.</a:t>
+            </a:r>
+          </a:p>
+        </p:txBody>
+      </p:sp>
+      <p:sp>
+        <p:nvSpPr>
+          <p:cNvPr id="23" name="TextBox 22"/>
+          <p:cNvSpPr txBox="1"/>
+          <p:nvPr/>
+        </p:nvSpPr>
+        <p:spPr>
+          <a:xfrm>
+            <a:off x="10835640" y="329184"/>
+            <a:ext cx="822960" cy="201168"/>
+          </a:xfrm>
+          <a:prstGeom prst="rect">
+            <a:avLst/>
+          </a:prstGeom>
+          <a:noFill/>
+        </p:spPr>
+        <p:txBody>
+          <a:bodyPr wrap="square" lIns="18288" rIns="18288" tIns="18288" bIns="18288">
+            <a:spAutoFit/>
+          </a:bodyPr>
+          <a:lstStyle/>
+          <a:p>
+            <a:pPr algn="r"/>
+            <a:r>
+              <a:rPr sz="1100" b="1">
+                <a:solidFill>
+                  <a:srgbClr val="475569"/>
+                </a:solidFill>
+                <a:latin typeface="Aptos"/>
+              </a:rPr>
+              <a:t>01a7d01c</a:t>
             </a:r>
           </a:p>
         </p:txBody>

</xml_diff>

<commit_message>
Simplify AutoVLA attack showcase slides
</commit_message>
<xml_diff>
--- a/report/autovla_blackbox_attack_2slides.pptx
+++ b/report/autovla_blackbox_attack_2slides.pptx
@@ -3085,7 +3085,7 @@
     <p:bg>
       <p:bgPr>
         <a:solidFill>
-          <a:srgbClr val="F8FAFC"/>
+          <a:srgbClr val="FFFFFF"/>
         </a:solidFill>
         <a:effectLst/>
       </p:bgPr>
@@ -3105,8 +3105,8 @@
         </p:nvSpPr>
         <p:spPr>
           <a:xfrm>
-            <a:off x="502920" y="292608"/>
-            <a:ext cx="8138160" cy="411480"/>
+            <a:off x="502920" y="320040"/>
+            <a:ext cx="8961120" cy="384048"/>
           </a:xfrm>
           <a:prstGeom prst="rect">
             <a:avLst/>
@@ -3114,7 +3114,7 @@
           <a:noFill/>
         </p:spPr>
         <p:txBody>
-          <a:bodyPr wrap="square" lIns="18288" rIns="18288" tIns="18288" bIns="18288">
+          <a:bodyPr wrap="square" lIns="0" rIns="0" tIns="0" bIns="0">
             <a:spAutoFit/>
           </a:bodyPr>
           <a:lstStyle/>
@@ -3126,7 +3126,7 @@
                 </a:solidFill>
                 <a:latin typeface="Aptos"/>
               </a:rPr>
-              <a:t>Showcase 1: Strongest Black-box Patch Effect</a:t>
+              <a:t>Showcase 1: Strongest black-box patch effect</a:t>
             </a:r>
           </a:p>
         </p:txBody>
@@ -3139,8 +3139,8 @@
         </p:nvSpPr>
         <p:spPr>
           <a:xfrm>
-            <a:off x="521207" y="749808"/>
-            <a:ext cx="7680960" cy="256032"/>
+            <a:off x="10607040" y="384048"/>
+            <a:ext cx="1051560" cy="201168"/>
           </a:xfrm>
           <a:prstGeom prst="rect">
             <a:avLst/>
@@ -3148,7 +3148,42 @@
           <a:noFill/>
         </p:spPr>
         <p:txBody>
-          <a:bodyPr wrap="square" lIns="18288" rIns="18288" tIns="18288" bIns="18288">
+          <a:bodyPr wrap="square" lIns="0" rIns="0" tIns="0" bIns="0">
+            <a:spAutoFit/>
+          </a:bodyPr>
+          <a:lstStyle/>
+          <a:p>
+            <a:pPr algn="r"/>
+            <a:r>
+              <a:rPr sz="1100" b="1">
+                <a:solidFill>
+                  <a:srgbClr val="475569"/>
+                </a:solidFill>
+                <a:latin typeface="Aptos"/>
+              </a:rPr>
+              <a:t>01bbf47b</a:t>
+            </a:r>
+          </a:p>
+        </p:txBody>
+      </p:sp>
+      <p:sp>
+        <p:nvSpPr>
+          <p:cNvPr id="4" name="TextBox 3"/>
+          <p:cNvSpPr txBox="1"/>
+          <p:nvPr/>
+        </p:nvSpPr>
+        <p:spPr>
+          <a:xfrm>
+            <a:off x="521207" y="749808"/>
+            <a:ext cx="10607040" cy="256032"/>
+          </a:xfrm>
+          <a:prstGeom prst="rect">
+            <a:avLst/>
+          </a:prstGeom>
+          <a:noFill/>
+        </p:spPr>
+        <p:txBody>
+          <a:bodyPr wrap="square" lIns="0" rIns="0" tIns="0" bIns="0">
             <a:spAutoFit/>
           </a:bodyPr>
           <a:lstStyle/>
@@ -3160,138 +3195,49 @@
                 </a:solidFill>
                 <a:latin typeface="Aptos"/>
               </a:rPr>
-              <a:t>Horizon-center patch on front camera causes a large final trajectory deviation.</a:t>
-            </a:r>
-          </a:p>
-        </p:txBody>
-      </p:sp>
-      <p:sp>
-        <p:nvSpPr>
-          <p:cNvPr id="4" name="Rounded Rectangle 3"/>
-          <p:cNvSpPr/>
+              <a:t>Front-camera patch; final shift 9.25 m, right shift +3.19 m.</a:t>
+            </a:r>
+          </a:p>
+        </p:txBody>
+      </p:sp>
+      <p:cxnSp>
+        <p:nvCxnSpPr>
+          <p:cNvPr id="5" name="Connector 4"/>
+          <p:cNvCxnSpPr/>
           <p:nvPr/>
-        </p:nvSpPr>
+        </p:nvCxnSpPr>
         <p:spPr>
           <a:xfrm>
-            <a:off x="502920" y="1078992"/>
-            <a:ext cx="11201400" cy="493776"/>
+            <a:off x="502920" y="1124712"/>
+            <a:ext cx="11183112" cy="0"/>
           </a:xfrm>
-          <a:prstGeom prst="roundRect">
+          <a:prstGeom prst="line">
             <a:avLst/>
           </a:prstGeom>
-          <a:solidFill>
-            <a:srgbClr val="EFF6FF"/>
-          </a:solidFill>
           <a:ln w="12700">
             <a:solidFill>
-              <a:srgbClr val="BFDBFE"/>
+              <a:srgbClr val="E2E8F0"/>
             </a:solidFill>
           </a:ln>
         </p:spPr>
         <p:style>
-          <a:lnRef idx="1">
+          <a:lnRef idx="2">
             <a:schemeClr val="accent1"/>
           </a:lnRef>
-          <a:fillRef idx="3">
+          <a:fillRef idx="0">
             <a:schemeClr val="accent1"/>
           </a:fillRef>
-          <a:effectRef idx="2">
+          <a:effectRef idx="1">
             <a:schemeClr val="accent1"/>
           </a:effectRef>
           <a:fontRef idx="minor">
-            <a:schemeClr val="lt1"/>
+            <a:schemeClr val="tx1"/>
           </a:fontRef>
         </p:style>
-        <p:txBody>
-          <a:bodyPr rtlCol="0" anchor="ctr"/>
-          <a:lstStyle/>
-          <a:p>
-            <a:pPr algn="ctr"/>
-          </a:p>
-        </p:txBody>
-      </p:sp>
-      <p:sp>
-        <p:nvSpPr>
-          <p:cNvPr id="5" name="TextBox 4"/>
-          <p:cNvSpPr txBox="1"/>
-          <p:nvPr/>
-        </p:nvSpPr>
-        <p:spPr>
-          <a:xfrm>
-            <a:off x="713232" y="1234440"/>
-            <a:ext cx="10607040" cy="201168"/>
-          </a:xfrm>
-          <a:prstGeom prst="rect">
-            <a:avLst/>
-          </a:prstGeom>
-          <a:noFill/>
-        </p:spPr>
-        <p:txBody>
-          <a:bodyPr wrap="square" lIns="18288" rIns="18288" tIns="18288" bIns="18288">
-            <a:spAutoFit/>
-          </a:bodyPr>
-          <a:lstStyle/>
-          <a:p>
-            <a:r>
-              <a:rPr sz="1300" b="1">
-                <a:solidFill>
-                  <a:srgbClr val="0F172A"/>
-                </a:solidFill>
-                <a:latin typeface="Aptos"/>
-              </a:rPr>
-              <a:t>Black-box: front camera only | no gradients | position sweep | trajectory-shift objective</a:t>
-            </a:r>
-          </a:p>
-        </p:txBody>
-      </p:sp>
-      <p:sp>
-        <p:nvSpPr>
-          <p:cNvPr id="6" name="Rounded Rectangle 5"/>
-          <p:cNvSpPr/>
-          <p:nvPr/>
-        </p:nvSpPr>
-        <p:spPr>
-          <a:xfrm>
-            <a:off x="502920" y="1783080"/>
-            <a:ext cx="6903720" cy="2788920"/>
-          </a:xfrm>
-          <a:prstGeom prst="roundRect">
-            <a:avLst/>
-          </a:prstGeom>
-          <a:solidFill>
-            <a:srgbClr val="FFFFFF"/>
-          </a:solidFill>
-          <a:ln w="12700">
-            <a:solidFill>
-              <a:srgbClr val="CBD5E1"/>
-            </a:solidFill>
-          </a:ln>
-        </p:spPr>
-        <p:style>
-          <a:lnRef idx="1">
-            <a:schemeClr val="accent1"/>
-          </a:lnRef>
-          <a:fillRef idx="3">
-            <a:schemeClr val="accent1"/>
-          </a:fillRef>
-          <a:effectRef idx="2">
-            <a:schemeClr val="accent1"/>
-          </a:effectRef>
-          <a:fontRef idx="minor">
-            <a:schemeClr val="lt1"/>
-          </a:fontRef>
-        </p:style>
-        <p:txBody>
-          <a:bodyPr rtlCol="0" anchor="ctr"/>
-          <a:lstStyle/>
-          <a:p>
-            <a:pPr algn="ctr"/>
-          </a:p>
-        </p:txBody>
-      </p:sp>
+      </p:cxnSp>
       <p:pic>
         <p:nvPicPr>
-          <p:cNvPr id="7" name="Picture 6" descr="01bbf47b_inputs.jpg"/>
+          <p:cNvPr id="6" name="Picture 5" descr="01bbf47b_inputs.jpg"/>
           <p:cNvPicPr>
             <a:picLocks noChangeAspect="1"/>
           </p:cNvPicPr>
@@ -3305,96 +3251,17 @@
         </p:blipFill>
         <p:spPr>
           <a:xfrm>
-            <a:off x="658368" y="1993392"/>
-            <a:ext cx="6601968" cy="2096024"/>
+            <a:off x="502920" y="1353312"/>
+            <a:ext cx="6812280" cy="2162794"/>
           </a:xfrm>
           <a:prstGeom prst="rect">
             <a:avLst/>
           </a:prstGeom>
         </p:spPr>
       </p:pic>
-      <p:sp>
-        <p:nvSpPr>
-          <p:cNvPr id="8" name="TextBox 7"/>
-          <p:cNvSpPr txBox="1"/>
-          <p:nvPr/>
-        </p:nvSpPr>
-        <p:spPr>
-          <a:xfrm>
-            <a:off x="658368" y="4315968"/>
-            <a:ext cx="6583680" cy="201168"/>
-          </a:xfrm>
-          <a:prstGeom prst="rect">
-            <a:avLst/>
-          </a:prstGeom>
-          <a:noFill/>
-        </p:spPr>
-        <p:txBody>
-          <a:bodyPr wrap="square" lIns="18288" rIns="18288" tIns="18288" bIns="18288">
-            <a:spAutoFit/>
-          </a:bodyPr>
-          <a:lstStyle/>
-          <a:p>
-            <a:r>
-              <a:rPr sz="1200" b="0">
-                <a:solidFill>
-                  <a:srgbClr val="475569"/>
-                </a:solidFill>
-                <a:latin typeface="Aptos"/>
-              </a:rPr>
-              <a:t>Input observation: clean front image vs patched front image</a:t>
-            </a:r>
-          </a:p>
-        </p:txBody>
-      </p:sp>
-      <p:sp>
-        <p:nvSpPr>
-          <p:cNvPr id="9" name="Rounded Rectangle 8"/>
-          <p:cNvSpPr/>
-          <p:nvPr/>
-        </p:nvSpPr>
-        <p:spPr>
-          <a:xfrm>
-            <a:off x="7635240" y="1783080"/>
-            <a:ext cx="4069080" cy="4160520"/>
-          </a:xfrm>
-          <a:prstGeom prst="roundRect">
-            <a:avLst/>
-          </a:prstGeom>
-          <a:solidFill>
-            <a:srgbClr val="FFFFFF"/>
-          </a:solidFill>
-          <a:ln w="12700">
-            <a:solidFill>
-              <a:srgbClr val="CBD5E1"/>
-            </a:solidFill>
-          </a:ln>
-        </p:spPr>
-        <p:style>
-          <a:lnRef idx="1">
-            <a:schemeClr val="accent1"/>
-          </a:lnRef>
-          <a:fillRef idx="3">
-            <a:schemeClr val="accent1"/>
-          </a:fillRef>
-          <a:effectRef idx="2">
-            <a:schemeClr val="accent1"/>
-          </a:effectRef>
-          <a:fontRef idx="minor">
-            <a:schemeClr val="lt1"/>
-          </a:fontRef>
-        </p:style>
-        <p:txBody>
-          <a:bodyPr rtlCol="0" anchor="ctr"/>
-          <a:lstStyle/>
-          <a:p>
-            <a:pPr algn="ctr"/>
-          </a:p>
-        </p:txBody>
-      </p:sp>
       <p:pic>
         <p:nvPicPr>
-          <p:cNvPr id="10" name="Picture 9" descr="01bbf47b_traj_overlay.png"/>
+          <p:cNvPr id="7" name="Picture 6" descr="01bbf47b_traj_overlay.png"/>
           <p:cNvPicPr>
             <a:picLocks noChangeAspect="1"/>
           </p:cNvPicPr>
@@ -3408,8 +3275,8 @@
         </p:blipFill>
         <p:spPr>
           <a:xfrm>
-            <a:off x="7982712" y="1993392"/>
-            <a:ext cx="2725042" cy="3493008"/>
+            <a:off x="7635240" y="1234440"/>
+            <a:ext cx="3745149" cy="4800600"/>
           </a:xfrm>
           <a:prstGeom prst="rect">
             <a:avLst/>
@@ -3418,14 +3285,14 @@
       </p:pic>
       <p:sp>
         <p:nvSpPr>
-          <p:cNvPr id="11" name="TextBox 10"/>
+          <p:cNvPr id="8" name="TextBox 7"/>
           <p:cNvSpPr txBox="1"/>
           <p:nvPr/>
         </p:nvSpPr>
         <p:spPr>
           <a:xfrm>
-            <a:off x="7891272" y="5559552"/>
-            <a:ext cx="3566160" cy="201168"/>
+            <a:off x="502920" y="6199632"/>
+            <a:ext cx="6812280" cy="201168"/>
           </a:xfrm>
           <a:prstGeom prst="rect">
             <a:avLst/>
@@ -3433,79 +3300,34 @@
           <a:noFill/>
         </p:spPr>
         <p:txBody>
-          <a:bodyPr wrap="square" lIns="18288" rIns="18288" tIns="18288" bIns="18288">
+          <a:bodyPr wrap="square" lIns="0" rIns="0" tIns="0" bIns="0">
             <a:spAutoFit/>
           </a:bodyPr>
           <a:lstStyle/>
           <a:p>
             <a:pPr algn="ctr"/>
             <a:r>
-              <a:rPr sz="1200" b="0">
+              <a:rPr sz="1300" b="0">
                 <a:solidFill>
                   <a:srgbClr val="475569"/>
                 </a:solidFill>
                 <a:latin typeface="Aptos"/>
               </a:rPr>
-              <a:t>Trajectory overlay: GT / clean pred / attacked pred</a:t>
-            </a:r>
-          </a:p>
-        </p:txBody>
-      </p:sp>
-      <p:sp>
-        <p:nvSpPr>
-          <p:cNvPr id="12" name="Rounded Rectangle 11"/>
-          <p:cNvSpPr/>
+              <a:t>Clean front input  |  Patched front input</a:t>
+            </a:r>
+          </a:p>
+        </p:txBody>
+      </p:sp>
+      <p:sp>
+        <p:nvSpPr>
+          <p:cNvPr id="9" name="TextBox 8"/>
+          <p:cNvSpPr txBox="1"/>
           <p:nvPr/>
         </p:nvSpPr>
         <p:spPr>
           <a:xfrm>
-            <a:off x="502920" y="4800600"/>
-            <a:ext cx="1783080" cy="566928"/>
-          </a:xfrm>
-          <a:prstGeom prst="roundRect">
-            <a:avLst/>
-          </a:prstGeom>
-          <a:solidFill>
-            <a:srgbClr val="FFFFFF"/>
-          </a:solidFill>
-          <a:ln w="12700">
-            <a:solidFill>
-              <a:srgbClr val="CBD5E1"/>
-            </a:solidFill>
-          </a:ln>
-        </p:spPr>
-        <p:style>
-          <a:lnRef idx="1">
-            <a:schemeClr val="accent1"/>
-          </a:lnRef>
-          <a:fillRef idx="3">
-            <a:schemeClr val="accent1"/>
-          </a:fillRef>
-          <a:effectRef idx="2">
-            <a:schemeClr val="accent1"/>
-          </a:effectRef>
-          <a:fontRef idx="minor">
-            <a:schemeClr val="lt1"/>
-          </a:fontRef>
-        </p:style>
-        <p:txBody>
-          <a:bodyPr rtlCol="0" anchor="ctr"/>
-          <a:lstStyle/>
-          <a:p>
-            <a:pPr algn="ctr"/>
-          </a:p>
-        </p:txBody>
-      </p:sp>
-      <p:sp>
-        <p:nvSpPr>
-          <p:cNvPr id="13" name="TextBox 12"/>
-          <p:cNvSpPr txBox="1"/>
-          <p:nvPr/>
-        </p:nvSpPr>
-        <p:spPr>
-          <a:xfrm>
-            <a:off x="612648" y="4882896"/>
-            <a:ext cx="713232" cy="182880"/>
+            <a:off x="7635240" y="6199632"/>
+            <a:ext cx="3840480" cy="201168"/>
           </a:xfrm>
           <a:prstGeom prst="rect">
             <a:avLst/>
@@ -3513,33 +3335,34 @@
           <a:noFill/>
         </p:spPr>
         <p:txBody>
-          <a:bodyPr wrap="square" lIns="18288" rIns="18288" tIns="18288" bIns="18288">
+          <a:bodyPr wrap="square" lIns="0" rIns="0" tIns="0" bIns="0">
             <a:spAutoFit/>
           </a:bodyPr>
           <a:lstStyle/>
           <a:p>
-            <a:r>
-              <a:rPr sz="1000" b="1">
+            <a:pPr algn="ctr"/>
+            <a:r>
+              <a:rPr sz="1300" b="0">
                 <a:solidFill>
                   <a:srgbClr val="475569"/>
                 </a:solidFill>
                 <a:latin typeface="Aptos"/>
               </a:rPr>
-              <a:t>final</a:t>
-            </a:r>
-          </a:p>
-        </p:txBody>
-      </p:sp>
-      <p:sp>
-        <p:nvSpPr>
-          <p:cNvPr id="14" name="TextBox 13"/>
+              <a:t>GT / clean prediction / attacked prediction</a:t>
+            </a:r>
+          </a:p>
+        </p:txBody>
+      </p:sp>
+      <p:sp>
+        <p:nvSpPr>
+          <p:cNvPr id="10" name="TextBox 9"/>
           <p:cNvSpPr txBox="1"/>
           <p:nvPr/>
         </p:nvSpPr>
         <p:spPr>
           <a:xfrm>
-            <a:off x="1069848" y="4864608"/>
-            <a:ext cx="1115568" cy="320040"/>
+            <a:off x="502920" y="6519672"/>
+            <a:ext cx="11155680" cy="201168"/>
           </a:xfrm>
           <a:prstGeom prst="rect">
             <a:avLst/>
@@ -3547,362 +3370,20 @@
           <a:noFill/>
         </p:spPr>
         <p:txBody>
-          <a:bodyPr wrap="square" lIns="18288" rIns="18288" tIns="18288" bIns="18288">
+          <a:bodyPr wrap="square" lIns="0" rIns="0" tIns="0" bIns="0">
             <a:spAutoFit/>
           </a:bodyPr>
           <a:lstStyle/>
           <a:p>
-            <a:pPr algn="r"/>
-            <a:r>
-              <a:rPr sz="1800" b="1">
-                <a:solidFill>
-                  <a:srgbClr val="DC2626"/>
-                </a:solidFill>
-                <a:latin typeface="Aptos"/>
-              </a:rPr>
-              <a:t>9.25m</a:t>
-            </a:r>
-          </a:p>
-        </p:txBody>
-      </p:sp>
-      <p:sp>
-        <p:nvSpPr>
-          <p:cNvPr id="15" name="Rounded Rectangle 14"/>
-          <p:cNvSpPr/>
-          <p:nvPr/>
-        </p:nvSpPr>
-        <p:spPr>
-          <a:xfrm>
-            <a:off x="2468880" y="4800600"/>
-            <a:ext cx="1783080" cy="566928"/>
-          </a:xfrm>
-          <a:prstGeom prst="roundRect">
-            <a:avLst/>
-          </a:prstGeom>
-          <a:solidFill>
-            <a:srgbClr val="FFFFFF"/>
-          </a:solidFill>
-          <a:ln w="12700">
-            <a:solidFill>
-              <a:srgbClr val="CBD5E1"/>
-            </a:solidFill>
-          </a:ln>
-        </p:spPr>
-        <p:style>
-          <a:lnRef idx="1">
-            <a:schemeClr val="accent1"/>
-          </a:lnRef>
-          <a:fillRef idx="3">
-            <a:schemeClr val="accent1"/>
-          </a:fillRef>
-          <a:effectRef idx="2">
-            <a:schemeClr val="accent1"/>
-          </a:effectRef>
-          <a:fontRef idx="minor">
-            <a:schemeClr val="lt1"/>
-          </a:fontRef>
-        </p:style>
-        <p:txBody>
-          <a:bodyPr rtlCol="0" anchor="ctr"/>
-          <a:lstStyle/>
-          <a:p>
             <a:pPr algn="ctr"/>
-          </a:p>
-        </p:txBody>
-      </p:sp>
-      <p:sp>
-        <p:nvSpPr>
-          <p:cNvPr id="16" name="TextBox 15"/>
-          <p:cNvSpPr txBox="1"/>
-          <p:nvPr/>
-        </p:nvSpPr>
-        <p:spPr>
-          <a:xfrm>
-            <a:off x="2578608" y="4882896"/>
-            <a:ext cx="713232" cy="182880"/>
-          </a:xfrm>
-          <a:prstGeom prst="rect">
-            <a:avLst/>
-          </a:prstGeom>
-          <a:noFill/>
-        </p:spPr>
-        <p:txBody>
-          <a:bodyPr wrap="square" lIns="18288" rIns="18288" tIns="18288" bIns="18288">
-            <a:spAutoFit/>
-          </a:bodyPr>
-          <a:lstStyle/>
-          <a:p>
-            <a:r>
-              <a:rPr sz="1000" b="1">
-                <a:solidFill>
-                  <a:srgbClr val="475569"/>
-                </a:solidFill>
-                <a:latin typeface="Aptos"/>
-              </a:rPr>
-              <a:t>right</a:t>
-            </a:r>
-          </a:p>
-        </p:txBody>
-      </p:sp>
-      <p:sp>
-        <p:nvSpPr>
-          <p:cNvPr id="17" name="TextBox 16"/>
-          <p:cNvSpPr txBox="1"/>
-          <p:nvPr/>
-        </p:nvSpPr>
-        <p:spPr>
-          <a:xfrm>
-            <a:off x="3035808" y="4864608"/>
-            <a:ext cx="1115568" cy="320040"/>
-          </a:xfrm>
-          <a:prstGeom prst="rect">
-            <a:avLst/>
-          </a:prstGeom>
-          <a:noFill/>
-        </p:spPr>
-        <p:txBody>
-          <a:bodyPr wrap="square" lIns="18288" rIns="18288" tIns="18288" bIns="18288">
-            <a:spAutoFit/>
-          </a:bodyPr>
-          <a:lstStyle/>
-          <a:p>
-            <a:pPr algn="r"/>
-            <a:r>
-              <a:rPr sz="1800" b="1">
-                <a:solidFill>
-                  <a:srgbClr val="059669"/>
-                </a:solidFill>
-                <a:latin typeface="Aptos"/>
-              </a:rPr>
-              <a:t>+3.19m</a:t>
-            </a:r>
-          </a:p>
-        </p:txBody>
-      </p:sp>
-      <p:sp>
-        <p:nvSpPr>
-          <p:cNvPr id="18" name="Rounded Rectangle 17"/>
-          <p:cNvSpPr/>
-          <p:nvPr/>
-        </p:nvSpPr>
-        <p:spPr>
-          <a:xfrm>
-            <a:off x="4434840" y="4800600"/>
-            <a:ext cx="1783080" cy="566928"/>
-          </a:xfrm>
-          <a:prstGeom prst="roundRect">
-            <a:avLst/>
-          </a:prstGeom>
-          <a:solidFill>
-            <a:srgbClr val="FFFFFF"/>
-          </a:solidFill>
-          <a:ln w="12700">
-            <a:solidFill>
-              <a:srgbClr val="CBD5E1"/>
-            </a:solidFill>
-          </a:ln>
-        </p:spPr>
-        <p:style>
-          <a:lnRef idx="1">
-            <a:schemeClr val="accent1"/>
-          </a:lnRef>
-          <a:fillRef idx="3">
-            <a:schemeClr val="accent1"/>
-          </a:fillRef>
-          <a:effectRef idx="2">
-            <a:schemeClr val="accent1"/>
-          </a:effectRef>
-          <a:fontRef idx="minor">
-            <a:schemeClr val="lt1"/>
-          </a:fontRef>
-        </p:style>
-        <p:txBody>
-          <a:bodyPr rtlCol="0" anchor="ctr"/>
-          <a:lstStyle/>
-          <a:p>
-            <a:pPr algn="ctr"/>
-          </a:p>
-        </p:txBody>
-      </p:sp>
-      <p:sp>
-        <p:nvSpPr>
-          <p:cNvPr id="19" name="TextBox 18"/>
-          <p:cNvSpPr txBox="1"/>
-          <p:nvPr/>
-        </p:nvSpPr>
-        <p:spPr>
-          <a:xfrm>
-            <a:off x="4544568" y="4882896"/>
-            <a:ext cx="713232" cy="182880"/>
-          </a:xfrm>
-          <a:prstGeom prst="rect">
-            <a:avLst/>
-          </a:prstGeom>
-          <a:noFill/>
-        </p:spPr>
-        <p:txBody>
-          <a:bodyPr wrap="square" lIns="18288" rIns="18288" tIns="18288" bIns="18288">
-            <a:spAutoFit/>
-          </a:bodyPr>
-          <a:lstStyle/>
-          <a:p>
-            <a:r>
-              <a:rPr sz="1000" b="1">
-                <a:solidFill>
-                  <a:srgbClr val="475569"/>
-                </a:solidFill>
-                <a:latin typeface="Aptos"/>
-              </a:rPr>
-              <a:t>mean</a:t>
-            </a:r>
-          </a:p>
-        </p:txBody>
-      </p:sp>
-      <p:sp>
-        <p:nvSpPr>
-          <p:cNvPr id="20" name="TextBox 19"/>
-          <p:cNvSpPr txBox="1"/>
-          <p:nvPr/>
-        </p:nvSpPr>
-        <p:spPr>
-          <a:xfrm>
-            <a:off x="5001768" y="4864608"/>
-            <a:ext cx="1115568" cy="320040"/>
-          </a:xfrm>
-          <a:prstGeom prst="rect">
-            <a:avLst/>
-          </a:prstGeom>
-          <a:noFill/>
-        </p:spPr>
-        <p:txBody>
-          <a:bodyPr wrap="square" lIns="18288" rIns="18288" tIns="18288" bIns="18288">
-            <a:spAutoFit/>
-          </a:bodyPr>
-          <a:lstStyle/>
-          <a:p>
-            <a:pPr algn="r"/>
-            <a:r>
-              <a:rPr sz="1800" b="1">
-                <a:solidFill>
-                  <a:srgbClr val="2563EB"/>
-                </a:solidFill>
-                <a:latin typeface="Aptos"/>
-              </a:rPr>
-              <a:t>3.44m</a:t>
-            </a:r>
-          </a:p>
-        </p:txBody>
-      </p:sp>
-      <p:sp>
-        <p:nvSpPr>
-          <p:cNvPr id="21" name="Rounded Rectangle 20"/>
-          <p:cNvSpPr/>
-          <p:nvPr/>
-        </p:nvSpPr>
-        <p:spPr>
-          <a:xfrm>
-            <a:off x="502920" y="5532120"/>
-            <a:ext cx="6903720" cy="566928"/>
-          </a:xfrm>
-          <a:prstGeom prst="roundRect">
-            <a:avLst/>
-          </a:prstGeom>
-          <a:solidFill>
-            <a:srgbClr val="FFFFFF"/>
-          </a:solidFill>
-          <a:ln w="12700">
-            <a:solidFill>
-              <a:srgbClr val="CBD5E1"/>
-            </a:solidFill>
-          </a:ln>
-        </p:spPr>
-        <p:style>
-          <a:lnRef idx="1">
-            <a:schemeClr val="accent1"/>
-          </a:lnRef>
-          <a:fillRef idx="3">
-            <a:schemeClr val="accent1"/>
-          </a:fillRef>
-          <a:effectRef idx="2">
-            <a:schemeClr val="accent1"/>
-          </a:effectRef>
-          <a:fontRef idx="minor">
-            <a:schemeClr val="lt1"/>
-          </a:fontRef>
-        </p:style>
-        <p:txBody>
-          <a:bodyPr rtlCol="0" anchor="ctr"/>
-          <a:lstStyle/>
-          <a:p>
-            <a:pPr algn="ctr"/>
-          </a:p>
-        </p:txBody>
-      </p:sp>
-      <p:sp>
-        <p:nvSpPr>
-          <p:cNvPr id="22" name="TextBox 21"/>
-          <p:cNvSpPr txBox="1"/>
-          <p:nvPr/>
-        </p:nvSpPr>
-        <p:spPr>
-          <a:xfrm>
-            <a:off x="685800" y="5660136"/>
-            <a:ext cx="6446520" cy="310896"/>
-          </a:xfrm>
-          <a:prstGeom prst="rect">
-            <a:avLst/>
-          </a:prstGeom>
-          <a:noFill/>
-        </p:spPr>
-        <p:txBody>
-          <a:bodyPr wrap="square" lIns="18288" rIns="18288" tIns="18288" bIns="18288">
-            <a:spAutoFit/>
-          </a:bodyPr>
-          <a:lstStyle/>
-          <a:p>
-            <a:r>
-              <a:rPr sz="1200" b="1">
+            <a:r>
+              <a:rPr sz="1400" b="1">
                 <a:solidFill>
                   <a:srgbClr val="0F172A"/>
                 </a:solidFill>
                 <a:latin typeface="Aptos"/>
               </a:rPr>
-              <a:t>Clean prediction goes straight; attacked prediction shifts right and slows/shortens the planned path.</a:t>
-            </a:r>
-          </a:p>
-        </p:txBody>
-      </p:sp>
-      <p:sp>
-        <p:nvSpPr>
-          <p:cNvPr id="23" name="TextBox 22"/>
-          <p:cNvSpPr txBox="1"/>
-          <p:nvPr/>
-        </p:nvSpPr>
-        <p:spPr>
-          <a:xfrm>
-            <a:off x="10835640" y="329184"/>
-            <a:ext cx="822960" cy="201168"/>
-          </a:xfrm>
-          <a:prstGeom prst="rect">
-            <a:avLst/>
-          </a:prstGeom>
-          <a:noFill/>
-        </p:spPr>
-        <p:txBody>
-          <a:bodyPr wrap="square" lIns="18288" rIns="18288" tIns="18288" bIns="18288">
-            <a:spAutoFit/>
-          </a:bodyPr>
-          <a:lstStyle/>
-          <a:p>
-            <a:pPr algn="r"/>
-            <a:r>
-              <a:rPr sz="1100" b="1">
-                <a:solidFill>
-                  <a:srgbClr val="475569"/>
-                </a:solidFill>
-                <a:latin typeface="Aptos"/>
-              </a:rPr>
-              <a:t>01bbf47b</a:t>
+              <a:t>Attacked prediction shifts right and shortens/slows the planned trajectory.</a:t>
             </a:r>
           </a:p>
         </p:txBody>
@@ -3921,7 +3402,7 @@
     <p:bg>
       <p:bgPr>
         <a:solidFill>
-          <a:srgbClr val="F8FAFC"/>
+          <a:srgbClr val="FFFFFF"/>
         </a:solidFill>
         <a:effectLst/>
       </p:bgPr>
@@ -3941,8 +3422,8 @@
         </p:nvSpPr>
         <p:spPr>
           <a:xfrm>
-            <a:off x="502920" y="292608"/>
-            <a:ext cx="8138160" cy="411480"/>
+            <a:off x="502920" y="320040"/>
+            <a:ext cx="8961120" cy="384048"/>
           </a:xfrm>
           <a:prstGeom prst="rect">
             <a:avLst/>
@@ -3950,7 +3431,7 @@
           <a:noFill/>
         </p:spPr>
         <p:txBody>
-          <a:bodyPr wrap="square" lIns="18288" rIns="18288" tIns="18288" bIns="18288">
+          <a:bodyPr wrap="square" lIns="0" rIns="0" tIns="0" bIns="0">
             <a:spAutoFit/>
           </a:bodyPr>
           <a:lstStyle/>
@@ -3962,7 +3443,7 @@
                 </a:solidFill>
                 <a:latin typeface="Aptos"/>
               </a:rPr>
-              <a:t>Showcase 2: Scene-aware Placement Helps</a:t>
+              <a:t>Showcase 2: Scene-aware placement helps</a:t>
             </a:r>
           </a:p>
         </p:txBody>
@@ -3975,8 +3456,8 @@
         </p:nvSpPr>
         <p:spPr>
           <a:xfrm>
-            <a:off x="521207" y="749808"/>
-            <a:ext cx="7680960" cy="256032"/>
+            <a:off x="10607040" y="384048"/>
+            <a:ext cx="1051560" cy="201168"/>
           </a:xfrm>
           <a:prstGeom prst="rect">
             <a:avLst/>
@@ -3984,7 +3465,42 @@
           <a:noFill/>
         </p:spPr>
         <p:txBody>
-          <a:bodyPr wrap="square" lIns="18288" rIns="18288" tIns="18288" bIns="18288">
+          <a:bodyPr wrap="square" lIns="0" rIns="0" tIns="0" bIns="0">
+            <a:spAutoFit/>
+          </a:bodyPr>
+          <a:lstStyle/>
+          <a:p>
+            <a:pPr algn="r"/>
+            <a:r>
+              <a:rPr sz="1100" b="1">
+                <a:solidFill>
+                  <a:srgbClr val="475569"/>
+                </a:solidFill>
+                <a:latin typeface="Aptos"/>
+              </a:rPr>
+              <a:t>01a7d01c</a:t>
+            </a:r>
+          </a:p>
+        </p:txBody>
+      </p:sp>
+      <p:sp>
+        <p:nvSpPr>
+          <p:cNvPr id="4" name="TextBox 3"/>
+          <p:cNvSpPr txBox="1"/>
+          <p:nvPr/>
+        </p:nvSpPr>
+        <p:spPr>
+          <a:xfrm>
+            <a:off x="521207" y="749808"/>
+            <a:ext cx="10607040" cy="256032"/>
+          </a:xfrm>
+          <a:prstGeom prst="rect">
+            <a:avLst/>
+          </a:prstGeom>
+          <a:noFill/>
+        </p:spPr>
+        <p:txBody>
+          <a:bodyPr wrap="square" lIns="0" rIns="0" tIns="0" bIns="0">
             <a:spAutoFit/>
           </a:bodyPr>
           <a:lstStyle/>
@@ -3996,138 +3512,49 @@
                 </a:solidFill>
                 <a:latin typeface="Aptos"/>
               </a:rPr>
-              <a:t>Patch is placed on a salient construction/roadside cue selected from the front image.</a:t>
-            </a:r>
-          </a:p>
-        </p:txBody>
-      </p:sp>
-      <p:sp>
-        <p:nvSpPr>
-          <p:cNvPr id="4" name="Rounded Rectangle 3"/>
-          <p:cNvSpPr/>
+              <a:t>Patch placed on a salient roadside/construction cue; final shift 3.69 m, right shift +2.35 m.</a:t>
+            </a:r>
+          </a:p>
+        </p:txBody>
+      </p:sp>
+      <p:cxnSp>
+        <p:nvCxnSpPr>
+          <p:cNvPr id="5" name="Connector 4"/>
+          <p:cNvCxnSpPr/>
           <p:nvPr/>
-        </p:nvSpPr>
+        </p:nvCxnSpPr>
         <p:spPr>
           <a:xfrm>
-            <a:off x="502920" y="1078992"/>
-            <a:ext cx="11201400" cy="493776"/>
+            <a:off x="502920" y="1124712"/>
+            <a:ext cx="11183112" cy="0"/>
           </a:xfrm>
-          <a:prstGeom prst="roundRect">
+          <a:prstGeom prst="line">
             <a:avLst/>
           </a:prstGeom>
-          <a:solidFill>
-            <a:srgbClr val="EFF6FF"/>
-          </a:solidFill>
           <a:ln w="12700">
             <a:solidFill>
-              <a:srgbClr val="BFDBFE"/>
+              <a:srgbClr val="E2E8F0"/>
             </a:solidFill>
           </a:ln>
         </p:spPr>
         <p:style>
-          <a:lnRef idx="1">
+          <a:lnRef idx="2">
             <a:schemeClr val="accent1"/>
           </a:lnRef>
-          <a:fillRef idx="3">
+          <a:fillRef idx="0">
             <a:schemeClr val="accent1"/>
           </a:fillRef>
-          <a:effectRef idx="2">
+          <a:effectRef idx="1">
             <a:schemeClr val="accent1"/>
           </a:effectRef>
           <a:fontRef idx="minor">
-            <a:schemeClr val="lt1"/>
+            <a:schemeClr val="tx1"/>
           </a:fontRef>
         </p:style>
-        <p:txBody>
-          <a:bodyPr rtlCol="0" anchor="ctr"/>
-          <a:lstStyle/>
-          <a:p>
-            <a:pPr algn="ctr"/>
-          </a:p>
-        </p:txBody>
-      </p:sp>
-      <p:sp>
-        <p:nvSpPr>
-          <p:cNvPr id="5" name="TextBox 4"/>
-          <p:cNvSpPr txBox="1"/>
-          <p:nvPr/>
-        </p:nvSpPr>
-        <p:spPr>
-          <a:xfrm>
-            <a:off x="713232" y="1234440"/>
-            <a:ext cx="10607040" cy="201168"/>
-          </a:xfrm>
-          <a:prstGeom prst="rect">
-            <a:avLst/>
-          </a:prstGeom>
-          <a:noFill/>
-        </p:spPr>
-        <p:txBody>
-          <a:bodyPr wrap="square" lIns="18288" rIns="18288" tIns="18288" bIns="18288">
-            <a:spAutoFit/>
-          </a:bodyPr>
-          <a:lstStyle/>
-          <a:p>
-            <a:r>
-              <a:rPr sz="1300" b="1">
-                <a:solidFill>
-                  <a:srgbClr val="0F172A"/>
-                </a:solidFill>
-                <a:latin typeface="Aptos"/>
-              </a:rPr>
-              <a:t>Black-box: front camera only | no gradients | position sweep | trajectory-shift objective</a:t>
-            </a:r>
-          </a:p>
-        </p:txBody>
-      </p:sp>
-      <p:sp>
-        <p:nvSpPr>
-          <p:cNvPr id="6" name="Rounded Rectangle 5"/>
-          <p:cNvSpPr/>
-          <p:nvPr/>
-        </p:nvSpPr>
-        <p:spPr>
-          <a:xfrm>
-            <a:off x="502920" y="1783080"/>
-            <a:ext cx="6903720" cy="2788920"/>
-          </a:xfrm>
-          <a:prstGeom prst="roundRect">
-            <a:avLst/>
-          </a:prstGeom>
-          <a:solidFill>
-            <a:srgbClr val="FFFFFF"/>
-          </a:solidFill>
-          <a:ln w="12700">
-            <a:solidFill>
-              <a:srgbClr val="CBD5E1"/>
-            </a:solidFill>
-          </a:ln>
-        </p:spPr>
-        <p:style>
-          <a:lnRef idx="1">
-            <a:schemeClr val="accent1"/>
-          </a:lnRef>
-          <a:fillRef idx="3">
-            <a:schemeClr val="accent1"/>
-          </a:fillRef>
-          <a:effectRef idx="2">
-            <a:schemeClr val="accent1"/>
-          </a:effectRef>
-          <a:fontRef idx="minor">
-            <a:schemeClr val="lt1"/>
-          </a:fontRef>
-        </p:style>
-        <p:txBody>
-          <a:bodyPr rtlCol="0" anchor="ctr"/>
-          <a:lstStyle/>
-          <a:p>
-            <a:pPr algn="ctr"/>
-          </a:p>
-        </p:txBody>
-      </p:sp>
+      </p:cxnSp>
       <p:pic>
         <p:nvPicPr>
-          <p:cNvPr id="7" name="Picture 6" descr="01a7d01c_inputs.jpg"/>
+          <p:cNvPr id="6" name="Picture 5" descr="01a7d01c_inputs.jpg"/>
           <p:cNvPicPr>
             <a:picLocks noChangeAspect="1"/>
           </p:cNvPicPr>
@@ -4141,96 +3568,17 @@
         </p:blipFill>
         <p:spPr>
           <a:xfrm>
-            <a:off x="658368" y="1993392"/>
-            <a:ext cx="6601968" cy="2096024"/>
+            <a:off x="502920" y="1353312"/>
+            <a:ext cx="6812280" cy="2162794"/>
           </a:xfrm>
           <a:prstGeom prst="rect">
             <a:avLst/>
           </a:prstGeom>
         </p:spPr>
       </p:pic>
-      <p:sp>
-        <p:nvSpPr>
-          <p:cNvPr id="8" name="TextBox 7"/>
-          <p:cNvSpPr txBox="1"/>
-          <p:nvPr/>
-        </p:nvSpPr>
-        <p:spPr>
-          <a:xfrm>
-            <a:off x="658368" y="4315968"/>
-            <a:ext cx="6583680" cy="201168"/>
-          </a:xfrm>
-          <a:prstGeom prst="rect">
-            <a:avLst/>
-          </a:prstGeom>
-          <a:noFill/>
-        </p:spPr>
-        <p:txBody>
-          <a:bodyPr wrap="square" lIns="18288" rIns="18288" tIns="18288" bIns="18288">
-            <a:spAutoFit/>
-          </a:bodyPr>
-          <a:lstStyle/>
-          <a:p>
-            <a:r>
-              <a:rPr sz="1200" b="0">
-                <a:solidFill>
-                  <a:srgbClr val="475569"/>
-                </a:solidFill>
-                <a:latin typeface="Aptos"/>
-              </a:rPr>
-              <a:t>Input observation: clean front image vs patched front image</a:t>
-            </a:r>
-          </a:p>
-        </p:txBody>
-      </p:sp>
-      <p:sp>
-        <p:nvSpPr>
-          <p:cNvPr id="9" name="Rounded Rectangle 8"/>
-          <p:cNvSpPr/>
-          <p:nvPr/>
-        </p:nvSpPr>
-        <p:spPr>
-          <a:xfrm>
-            <a:off x="7635240" y="1783080"/>
-            <a:ext cx="4069080" cy="4160520"/>
-          </a:xfrm>
-          <a:prstGeom prst="roundRect">
-            <a:avLst/>
-          </a:prstGeom>
-          <a:solidFill>
-            <a:srgbClr val="FFFFFF"/>
-          </a:solidFill>
-          <a:ln w="12700">
-            <a:solidFill>
-              <a:srgbClr val="CBD5E1"/>
-            </a:solidFill>
-          </a:ln>
-        </p:spPr>
-        <p:style>
-          <a:lnRef idx="1">
-            <a:schemeClr val="accent1"/>
-          </a:lnRef>
-          <a:fillRef idx="3">
-            <a:schemeClr val="accent1"/>
-          </a:fillRef>
-          <a:effectRef idx="2">
-            <a:schemeClr val="accent1"/>
-          </a:effectRef>
-          <a:fontRef idx="minor">
-            <a:schemeClr val="lt1"/>
-          </a:fontRef>
-        </p:style>
-        <p:txBody>
-          <a:bodyPr rtlCol="0" anchor="ctr"/>
-          <a:lstStyle/>
-          <a:p>
-            <a:pPr algn="ctr"/>
-          </a:p>
-        </p:txBody>
-      </p:sp>
       <p:pic>
         <p:nvPicPr>
-          <p:cNvPr id="10" name="Picture 9" descr="01a7d01c_traj_overlay.png"/>
+          <p:cNvPr id="7" name="Picture 6" descr="01a7d01c_traj_overlay.png"/>
           <p:cNvPicPr>
             <a:picLocks noChangeAspect="1"/>
           </p:cNvPicPr>
@@ -4244,8 +3592,8 @@
         </p:blipFill>
         <p:spPr>
           <a:xfrm>
-            <a:off x="7982712" y="1993392"/>
-            <a:ext cx="2725042" cy="3493008"/>
+            <a:off x="7635240" y="1234440"/>
+            <a:ext cx="3745149" cy="4800600"/>
           </a:xfrm>
           <a:prstGeom prst="rect">
             <a:avLst/>
@@ -4254,14 +3602,14 @@
       </p:pic>
       <p:sp>
         <p:nvSpPr>
-          <p:cNvPr id="11" name="TextBox 10"/>
+          <p:cNvPr id="8" name="TextBox 7"/>
           <p:cNvSpPr txBox="1"/>
           <p:nvPr/>
         </p:nvSpPr>
         <p:spPr>
           <a:xfrm>
-            <a:off x="7891272" y="5559552"/>
-            <a:ext cx="3566160" cy="201168"/>
+            <a:off x="502920" y="6199632"/>
+            <a:ext cx="6812280" cy="201168"/>
           </a:xfrm>
           <a:prstGeom prst="rect">
             <a:avLst/>
@@ -4269,79 +3617,34 @@
           <a:noFill/>
         </p:spPr>
         <p:txBody>
-          <a:bodyPr wrap="square" lIns="18288" rIns="18288" tIns="18288" bIns="18288">
+          <a:bodyPr wrap="square" lIns="0" rIns="0" tIns="0" bIns="0">
             <a:spAutoFit/>
           </a:bodyPr>
           <a:lstStyle/>
           <a:p>
             <a:pPr algn="ctr"/>
             <a:r>
-              <a:rPr sz="1200" b="0">
+              <a:rPr sz="1300" b="0">
                 <a:solidFill>
                   <a:srgbClr val="475569"/>
                 </a:solidFill>
                 <a:latin typeface="Aptos"/>
               </a:rPr>
-              <a:t>Trajectory overlay: GT / clean pred / attacked pred</a:t>
-            </a:r>
-          </a:p>
-        </p:txBody>
-      </p:sp>
-      <p:sp>
-        <p:nvSpPr>
-          <p:cNvPr id="12" name="Rounded Rectangle 11"/>
-          <p:cNvSpPr/>
+              <a:t>Clean front input  |  Patched front input</a:t>
+            </a:r>
+          </a:p>
+        </p:txBody>
+      </p:sp>
+      <p:sp>
+        <p:nvSpPr>
+          <p:cNvPr id="9" name="TextBox 8"/>
+          <p:cNvSpPr txBox="1"/>
           <p:nvPr/>
         </p:nvSpPr>
         <p:spPr>
           <a:xfrm>
-            <a:off x="502920" y="4800600"/>
-            <a:ext cx="1783080" cy="566928"/>
-          </a:xfrm>
-          <a:prstGeom prst="roundRect">
-            <a:avLst/>
-          </a:prstGeom>
-          <a:solidFill>
-            <a:srgbClr val="FFFFFF"/>
-          </a:solidFill>
-          <a:ln w="12700">
-            <a:solidFill>
-              <a:srgbClr val="CBD5E1"/>
-            </a:solidFill>
-          </a:ln>
-        </p:spPr>
-        <p:style>
-          <a:lnRef idx="1">
-            <a:schemeClr val="accent1"/>
-          </a:lnRef>
-          <a:fillRef idx="3">
-            <a:schemeClr val="accent1"/>
-          </a:fillRef>
-          <a:effectRef idx="2">
-            <a:schemeClr val="accent1"/>
-          </a:effectRef>
-          <a:fontRef idx="minor">
-            <a:schemeClr val="lt1"/>
-          </a:fontRef>
-        </p:style>
-        <p:txBody>
-          <a:bodyPr rtlCol="0" anchor="ctr"/>
-          <a:lstStyle/>
-          <a:p>
-            <a:pPr algn="ctr"/>
-          </a:p>
-        </p:txBody>
-      </p:sp>
-      <p:sp>
-        <p:nvSpPr>
-          <p:cNvPr id="13" name="TextBox 12"/>
-          <p:cNvSpPr txBox="1"/>
-          <p:nvPr/>
-        </p:nvSpPr>
-        <p:spPr>
-          <a:xfrm>
-            <a:off x="612648" y="4882896"/>
-            <a:ext cx="713232" cy="182880"/>
+            <a:off x="7635240" y="6199632"/>
+            <a:ext cx="3840480" cy="201168"/>
           </a:xfrm>
           <a:prstGeom prst="rect">
             <a:avLst/>
@@ -4349,33 +3652,34 @@
           <a:noFill/>
         </p:spPr>
         <p:txBody>
-          <a:bodyPr wrap="square" lIns="18288" rIns="18288" tIns="18288" bIns="18288">
+          <a:bodyPr wrap="square" lIns="0" rIns="0" tIns="0" bIns="0">
             <a:spAutoFit/>
           </a:bodyPr>
           <a:lstStyle/>
           <a:p>
-            <a:r>
-              <a:rPr sz="1000" b="1">
+            <a:pPr algn="ctr"/>
+            <a:r>
+              <a:rPr sz="1300" b="0">
                 <a:solidFill>
                   <a:srgbClr val="475569"/>
                 </a:solidFill>
                 <a:latin typeface="Aptos"/>
               </a:rPr>
-              <a:t>final</a:t>
-            </a:r>
-          </a:p>
-        </p:txBody>
-      </p:sp>
-      <p:sp>
-        <p:nvSpPr>
-          <p:cNvPr id="14" name="TextBox 13"/>
+              <a:t>GT / clean prediction / attacked prediction</a:t>
+            </a:r>
+          </a:p>
+        </p:txBody>
+      </p:sp>
+      <p:sp>
+        <p:nvSpPr>
+          <p:cNvPr id="10" name="TextBox 9"/>
           <p:cNvSpPr txBox="1"/>
           <p:nvPr/>
         </p:nvSpPr>
         <p:spPr>
           <a:xfrm>
-            <a:off x="1069848" y="4864608"/>
-            <a:ext cx="1115568" cy="320040"/>
+            <a:off x="502920" y="6519672"/>
+            <a:ext cx="11155680" cy="201168"/>
           </a:xfrm>
           <a:prstGeom prst="rect">
             <a:avLst/>
@@ -4383,362 +3687,20 @@
           <a:noFill/>
         </p:spPr>
         <p:txBody>
-          <a:bodyPr wrap="square" lIns="18288" rIns="18288" tIns="18288" bIns="18288">
+          <a:bodyPr wrap="square" lIns="0" rIns="0" tIns="0" bIns="0">
             <a:spAutoFit/>
           </a:bodyPr>
           <a:lstStyle/>
           <a:p>
-            <a:pPr algn="r"/>
-            <a:r>
-              <a:rPr sz="1800" b="1">
-                <a:solidFill>
-                  <a:srgbClr val="DC2626"/>
-                </a:solidFill>
-                <a:latin typeface="Aptos"/>
-              </a:rPr>
-              <a:t>3.69m</a:t>
-            </a:r>
-          </a:p>
-        </p:txBody>
-      </p:sp>
-      <p:sp>
-        <p:nvSpPr>
-          <p:cNvPr id="15" name="Rounded Rectangle 14"/>
-          <p:cNvSpPr/>
-          <p:nvPr/>
-        </p:nvSpPr>
-        <p:spPr>
-          <a:xfrm>
-            <a:off x="2468880" y="4800600"/>
-            <a:ext cx="1783080" cy="566928"/>
-          </a:xfrm>
-          <a:prstGeom prst="roundRect">
-            <a:avLst/>
-          </a:prstGeom>
-          <a:solidFill>
-            <a:srgbClr val="FFFFFF"/>
-          </a:solidFill>
-          <a:ln w="12700">
-            <a:solidFill>
-              <a:srgbClr val="CBD5E1"/>
-            </a:solidFill>
-          </a:ln>
-        </p:spPr>
-        <p:style>
-          <a:lnRef idx="1">
-            <a:schemeClr val="accent1"/>
-          </a:lnRef>
-          <a:fillRef idx="3">
-            <a:schemeClr val="accent1"/>
-          </a:fillRef>
-          <a:effectRef idx="2">
-            <a:schemeClr val="accent1"/>
-          </a:effectRef>
-          <a:fontRef idx="minor">
-            <a:schemeClr val="lt1"/>
-          </a:fontRef>
-        </p:style>
-        <p:txBody>
-          <a:bodyPr rtlCol="0" anchor="ctr"/>
-          <a:lstStyle/>
-          <a:p>
             <a:pPr algn="ctr"/>
-          </a:p>
-        </p:txBody>
-      </p:sp>
-      <p:sp>
-        <p:nvSpPr>
-          <p:cNvPr id="16" name="TextBox 15"/>
-          <p:cNvSpPr txBox="1"/>
-          <p:nvPr/>
-        </p:nvSpPr>
-        <p:spPr>
-          <a:xfrm>
-            <a:off x="2578608" y="4882896"/>
-            <a:ext cx="713232" cy="182880"/>
-          </a:xfrm>
-          <a:prstGeom prst="rect">
-            <a:avLst/>
-          </a:prstGeom>
-          <a:noFill/>
-        </p:spPr>
-        <p:txBody>
-          <a:bodyPr wrap="square" lIns="18288" rIns="18288" tIns="18288" bIns="18288">
-            <a:spAutoFit/>
-          </a:bodyPr>
-          <a:lstStyle/>
-          <a:p>
-            <a:r>
-              <a:rPr sz="1000" b="1">
-                <a:solidFill>
-                  <a:srgbClr val="475569"/>
-                </a:solidFill>
-                <a:latin typeface="Aptos"/>
-              </a:rPr>
-              <a:t>right</a:t>
-            </a:r>
-          </a:p>
-        </p:txBody>
-      </p:sp>
-      <p:sp>
-        <p:nvSpPr>
-          <p:cNvPr id="17" name="TextBox 16"/>
-          <p:cNvSpPr txBox="1"/>
-          <p:nvPr/>
-        </p:nvSpPr>
-        <p:spPr>
-          <a:xfrm>
-            <a:off x="3035808" y="4864608"/>
-            <a:ext cx="1115568" cy="320040"/>
-          </a:xfrm>
-          <a:prstGeom prst="rect">
-            <a:avLst/>
-          </a:prstGeom>
-          <a:noFill/>
-        </p:spPr>
-        <p:txBody>
-          <a:bodyPr wrap="square" lIns="18288" rIns="18288" tIns="18288" bIns="18288">
-            <a:spAutoFit/>
-          </a:bodyPr>
-          <a:lstStyle/>
-          <a:p>
-            <a:pPr algn="r"/>
-            <a:r>
-              <a:rPr sz="1800" b="1">
-                <a:solidFill>
-                  <a:srgbClr val="059669"/>
-                </a:solidFill>
-                <a:latin typeface="Aptos"/>
-              </a:rPr>
-              <a:t>+2.35m</a:t>
-            </a:r>
-          </a:p>
-        </p:txBody>
-      </p:sp>
-      <p:sp>
-        <p:nvSpPr>
-          <p:cNvPr id="18" name="Rounded Rectangle 17"/>
-          <p:cNvSpPr/>
-          <p:nvPr/>
-        </p:nvSpPr>
-        <p:spPr>
-          <a:xfrm>
-            <a:off x="4434840" y="4800600"/>
-            <a:ext cx="1783080" cy="566928"/>
-          </a:xfrm>
-          <a:prstGeom prst="roundRect">
-            <a:avLst/>
-          </a:prstGeom>
-          <a:solidFill>
-            <a:srgbClr val="FFFFFF"/>
-          </a:solidFill>
-          <a:ln w="12700">
-            <a:solidFill>
-              <a:srgbClr val="CBD5E1"/>
-            </a:solidFill>
-          </a:ln>
-        </p:spPr>
-        <p:style>
-          <a:lnRef idx="1">
-            <a:schemeClr val="accent1"/>
-          </a:lnRef>
-          <a:fillRef idx="3">
-            <a:schemeClr val="accent1"/>
-          </a:fillRef>
-          <a:effectRef idx="2">
-            <a:schemeClr val="accent1"/>
-          </a:effectRef>
-          <a:fontRef idx="minor">
-            <a:schemeClr val="lt1"/>
-          </a:fontRef>
-        </p:style>
-        <p:txBody>
-          <a:bodyPr rtlCol="0" anchor="ctr"/>
-          <a:lstStyle/>
-          <a:p>
-            <a:pPr algn="ctr"/>
-          </a:p>
-        </p:txBody>
-      </p:sp>
-      <p:sp>
-        <p:nvSpPr>
-          <p:cNvPr id="19" name="TextBox 18"/>
-          <p:cNvSpPr txBox="1"/>
-          <p:nvPr/>
-        </p:nvSpPr>
-        <p:spPr>
-          <a:xfrm>
-            <a:off x="4544568" y="4882896"/>
-            <a:ext cx="713232" cy="182880"/>
-          </a:xfrm>
-          <a:prstGeom prst="rect">
-            <a:avLst/>
-          </a:prstGeom>
-          <a:noFill/>
-        </p:spPr>
-        <p:txBody>
-          <a:bodyPr wrap="square" lIns="18288" rIns="18288" tIns="18288" bIns="18288">
-            <a:spAutoFit/>
-          </a:bodyPr>
-          <a:lstStyle/>
-          <a:p>
-            <a:r>
-              <a:rPr sz="1000" b="1">
-                <a:solidFill>
-                  <a:srgbClr val="475569"/>
-                </a:solidFill>
-                <a:latin typeface="Aptos"/>
-              </a:rPr>
-              <a:t>mean</a:t>
-            </a:r>
-          </a:p>
-        </p:txBody>
-      </p:sp>
-      <p:sp>
-        <p:nvSpPr>
-          <p:cNvPr id="20" name="TextBox 19"/>
-          <p:cNvSpPr txBox="1"/>
-          <p:nvPr/>
-        </p:nvSpPr>
-        <p:spPr>
-          <a:xfrm>
-            <a:off x="5001768" y="4864608"/>
-            <a:ext cx="1115568" cy="320040"/>
-          </a:xfrm>
-          <a:prstGeom prst="rect">
-            <a:avLst/>
-          </a:prstGeom>
-          <a:noFill/>
-        </p:spPr>
-        <p:txBody>
-          <a:bodyPr wrap="square" lIns="18288" rIns="18288" tIns="18288" bIns="18288">
-            <a:spAutoFit/>
-          </a:bodyPr>
-          <a:lstStyle/>
-          <a:p>
-            <a:pPr algn="r"/>
-            <a:r>
-              <a:rPr sz="1800" b="1">
-                <a:solidFill>
-                  <a:srgbClr val="2563EB"/>
-                </a:solidFill>
-                <a:latin typeface="Aptos"/>
-              </a:rPr>
-              <a:t>1.47m</a:t>
-            </a:r>
-          </a:p>
-        </p:txBody>
-      </p:sp>
-      <p:sp>
-        <p:nvSpPr>
-          <p:cNvPr id="21" name="Rounded Rectangle 20"/>
-          <p:cNvSpPr/>
-          <p:nvPr/>
-        </p:nvSpPr>
-        <p:spPr>
-          <a:xfrm>
-            <a:off x="502920" y="5532120"/>
-            <a:ext cx="6903720" cy="566928"/>
-          </a:xfrm>
-          <a:prstGeom prst="roundRect">
-            <a:avLst/>
-          </a:prstGeom>
-          <a:solidFill>
-            <a:srgbClr val="FFFFFF"/>
-          </a:solidFill>
-          <a:ln w="12700">
-            <a:solidFill>
-              <a:srgbClr val="CBD5E1"/>
-            </a:solidFill>
-          </a:ln>
-        </p:spPr>
-        <p:style>
-          <a:lnRef idx="1">
-            <a:schemeClr val="accent1"/>
-          </a:lnRef>
-          <a:fillRef idx="3">
-            <a:schemeClr val="accent1"/>
-          </a:fillRef>
-          <a:effectRef idx="2">
-            <a:schemeClr val="accent1"/>
-          </a:effectRef>
-          <a:fontRef idx="minor">
-            <a:schemeClr val="lt1"/>
-          </a:fontRef>
-        </p:style>
-        <p:txBody>
-          <a:bodyPr rtlCol="0" anchor="ctr"/>
-          <a:lstStyle/>
-          <a:p>
-            <a:pPr algn="ctr"/>
-          </a:p>
-        </p:txBody>
-      </p:sp>
-      <p:sp>
-        <p:nvSpPr>
-          <p:cNvPr id="22" name="TextBox 21"/>
-          <p:cNvSpPr txBox="1"/>
-          <p:nvPr/>
-        </p:nvSpPr>
-        <p:spPr>
-          <a:xfrm>
-            <a:off x="685800" y="5660136"/>
-            <a:ext cx="6446520" cy="310896"/>
-          </a:xfrm>
-          <a:prstGeom prst="rect">
-            <a:avLst/>
-          </a:prstGeom>
-          <a:noFill/>
-        </p:spPr>
-        <p:txBody>
-          <a:bodyPr wrap="square" lIns="18288" rIns="18288" tIns="18288" bIns="18288">
-            <a:spAutoFit/>
-          </a:bodyPr>
-          <a:lstStyle/>
-          <a:p>
-            <a:r>
-              <a:rPr sz="1200" b="1">
+            <a:r>
+              <a:rPr sz="1400" b="1">
                 <a:solidFill>
                   <a:srgbClr val="0F172A"/>
                 </a:solidFill>
                 <a:latin typeface="Aptos"/>
               </a:rPr>
-              <a:t>Compared with fixed placement, scene-aware placement increases final shift from 1.31 m to 3.69 m.</a:t>
-            </a:r>
-          </a:p>
-        </p:txBody>
-      </p:sp>
-      <p:sp>
-        <p:nvSpPr>
-          <p:cNvPr id="23" name="TextBox 22"/>
-          <p:cNvSpPr txBox="1"/>
-          <p:nvPr/>
-        </p:nvSpPr>
-        <p:spPr>
-          <a:xfrm>
-            <a:off x="10835640" y="329184"/>
-            <a:ext cx="822960" cy="201168"/>
-          </a:xfrm>
-          <a:prstGeom prst="rect">
-            <a:avLst/>
-          </a:prstGeom>
-          <a:noFill/>
-        </p:spPr>
-        <p:txBody>
-          <a:bodyPr wrap="square" lIns="18288" rIns="18288" tIns="18288" bIns="18288">
-            <a:spAutoFit/>
-          </a:bodyPr>
-          <a:lstStyle/>
-          <a:p>
-            <a:pPr algn="r"/>
-            <a:r>
-              <a:rPr sz="1100" b="1">
-                <a:solidFill>
-                  <a:srgbClr val="475569"/>
-                </a:solidFill>
-                <a:latin typeface="Aptos"/>
-              </a:rPr>
-              <a:t>01a7d01c</a:t>
+              <a:t>Scene-aware placement improves this case from 1.31 m to 3.69 m final shift.</a:t>
             </a:r>
           </a:p>
         </p:txBody>

</xml_diff>

<commit_message>
Add all AutoVLA attack cases to slides
</commit_message>
<xml_diff>
--- a/report/autovla_blackbox_attack_2slides.pptx
+++ b/report/autovla_blackbox_attack_2slides.pptx
@@ -7,6 +7,9 @@
   <p:sldIdLst>
     <p:sldId id="256" r:id="rId7"/>
     <p:sldId id="257" r:id="rId8"/>
+    <p:sldId id="258" r:id="rId9"/>
+    <p:sldId id="259" r:id="rId10"/>
+    <p:sldId id="260" r:id="rId11"/>
   </p:sldIdLst>
   <p:sldSz cx="12191999" cy="6858000" type="screen4x3"/>
   <p:notesSz cx="6858000" cy="9144000"/>
@@ -3126,7 +3129,7 @@
                 </a:solidFill>
                 <a:latin typeface="Aptos"/>
               </a:rPr>
-              <a:t>Showcase 1: Strongest black-box patch effect</a:t>
+              <a:t>Case 1: strongest black-box patch effect</a:t>
             </a:r>
           </a:p>
         </p:txBody>
@@ -3195,7 +3198,7 @@
                 </a:solidFill>
                 <a:latin typeface="Aptos"/>
               </a:rPr>
-              <a:t>Front-camera patch; final shift 9.25 m, right shift +3.19 m.</a:t>
+              <a:t>p20 front-camera patch; final shift 9.25 m, right shift +3.19 m, mean shift 3.44 m.</a:t>
             </a:r>
           </a:p>
         </p:txBody>
@@ -3383,7 +3386,7 @@
                 </a:solidFill>
                 <a:latin typeface="Aptos"/>
               </a:rPr>
-              <a:t>Attacked prediction shifts right and shortens/slows the planned trajectory.</a:t>
+              <a:t>Selected position = horizon_center; final shift 9.25 m, right shift +3.19 m.</a:t>
             </a:r>
           </a:p>
         </p:txBody>
@@ -3443,7 +3446,7 @@
                 </a:solidFill>
                 <a:latin typeface="Aptos"/>
               </a:rPr>
-              <a:t>Showcase 2: Scene-aware placement helps</a:t>
+              <a:t>Case 2: scene-aware placement helps</a:t>
             </a:r>
           </a:p>
         </p:txBody>
@@ -3512,7 +3515,7 @@
                 </a:solidFill>
                 <a:latin typeface="Aptos"/>
               </a:rPr>
-              <a:t>Patch placed on a salient roadside/construction cue; final shift 3.69 m, right shift +2.35 m.</a:t>
+              <a:t>p20 front-camera patch; final shift 3.69 m, right shift +2.35 m, mean shift 1.47 m.</a:t>
             </a:r>
           </a:p>
         </p:txBody>
@@ -3700,7 +3703,958 @@
                 </a:solidFill>
                 <a:latin typeface="Aptos"/>
               </a:rPr>
-              <a:t>Scene-aware placement improves this case from 1.31 m to 3.69 m final shift.</a:t>
+              <a:t>Selected position = scene_aware; final shift 3.69 m, right shift +2.35 m.</a:t>
+            </a:r>
+          </a:p>
+        </p:txBody>
+      </p:sp>
+    </p:spTree>
+  </p:cSld>
+  <p:clrMapOvr>
+    <a:masterClrMapping/>
+  </p:clrMapOvr>
+</p:sld>
+</file>
+
+<file path=ppt/slides/slide3.xml><?xml version="1.0" encoding="utf-8"?>
+<p:sld xmlns:a="http://schemas.openxmlformats.org/drawingml/2006/main" xmlns:p="http://schemas.openxmlformats.org/presentationml/2006/main" xmlns:r="http://schemas.openxmlformats.org/officeDocument/2006/relationships">
+  <p:cSld>
+    <p:bg>
+      <p:bgPr>
+        <a:solidFill>
+          <a:srgbClr val="FFFFFF"/>
+        </a:solidFill>
+        <a:effectLst/>
+      </p:bgPr>
+    </p:bg>
+    <p:spTree>
+      <p:nvGrpSpPr>
+        <p:cNvPr id="1" name=""/>
+        <p:cNvGrpSpPr/>
+        <p:nvPr/>
+      </p:nvGrpSpPr>
+      <p:grpSpPr/>
+      <p:sp>
+        <p:nvSpPr>
+          <p:cNvPr id="2" name="TextBox 1"/>
+          <p:cNvSpPr txBox="1"/>
+          <p:nvPr/>
+        </p:nvSpPr>
+        <p:spPr>
+          <a:xfrm>
+            <a:off x="502920" y="320040"/>
+            <a:ext cx="8961120" cy="384048"/>
+          </a:xfrm>
+          <a:prstGeom prst="rect">
+            <a:avLst/>
+          </a:prstGeom>
+          <a:noFill/>
+        </p:spPr>
+        <p:txBody>
+          <a:bodyPr wrap="square" lIns="0" rIns="0" tIns="0" bIns="0">
+            <a:spAutoFit/>
+          </a:bodyPr>
+          <a:lstStyle/>
+          <a:p>
+            <a:r>
+              <a:rPr sz="2800" b="1">
+                <a:solidFill>
+                  <a:srgbClr val="0F172A"/>
+                </a:solidFill>
+                <a:latin typeface="Aptos"/>
+              </a:rPr>
+              <a:t>Case 3: AutoVLA black-box patch sample</a:t>
+            </a:r>
+          </a:p>
+        </p:txBody>
+      </p:sp>
+      <p:sp>
+        <p:nvSpPr>
+          <p:cNvPr id="3" name="TextBox 2"/>
+          <p:cNvSpPr txBox="1"/>
+          <p:nvPr/>
+        </p:nvSpPr>
+        <p:spPr>
+          <a:xfrm>
+            <a:off x="10607040" y="384048"/>
+            <a:ext cx="1051560" cy="201168"/>
+          </a:xfrm>
+          <a:prstGeom prst="rect">
+            <a:avLst/>
+          </a:prstGeom>
+          <a:noFill/>
+        </p:spPr>
+        <p:txBody>
+          <a:bodyPr wrap="square" lIns="0" rIns="0" tIns="0" bIns="0">
+            <a:spAutoFit/>
+          </a:bodyPr>
+          <a:lstStyle/>
+          <a:p>
+            <a:pPr algn="r"/>
+            <a:r>
+              <a:rPr sz="1100" b="1">
+                <a:solidFill>
+                  <a:srgbClr val="475569"/>
+                </a:solidFill>
+                <a:latin typeface="Aptos"/>
+              </a:rPr>
+              <a:t>0141260a</a:t>
+            </a:r>
+          </a:p>
+        </p:txBody>
+      </p:sp>
+      <p:sp>
+        <p:nvSpPr>
+          <p:cNvPr id="4" name="TextBox 3"/>
+          <p:cNvSpPr txBox="1"/>
+          <p:nvPr/>
+        </p:nvSpPr>
+        <p:spPr>
+          <a:xfrm>
+            <a:off x="521207" y="749808"/>
+            <a:ext cx="10607040" cy="256032"/>
+          </a:xfrm>
+          <a:prstGeom prst="rect">
+            <a:avLst/>
+          </a:prstGeom>
+          <a:noFill/>
+        </p:spPr>
+        <p:txBody>
+          <a:bodyPr wrap="square" lIns="0" rIns="0" tIns="0" bIns="0">
+            <a:spAutoFit/>
+          </a:bodyPr>
+          <a:lstStyle/>
+          <a:p>
+            <a:r>
+              <a:rPr sz="1500" b="0">
+                <a:solidFill>
+                  <a:srgbClr val="475569"/>
+                </a:solidFill>
+                <a:latin typeface="Aptos"/>
+              </a:rPr>
+              <a:t>p20 front-camera patch; final shift 2.44 m, right shift -2.38 m, mean shift 1.26 m.</a:t>
+            </a:r>
+          </a:p>
+        </p:txBody>
+      </p:sp>
+      <p:cxnSp>
+        <p:nvCxnSpPr>
+          <p:cNvPr id="5" name="Connector 4"/>
+          <p:cNvCxnSpPr/>
+          <p:nvPr/>
+        </p:nvCxnSpPr>
+        <p:spPr>
+          <a:xfrm>
+            <a:off x="502920" y="1124712"/>
+            <a:ext cx="11183112" cy="0"/>
+          </a:xfrm>
+          <a:prstGeom prst="line">
+            <a:avLst/>
+          </a:prstGeom>
+          <a:ln w="12700">
+            <a:solidFill>
+              <a:srgbClr val="E2E8F0"/>
+            </a:solidFill>
+          </a:ln>
+        </p:spPr>
+        <p:style>
+          <a:lnRef idx="2">
+            <a:schemeClr val="accent1"/>
+          </a:lnRef>
+          <a:fillRef idx="0">
+            <a:schemeClr val="accent1"/>
+          </a:fillRef>
+          <a:effectRef idx="1">
+            <a:schemeClr val="accent1"/>
+          </a:effectRef>
+          <a:fontRef idx="minor">
+            <a:schemeClr val="tx1"/>
+          </a:fontRef>
+        </p:style>
+      </p:cxnSp>
+      <p:pic>
+        <p:nvPicPr>
+          <p:cNvPr id="6" name="Picture 5" descr="0141260a_inputs.jpg"/>
+          <p:cNvPicPr>
+            <a:picLocks noChangeAspect="1"/>
+          </p:cNvPicPr>
+          <p:nvPr/>
+        </p:nvPicPr>
+        <p:blipFill>
+          <a:blip r:embed="rId2"/>
+          <a:stretch>
+            <a:fillRect/>
+          </a:stretch>
+        </p:blipFill>
+        <p:spPr>
+          <a:xfrm>
+            <a:off x="502920" y="1353312"/>
+            <a:ext cx="6812280" cy="2162794"/>
+          </a:xfrm>
+          <a:prstGeom prst="rect">
+            <a:avLst/>
+          </a:prstGeom>
+        </p:spPr>
+      </p:pic>
+      <p:pic>
+        <p:nvPicPr>
+          <p:cNvPr id="7" name="Picture 6" descr="0141260a_traj_overlay.png"/>
+          <p:cNvPicPr>
+            <a:picLocks noChangeAspect="1"/>
+          </p:cNvPicPr>
+          <p:nvPr/>
+        </p:nvPicPr>
+        <p:blipFill>
+          <a:blip r:embed="rId3"/>
+          <a:stretch>
+            <a:fillRect/>
+          </a:stretch>
+        </p:blipFill>
+        <p:spPr>
+          <a:xfrm>
+            <a:off x="7635240" y="1234440"/>
+            <a:ext cx="3745149" cy="4800600"/>
+          </a:xfrm>
+          <a:prstGeom prst="rect">
+            <a:avLst/>
+          </a:prstGeom>
+        </p:spPr>
+      </p:pic>
+      <p:sp>
+        <p:nvSpPr>
+          <p:cNvPr id="8" name="TextBox 7"/>
+          <p:cNvSpPr txBox="1"/>
+          <p:nvPr/>
+        </p:nvSpPr>
+        <p:spPr>
+          <a:xfrm>
+            <a:off x="502920" y="6199632"/>
+            <a:ext cx="6812280" cy="201168"/>
+          </a:xfrm>
+          <a:prstGeom prst="rect">
+            <a:avLst/>
+          </a:prstGeom>
+          <a:noFill/>
+        </p:spPr>
+        <p:txBody>
+          <a:bodyPr wrap="square" lIns="0" rIns="0" tIns="0" bIns="0">
+            <a:spAutoFit/>
+          </a:bodyPr>
+          <a:lstStyle/>
+          <a:p>
+            <a:pPr algn="ctr"/>
+            <a:r>
+              <a:rPr sz="1300" b="0">
+                <a:solidFill>
+                  <a:srgbClr val="475569"/>
+                </a:solidFill>
+                <a:latin typeface="Aptos"/>
+              </a:rPr>
+              <a:t>Clean front input  |  Patched front input</a:t>
+            </a:r>
+          </a:p>
+        </p:txBody>
+      </p:sp>
+      <p:sp>
+        <p:nvSpPr>
+          <p:cNvPr id="9" name="TextBox 8"/>
+          <p:cNvSpPr txBox="1"/>
+          <p:nvPr/>
+        </p:nvSpPr>
+        <p:spPr>
+          <a:xfrm>
+            <a:off x="7635240" y="6199632"/>
+            <a:ext cx="3840480" cy="201168"/>
+          </a:xfrm>
+          <a:prstGeom prst="rect">
+            <a:avLst/>
+          </a:prstGeom>
+          <a:noFill/>
+        </p:spPr>
+        <p:txBody>
+          <a:bodyPr wrap="square" lIns="0" rIns="0" tIns="0" bIns="0">
+            <a:spAutoFit/>
+          </a:bodyPr>
+          <a:lstStyle/>
+          <a:p>
+            <a:pPr algn="ctr"/>
+            <a:r>
+              <a:rPr sz="1300" b="0">
+                <a:solidFill>
+                  <a:srgbClr val="475569"/>
+                </a:solidFill>
+                <a:latin typeface="Aptos"/>
+              </a:rPr>
+              <a:t>GT / clean prediction / attacked prediction</a:t>
+            </a:r>
+          </a:p>
+        </p:txBody>
+      </p:sp>
+      <p:sp>
+        <p:nvSpPr>
+          <p:cNvPr id="10" name="TextBox 9"/>
+          <p:cNvSpPr txBox="1"/>
+          <p:nvPr/>
+        </p:nvSpPr>
+        <p:spPr>
+          <a:xfrm>
+            <a:off x="502920" y="6519672"/>
+            <a:ext cx="11155680" cy="201168"/>
+          </a:xfrm>
+          <a:prstGeom prst="rect">
+            <a:avLst/>
+          </a:prstGeom>
+          <a:noFill/>
+        </p:spPr>
+        <p:txBody>
+          <a:bodyPr wrap="square" lIns="0" rIns="0" tIns="0" bIns="0">
+            <a:spAutoFit/>
+          </a:bodyPr>
+          <a:lstStyle/>
+          <a:p>
+            <a:pPr algn="ctr"/>
+            <a:r>
+              <a:rPr sz="1400" b="1">
+                <a:solidFill>
+                  <a:srgbClr val="0F172A"/>
+                </a:solidFill>
+                <a:latin typeface="Aptos"/>
+              </a:rPr>
+              <a:t>Selected position = bottom_center; final shift 2.44 m, left/opposite shift -2.38 m.</a:t>
+            </a:r>
+          </a:p>
+        </p:txBody>
+      </p:sp>
+    </p:spTree>
+  </p:cSld>
+  <p:clrMapOvr>
+    <a:masterClrMapping/>
+  </p:clrMapOvr>
+</p:sld>
+</file>
+
+<file path=ppt/slides/slide4.xml><?xml version="1.0" encoding="utf-8"?>
+<p:sld xmlns:a="http://schemas.openxmlformats.org/drawingml/2006/main" xmlns:p="http://schemas.openxmlformats.org/presentationml/2006/main" xmlns:r="http://schemas.openxmlformats.org/officeDocument/2006/relationships">
+  <p:cSld>
+    <p:bg>
+      <p:bgPr>
+        <a:solidFill>
+          <a:srgbClr val="FFFFFF"/>
+        </a:solidFill>
+        <a:effectLst/>
+      </p:bgPr>
+    </p:bg>
+    <p:spTree>
+      <p:nvGrpSpPr>
+        <p:cNvPr id="1" name=""/>
+        <p:cNvGrpSpPr/>
+        <p:nvPr/>
+      </p:nvGrpSpPr>
+      <p:grpSpPr/>
+      <p:sp>
+        <p:nvSpPr>
+          <p:cNvPr id="2" name="TextBox 1"/>
+          <p:cNvSpPr txBox="1"/>
+          <p:nvPr/>
+        </p:nvSpPr>
+        <p:spPr>
+          <a:xfrm>
+            <a:off x="502920" y="320040"/>
+            <a:ext cx="8961120" cy="384048"/>
+          </a:xfrm>
+          <a:prstGeom prst="rect">
+            <a:avLst/>
+          </a:prstGeom>
+          <a:noFill/>
+        </p:spPr>
+        <p:txBody>
+          <a:bodyPr wrap="square" lIns="0" rIns="0" tIns="0" bIns="0">
+            <a:spAutoFit/>
+          </a:bodyPr>
+          <a:lstStyle/>
+          <a:p>
+            <a:r>
+              <a:rPr sz="2800" b="1">
+                <a:solidFill>
+                  <a:srgbClr val="0F172A"/>
+                </a:solidFill>
+                <a:latin typeface="Aptos"/>
+              </a:rPr>
+              <a:t>Case 4: AutoVLA black-box patch sample</a:t>
+            </a:r>
+          </a:p>
+        </p:txBody>
+      </p:sp>
+      <p:sp>
+        <p:nvSpPr>
+          <p:cNvPr id="3" name="TextBox 2"/>
+          <p:cNvSpPr txBox="1"/>
+          <p:nvPr/>
+        </p:nvSpPr>
+        <p:spPr>
+          <a:xfrm>
+            <a:off x="10607040" y="384048"/>
+            <a:ext cx="1051560" cy="201168"/>
+          </a:xfrm>
+          <a:prstGeom prst="rect">
+            <a:avLst/>
+          </a:prstGeom>
+          <a:noFill/>
+        </p:spPr>
+        <p:txBody>
+          <a:bodyPr wrap="square" lIns="0" rIns="0" tIns="0" bIns="0">
+            <a:spAutoFit/>
+          </a:bodyPr>
+          <a:lstStyle/>
+          <a:p>
+            <a:pPr algn="r"/>
+            <a:r>
+              <a:rPr sz="1100" b="1">
+                <a:solidFill>
+                  <a:srgbClr val="475569"/>
+                </a:solidFill>
+                <a:latin typeface="Aptos"/>
+              </a:rPr>
+              <a:t>000681a0</a:t>
+            </a:r>
+          </a:p>
+        </p:txBody>
+      </p:sp>
+      <p:sp>
+        <p:nvSpPr>
+          <p:cNvPr id="4" name="TextBox 3"/>
+          <p:cNvSpPr txBox="1"/>
+          <p:nvPr/>
+        </p:nvSpPr>
+        <p:spPr>
+          <a:xfrm>
+            <a:off x="521207" y="749808"/>
+            <a:ext cx="10607040" cy="256032"/>
+          </a:xfrm>
+          <a:prstGeom prst="rect">
+            <a:avLst/>
+          </a:prstGeom>
+          <a:noFill/>
+        </p:spPr>
+        <p:txBody>
+          <a:bodyPr wrap="square" lIns="0" rIns="0" tIns="0" bIns="0">
+            <a:spAutoFit/>
+          </a:bodyPr>
+          <a:lstStyle/>
+          <a:p>
+            <a:r>
+              <a:rPr sz="1500" b="0">
+                <a:solidFill>
+                  <a:srgbClr val="475569"/>
+                </a:solidFill>
+                <a:latin typeface="Aptos"/>
+              </a:rPr>
+              <a:t>p20 front-camera patch; final shift 1.74 m, right shift +1.57 m, mean shift 0.88 m.</a:t>
+            </a:r>
+          </a:p>
+        </p:txBody>
+      </p:sp>
+      <p:cxnSp>
+        <p:nvCxnSpPr>
+          <p:cNvPr id="5" name="Connector 4"/>
+          <p:cNvCxnSpPr/>
+          <p:nvPr/>
+        </p:nvCxnSpPr>
+        <p:spPr>
+          <a:xfrm>
+            <a:off x="502920" y="1124712"/>
+            <a:ext cx="11183112" cy="0"/>
+          </a:xfrm>
+          <a:prstGeom prst="line">
+            <a:avLst/>
+          </a:prstGeom>
+          <a:ln w="12700">
+            <a:solidFill>
+              <a:srgbClr val="E2E8F0"/>
+            </a:solidFill>
+          </a:ln>
+        </p:spPr>
+        <p:style>
+          <a:lnRef idx="2">
+            <a:schemeClr val="accent1"/>
+          </a:lnRef>
+          <a:fillRef idx="0">
+            <a:schemeClr val="accent1"/>
+          </a:fillRef>
+          <a:effectRef idx="1">
+            <a:schemeClr val="accent1"/>
+          </a:effectRef>
+          <a:fontRef idx="minor">
+            <a:schemeClr val="tx1"/>
+          </a:fontRef>
+        </p:style>
+      </p:cxnSp>
+      <p:pic>
+        <p:nvPicPr>
+          <p:cNvPr id="6" name="Picture 5" descr="000681a0_inputs.jpg"/>
+          <p:cNvPicPr>
+            <a:picLocks noChangeAspect="1"/>
+          </p:cNvPicPr>
+          <p:nvPr/>
+        </p:nvPicPr>
+        <p:blipFill>
+          <a:blip r:embed="rId2"/>
+          <a:stretch>
+            <a:fillRect/>
+          </a:stretch>
+        </p:blipFill>
+        <p:spPr>
+          <a:xfrm>
+            <a:off x="502920" y="1353312"/>
+            <a:ext cx="6812280" cy="2162794"/>
+          </a:xfrm>
+          <a:prstGeom prst="rect">
+            <a:avLst/>
+          </a:prstGeom>
+        </p:spPr>
+      </p:pic>
+      <p:pic>
+        <p:nvPicPr>
+          <p:cNvPr id="7" name="Picture 6" descr="000681a0_traj_overlay.png"/>
+          <p:cNvPicPr>
+            <a:picLocks noChangeAspect="1"/>
+          </p:cNvPicPr>
+          <p:nvPr/>
+        </p:nvPicPr>
+        <p:blipFill>
+          <a:blip r:embed="rId3"/>
+          <a:stretch>
+            <a:fillRect/>
+          </a:stretch>
+        </p:blipFill>
+        <p:spPr>
+          <a:xfrm>
+            <a:off x="7635240" y="1234440"/>
+            <a:ext cx="3745149" cy="4800600"/>
+          </a:xfrm>
+          <a:prstGeom prst="rect">
+            <a:avLst/>
+          </a:prstGeom>
+        </p:spPr>
+      </p:pic>
+      <p:sp>
+        <p:nvSpPr>
+          <p:cNvPr id="8" name="TextBox 7"/>
+          <p:cNvSpPr txBox="1"/>
+          <p:nvPr/>
+        </p:nvSpPr>
+        <p:spPr>
+          <a:xfrm>
+            <a:off x="502920" y="6199632"/>
+            <a:ext cx="6812280" cy="201168"/>
+          </a:xfrm>
+          <a:prstGeom prst="rect">
+            <a:avLst/>
+          </a:prstGeom>
+          <a:noFill/>
+        </p:spPr>
+        <p:txBody>
+          <a:bodyPr wrap="square" lIns="0" rIns="0" tIns="0" bIns="0">
+            <a:spAutoFit/>
+          </a:bodyPr>
+          <a:lstStyle/>
+          <a:p>
+            <a:pPr algn="ctr"/>
+            <a:r>
+              <a:rPr sz="1300" b="0">
+                <a:solidFill>
+                  <a:srgbClr val="475569"/>
+                </a:solidFill>
+                <a:latin typeface="Aptos"/>
+              </a:rPr>
+              <a:t>Clean front input  |  Patched front input</a:t>
+            </a:r>
+          </a:p>
+        </p:txBody>
+      </p:sp>
+      <p:sp>
+        <p:nvSpPr>
+          <p:cNvPr id="9" name="TextBox 8"/>
+          <p:cNvSpPr txBox="1"/>
+          <p:nvPr/>
+        </p:nvSpPr>
+        <p:spPr>
+          <a:xfrm>
+            <a:off x="7635240" y="6199632"/>
+            <a:ext cx="3840480" cy="201168"/>
+          </a:xfrm>
+          <a:prstGeom prst="rect">
+            <a:avLst/>
+          </a:prstGeom>
+          <a:noFill/>
+        </p:spPr>
+        <p:txBody>
+          <a:bodyPr wrap="square" lIns="0" rIns="0" tIns="0" bIns="0">
+            <a:spAutoFit/>
+          </a:bodyPr>
+          <a:lstStyle/>
+          <a:p>
+            <a:pPr algn="ctr"/>
+            <a:r>
+              <a:rPr sz="1300" b="0">
+                <a:solidFill>
+                  <a:srgbClr val="475569"/>
+                </a:solidFill>
+                <a:latin typeface="Aptos"/>
+              </a:rPr>
+              <a:t>GT / clean prediction / attacked prediction</a:t>
+            </a:r>
+          </a:p>
+        </p:txBody>
+      </p:sp>
+      <p:sp>
+        <p:nvSpPr>
+          <p:cNvPr id="10" name="TextBox 9"/>
+          <p:cNvSpPr txBox="1"/>
+          <p:nvPr/>
+        </p:nvSpPr>
+        <p:spPr>
+          <a:xfrm>
+            <a:off x="502920" y="6519672"/>
+            <a:ext cx="11155680" cy="201168"/>
+          </a:xfrm>
+          <a:prstGeom prst="rect">
+            <a:avLst/>
+          </a:prstGeom>
+          <a:noFill/>
+        </p:spPr>
+        <p:txBody>
+          <a:bodyPr wrap="square" lIns="0" rIns="0" tIns="0" bIns="0">
+            <a:spAutoFit/>
+          </a:bodyPr>
+          <a:lstStyle/>
+          <a:p>
+            <a:pPr algn="ctr"/>
+            <a:r>
+              <a:rPr sz="1400" b="1">
+                <a:solidFill>
+                  <a:srgbClr val="0F172A"/>
+                </a:solidFill>
+                <a:latin typeface="Aptos"/>
+              </a:rPr>
+              <a:t>Selected position = road_left; final shift 1.74 m, right shift +1.57 m.</a:t>
+            </a:r>
+          </a:p>
+        </p:txBody>
+      </p:sp>
+    </p:spTree>
+  </p:cSld>
+  <p:clrMapOvr>
+    <a:masterClrMapping/>
+  </p:clrMapOvr>
+</p:sld>
+</file>
+
+<file path=ppt/slides/slide5.xml><?xml version="1.0" encoding="utf-8"?>
+<p:sld xmlns:a="http://schemas.openxmlformats.org/drawingml/2006/main" xmlns:p="http://schemas.openxmlformats.org/presentationml/2006/main" xmlns:r="http://schemas.openxmlformats.org/officeDocument/2006/relationships">
+  <p:cSld>
+    <p:bg>
+      <p:bgPr>
+        <a:solidFill>
+          <a:srgbClr val="FFFFFF"/>
+        </a:solidFill>
+        <a:effectLst/>
+      </p:bgPr>
+    </p:bg>
+    <p:spTree>
+      <p:nvGrpSpPr>
+        <p:cNvPr id="1" name=""/>
+        <p:cNvGrpSpPr/>
+        <p:nvPr/>
+      </p:nvGrpSpPr>
+      <p:grpSpPr/>
+      <p:sp>
+        <p:nvSpPr>
+          <p:cNvPr id="2" name="TextBox 1"/>
+          <p:cNvSpPr txBox="1"/>
+          <p:nvPr/>
+        </p:nvSpPr>
+        <p:spPr>
+          <a:xfrm>
+            <a:off x="502920" y="320040"/>
+            <a:ext cx="8961120" cy="384048"/>
+          </a:xfrm>
+          <a:prstGeom prst="rect">
+            <a:avLst/>
+          </a:prstGeom>
+          <a:noFill/>
+        </p:spPr>
+        <p:txBody>
+          <a:bodyPr wrap="square" lIns="0" rIns="0" tIns="0" bIns="0">
+            <a:spAutoFit/>
+          </a:bodyPr>
+          <a:lstStyle/>
+          <a:p>
+            <a:r>
+              <a:rPr sz="2800" b="1">
+                <a:solidFill>
+                  <a:srgbClr val="0F172A"/>
+                </a:solidFill>
+                <a:latin typeface="Aptos"/>
+              </a:rPr>
+              <a:t>Case 5: AutoVLA black-box patch sample</a:t>
+            </a:r>
+          </a:p>
+        </p:txBody>
+      </p:sp>
+      <p:sp>
+        <p:nvSpPr>
+          <p:cNvPr id="3" name="TextBox 2"/>
+          <p:cNvSpPr txBox="1"/>
+          <p:nvPr/>
+        </p:nvSpPr>
+        <p:spPr>
+          <a:xfrm>
+            <a:off x="10607040" y="384048"/>
+            <a:ext cx="1051560" cy="201168"/>
+          </a:xfrm>
+          <a:prstGeom prst="rect">
+            <a:avLst/>
+          </a:prstGeom>
+          <a:noFill/>
+        </p:spPr>
+        <p:txBody>
+          <a:bodyPr wrap="square" lIns="0" rIns="0" tIns="0" bIns="0">
+            <a:spAutoFit/>
+          </a:bodyPr>
+          <a:lstStyle/>
+          <a:p>
+            <a:pPr algn="r"/>
+            <a:r>
+              <a:rPr sz="1100" b="1">
+                <a:solidFill>
+                  <a:srgbClr val="475569"/>
+                </a:solidFill>
+                <a:latin typeface="Aptos"/>
+              </a:rPr>
+              <a:t>012f334e</a:t>
+            </a:r>
+          </a:p>
+        </p:txBody>
+      </p:sp>
+      <p:sp>
+        <p:nvSpPr>
+          <p:cNvPr id="4" name="TextBox 3"/>
+          <p:cNvSpPr txBox="1"/>
+          <p:nvPr/>
+        </p:nvSpPr>
+        <p:spPr>
+          <a:xfrm>
+            <a:off x="521207" y="749808"/>
+            <a:ext cx="10607040" cy="256032"/>
+          </a:xfrm>
+          <a:prstGeom prst="rect">
+            <a:avLst/>
+          </a:prstGeom>
+          <a:noFill/>
+        </p:spPr>
+        <p:txBody>
+          <a:bodyPr wrap="square" lIns="0" rIns="0" tIns="0" bIns="0">
+            <a:spAutoFit/>
+          </a:bodyPr>
+          <a:lstStyle/>
+          <a:p>
+            <a:r>
+              <a:rPr sz="1500" b="0">
+                <a:solidFill>
+                  <a:srgbClr val="475569"/>
+                </a:solidFill>
+                <a:latin typeface="Aptos"/>
+              </a:rPr>
+              <a:t>p20 front-camera patch; final shift 0.00 m, right shift -0.00 m, mean shift 0.00 m.</a:t>
+            </a:r>
+          </a:p>
+        </p:txBody>
+      </p:sp>
+      <p:cxnSp>
+        <p:nvCxnSpPr>
+          <p:cNvPr id="5" name="Connector 4"/>
+          <p:cNvCxnSpPr/>
+          <p:nvPr/>
+        </p:nvCxnSpPr>
+        <p:spPr>
+          <a:xfrm>
+            <a:off x="502920" y="1124712"/>
+            <a:ext cx="11183112" cy="0"/>
+          </a:xfrm>
+          <a:prstGeom prst="line">
+            <a:avLst/>
+          </a:prstGeom>
+          <a:ln w="12700">
+            <a:solidFill>
+              <a:srgbClr val="E2E8F0"/>
+            </a:solidFill>
+          </a:ln>
+        </p:spPr>
+        <p:style>
+          <a:lnRef idx="2">
+            <a:schemeClr val="accent1"/>
+          </a:lnRef>
+          <a:fillRef idx="0">
+            <a:schemeClr val="accent1"/>
+          </a:fillRef>
+          <a:effectRef idx="1">
+            <a:schemeClr val="accent1"/>
+          </a:effectRef>
+          <a:fontRef idx="minor">
+            <a:schemeClr val="tx1"/>
+          </a:fontRef>
+        </p:style>
+      </p:cxnSp>
+      <p:pic>
+        <p:nvPicPr>
+          <p:cNvPr id="6" name="Picture 5" descr="012f334e_inputs.jpg"/>
+          <p:cNvPicPr>
+            <a:picLocks noChangeAspect="1"/>
+          </p:cNvPicPr>
+          <p:nvPr/>
+        </p:nvPicPr>
+        <p:blipFill>
+          <a:blip r:embed="rId2"/>
+          <a:stretch>
+            <a:fillRect/>
+          </a:stretch>
+        </p:blipFill>
+        <p:spPr>
+          <a:xfrm>
+            <a:off x="502920" y="1353312"/>
+            <a:ext cx="6812280" cy="2162794"/>
+          </a:xfrm>
+          <a:prstGeom prst="rect">
+            <a:avLst/>
+          </a:prstGeom>
+        </p:spPr>
+      </p:pic>
+      <p:pic>
+        <p:nvPicPr>
+          <p:cNvPr id="7" name="Picture 6" descr="012f334e_traj_overlay.png"/>
+          <p:cNvPicPr>
+            <a:picLocks noChangeAspect="1"/>
+          </p:cNvPicPr>
+          <p:nvPr/>
+        </p:nvPicPr>
+        <p:blipFill>
+          <a:blip r:embed="rId3"/>
+          <a:stretch>
+            <a:fillRect/>
+          </a:stretch>
+        </p:blipFill>
+        <p:spPr>
+          <a:xfrm>
+            <a:off x="7635240" y="1234440"/>
+            <a:ext cx="3745149" cy="4800600"/>
+          </a:xfrm>
+          <a:prstGeom prst="rect">
+            <a:avLst/>
+          </a:prstGeom>
+        </p:spPr>
+      </p:pic>
+      <p:sp>
+        <p:nvSpPr>
+          <p:cNvPr id="8" name="TextBox 7"/>
+          <p:cNvSpPr txBox="1"/>
+          <p:nvPr/>
+        </p:nvSpPr>
+        <p:spPr>
+          <a:xfrm>
+            <a:off x="502920" y="6199632"/>
+            <a:ext cx="6812280" cy="201168"/>
+          </a:xfrm>
+          <a:prstGeom prst="rect">
+            <a:avLst/>
+          </a:prstGeom>
+          <a:noFill/>
+        </p:spPr>
+        <p:txBody>
+          <a:bodyPr wrap="square" lIns="0" rIns="0" tIns="0" bIns="0">
+            <a:spAutoFit/>
+          </a:bodyPr>
+          <a:lstStyle/>
+          <a:p>
+            <a:pPr algn="ctr"/>
+            <a:r>
+              <a:rPr sz="1300" b="0">
+                <a:solidFill>
+                  <a:srgbClr val="475569"/>
+                </a:solidFill>
+                <a:latin typeface="Aptos"/>
+              </a:rPr>
+              <a:t>Clean front input  |  Patched front input</a:t>
+            </a:r>
+          </a:p>
+        </p:txBody>
+      </p:sp>
+      <p:sp>
+        <p:nvSpPr>
+          <p:cNvPr id="9" name="TextBox 8"/>
+          <p:cNvSpPr txBox="1"/>
+          <p:nvPr/>
+        </p:nvSpPr>
+        <p:spPr>
+          <a:xfrm>
+            <a:off x="7635240" y="6199632"/>
+            <a:ext cx="3840480" cy="201168"/>
+          </a:xfrm>
+          <a:prstGeom prst="rect">
+            <a:avLst/>
+          </a:prstGeom>
+          <a:noFill/>
+        </p:spPr>
+        <p:txBody>
+          <a:bodyPr wrap="square" lIns="0" rIns="0" tIns="0" bIns="0">
+            <a:spAutoFit/>
+          </a:bodyPr>
+          <a:lstStyle/>
+          <a:p>
+            <a:pPr algn="ctr"/>
+            <a:r>
+              <a:rPr sz="1300" b="0">
+                <a:solidFill>
+                  <a:srgbClr val="475569"/>
+                </a:solidFill>
+                <a:latin typeface="Aptos"/>
+              </a:rPr>
+              <a:t>GT / clean prediction / attacked prediction</a:t>
+            </a:r>
+          </a:p>
+        </p:txBody>
+      </p:sp>
+      <p:sp>
+        <p:nvSpPr>
+          <p:cNvPr id="10" name="TextBox 9"/>
+          <p:cNvSpPr txBox="1"/>
+          <p:nvPr/>
+        </p:nvSpPr>
+        <p:spPr>
+          <a:xfrm>
+            <a:off x="502920" y="6519672"/>
+            <a:ext cx="11155680" cy="201168"/>
+          </a:xfrm>
+          <a:prstGeom prst="rect">
+            <a:avLst/>
+          </a:prstGeom>
+          <a:noFill/>
+        </p:spPr>
+        <p:txBody>
+          <a:bodyPr wrap="square" lIns="0" rIns="0" tIns="0" bIns="0">
+            <a:spAutoFit/>
+          </a:bodyPr>
+          <a:lstStyle/>
+          <a:p>
+            <a:pPr algn="ctr"/>
+            <a:r>
+              <a:rPr sz="1400" b="1">
+                <a:solidFill>
+                  <a:srgbClr val="0F172A"/>
+                </a:solidFill>
+                <a:latin typeface="Aptos"/>
+              </a:rPr>
+              <a:t>No decoded trajectory change in this sample; selected position = road_left.</a:t>
             </a:r>
           </a:p>
         </p:txBody>

</xml_diff>